<commit_message>
Auto backup 12/10/2026 12:00:04,00
</commit_message>
<xml_diff>
--- a/CPU_Lite/CPU_Lite_PPT.pptx
+++ b/CPU_Lite/CPU_Lite_PPT.pptx
@@ -1,15 +1,19 @@
 
 <file path=ppt/presentation.xml><?xml version="1.0" encoding="utf-8"?>
-<p:presentation xmlns:a="http://schemas.openxmlformats.org/drawingml/2006/main" xmlns:r="http://schemas.openxmlformats.org/officeDocument/2006/relationships" xmlns:p="http://schemas.openxmlformats.org/presentationml/2006/main" saveSubsetFonts="1">
+<p:presentation xmlns:a="http://schemas.openxmlformats.org/drawingml/2006/main" xmlns:r="http://schemas.openxmlformats.org/officeDocument/2006/relationships" xmlns:p="http://schemas.openxmlformats.org/presentationml/2006/main" showSpecialPlsOnTitleSld="0" saveSubsetFonts="1">
   <p:sldMasterIdLst>
     <p:sldMasterId id="2147483648" r:id="rId1"/>
   </p:sldMasterIdLst>
+  <p:notesMasterIdLst>
+    <p:notesMasterId r:id="rId8"/>
+  </p:notesMasterIdLst>
   <p:sldIdLst>
     <p:sldId id="256" r:id="rId2"/>
     <p:sldId id="257" r:id="rId3"/>
     <p:sldId id="259" r:id="rId4"/>
-    <p:sldId id="258" r:id="rId5"/>
-    <p:sldId id="260" r:id="rId6"/>
+    <p:sldId id="261" r:id="rId5"/>
+    <p:sldId id="258" r:id="rId6"/>
+    <p:sldId id="260" r:id="rId7"/>
   </p:sldIdLst>
   <p:sldSz cx="12192000" cy="6858000"/>
   <p:notesSz cx="6858000" cy="9144000"/>
@@ -116,6 +120,356 @@
 </p:presentation>
 </file>
 
+<file path=ppt/notesMasters/notesMaster1.xml><?xml version="1.0" encoding="utf-8"?>
+<p:notesMaster xmlns:a="http://schemas.openxmlformats.org/drawingml/2006/main" xmlns:r="http://schemas.openxmlformats.org/officeDocument/2006/relationships" xmlns:p="http://schemas.openxmlformats.org/presentationml/2006/main">
+  <p:cSld>
+    <p:bg>
+      <p:bgRef idx="1001">
+        <a:schemeClr val="bg1"/>
+      </p:bgRef>
+    </p:bg>
+    <p:spTree>
+      <p:nvGrpSpPr>
+        <p:cNvPr id="1" name=""/>
+        <p:cNvGrpSpPr/>
+        <p:nvPr/>
+      </p:nvGrpSpPr>
+      <p:grpSpPr>
+        <a:xfrm>
+          <a:off x="0" y="0"/>
+          <a:ext cx="0" cy="0"/>
+          <a:chOff x="0" y="0"/>
+          <a:chExt cx="0" cy="0"/>
+        </a:xfrm>
+      </p:grpSpPr>
+      <p:sp>
+        <p:nvSpPr>
+          <p:cNvPr id="2" name="Header Placeholder 1"/>
+          <p:cNvSpPr>
+            <a:spLocks noGrp="1"/>
+          </p:cNvSpPr>
+          <p:nvPr>
+            <p:ph type="hdr" sz="quarter"/>
+          </p:nvPr>
+        </p:nvSpPr>
+        <p:spPr>
+          <a:xfrm>
+            <a:off x="0" y="0"/>
+            <a:ext cx="2971800" cy="458788"/>
+          </a:xfrm>
+          <a:prstGeom prst="rect">
+            <a:avLst/>
+          </a:prstGeom>
+        </p:spPr>
+        <p:txBody>
+          <a:bodyPr vert="horz" lIns="91440" tIns="45720" rIns="91440" bIns="45720" rtlCol="0"/>
+          <a:lstStyle>
+            <a:lvl1pPr algn="l">
+              <a:defRPr sz="1200"/>
+            </a:lvl1pPr>
+          </a:lstStyle>
+          <a:p>
+            <a:endParaRPr lang="en-DE"/>
+          </a:p>
+        </p:txBody>
+      </p:sp>
+      <p:sp>
+        <p:nvSpPr>
+          <p:cNvPr id="3" name="Date Placeholder 2"/>
+          <p:cNvSpPr>
+            <a:spLocks noGrp="1"/>
+          </p:cNvSpPr>
+          <p:nvPr>
+            <p:ph type="dt" idx="1"/>
+          </p:nvPr>
+        </p:nvSpPr>
+        <p:spPr>
+          <a:xfrm>
+            <a:off x="3884613" y="0"/>
+            <a:ext cx="2971800" cy="458788"/>
+          </a:xfrm>
+          <a:prstGeom prst="rect">
+            <a:avLst/>
+          </a:prstGeom>
+        </p:spPr>
+        <p:txBody>
+          <a:bodyPr vert="horz" lIns="91440" tIns="45720" rIns="91440" bIns="45720" rtlCol="0"/>
+          <a:lstStyle>
+            <a:lvl1pPr algn="r">
+              <a:defRPr sz="1200"/>
+            </a:lvl1pPr>
+          </a:lstStyle>
+          <a:p>
+            <a:fld id="{40121602-EAA8-4F1C-9FF7-6AF9819ED24A}" type="datetimeFigureOut">
+              <a:rPr lang="en-DE" smtClean="0"/>
+              <a:t>11/10/2026</a:t>
+            </a:fld>
+            <a:endParaRPr lang="en-DE"/>
+          </a:p>
+        </p:txBody>
+      </p:sp>
+      <p:sp>
+        <p:nvSpPr>
+          <p:cNvPr id="4" name="Slide Image Placeholder 3"/>
+          <p:cNvSpPr>
+            <a:spLocks noGrp="1" noRot="1" noChangeAspect="1"/>
+          </p:cNvSpPr>
+          <p:nvPr>
+            <p:ph type="sldImg" idx="2"/>
+          </p:nvPr>
+        </p:nvSpPr>
+        <p:spPr>
+          <a:xfrm>
+            <a:off x="685800" y="1143000"/>
+            <a:ext cx="5486400" cy="3086100"/>
+          </a:xfrm>
+          <a:prstGeom prst="rect">
+            <a:avLst/>
+          </a:prstGeom>
+          <a:noFill/>
+          <a:ln w="12700">
+            <a:solidFill>
+              <a:prstClr val="black"/>
+            </a:solidFill>
+          </a:ln>
+        </p:spPr>
+        <p:txBody>
+          <a:bodyPr vert="horz" lIns="91440" tIns="45720" rIns="91440" bIns="45720" rtlCol="0" anchor="ctr"/>
+          <a:lstStyle/>
+          <a:p>
+            <a:endParaRPr lang="en-DE"/>
+          </a:p>
+        </p:txBody>
+      </p:sp>
+      <p:sp>
+        <p:nvSpPr>
+          <p:cNvPr id="5" name="Notes Placeholder 4"/>
+          <p:cNvSpPr>
+            <a:spLocks noGrp="1"/>
+          </p:cNvSpPr>
+          <p:nvPr>
+            <p:ph type="body" sz="quarter" idx="3"/>
+          </p:nvPr>
+        </p:nvSpPr>
+        <p:spPr>
+          <a:xfrm>
+            <a:off x="685800" y="4400550"/>
+            <a:ext cx="5486400" cy="3600450"/>
+          </a:xfrm>
+          <a:prstGeom prst="rect">
+            <a:avLst/>
+          </a:prstGeom>
+        </p:spPr>
+        <p:txBody>
+          <a:bodyPr vert="horz" lIns="91440" tIns="45720" rIns="91440" bIns="45720" rtlCol="0"/>
+          <a:lstStyle/>
+          <a:p>
+            <a:pPr lvl="0"/>
+            <a:r>
+              <a:rPr lang="en-US"/>
+              <a:t>Click to edit Master text styles</a:t>
+            </a:r>
+          </a:p>
+          <a:p>
+            <a:pPr lvl="1"/>
+            <a:r>
+              <a:rPr lang="en-US"/>
+              <a:t>Second level</a:t>
+            </a:r>
+          </a:p>
+          <a:p>
+            <a:pPr lvl="2"/>
+            <a:r>
+              <a:rPr lang="en-US"/>
+              <a:t>Third level</a:t>
+            </a:r>
+          </a:p>
+          <a:p>
+            <a:pPr lvl="3"/>
+            <a:r>
+              <a:rPr lang="en-US"/>
+              <a:t>Fourth level</a:t>
+            </a:r>
+          </a:p>
+          <a:p>
+            <a:pPr lvl="4"/>
+            <a:r>
+              <a:rPr lang="en-US"/>
+              <a:t>Fifth level</a:t>
+            </a:r>
+            <a:endParaRPr lang="en-DE"/>
+          </a:p>
+        </p:txBody>
+      </p:sp>
+      <p:sp>
+        <p:nvSpPr>
+          <p:cNvPr id="6" name="Footer Placeholder 5"/>
+          <p:cNvSpPr>
+            <a:spLocks noGrp="1"/>
+          </p:cNvSpPr>
+          <p:nvPr>
+            <p:ph type="ftr" sz="quarter" idx="4"/>
+          </p:nvPr>
+        </p:nvSpPr>
+        <p:spPr>
+          <a:xfrm>
+            <a:off x="0" y="8685213"/>
+            <a:ext cx="2971800" cy="458787"/>
+          </a:xfrm>
+          <a:prstGeom prst="rect">
+            <a:avLst/>
+          </a:prstGeom>
+        </p:spPr>
+        <p:txBody>
+          <a:bodyPr vert="horz" lIns="91440" tIns="45720" rIns="91440" bIns="45720" rtlCol="0" anchor="b"/>
+          <a:lstStyle>
+            <a:lvl1pPr algn="l">
+              <a:defRPr sz="1200"/>
+            </a:lvl1pPr>
+          </a:lstStyle>
+          <a:p>
+            <a:endParaRPr lang="en-DE"/>
+          </a:p>
+        </p:txBody>
+      </p:sp>
+      <p:sp>
+        <p:nvSpPr>
+          <p:cNvPr id="7" name="Slide Number Placeholder 6"/>
+          <p:cNvSpPr>
+            <a:spLocks noGrp="1"/>
+          </p:cNvSpPr>
+          <p:nvPr>
+            <p:ph type="sldNum" sz="quarter" idx="5"/>
+          </p:nvPr>
+        </p:nvSpPr>
+        <p:spPr>
+          <a:xfrm>
+            <a:off x="3884613" y="8685213"/>
+            <a:ext cx="2971800" cy="458787"/>
+          </a:xfrm>
+          <a:prstGeom prst="rect">
+            <a:avLst/>
+          </a:prstGeom>
+        </p:spPr>
+        <p:txBody>
+          <a:bodyPr vert="horz" lIns="91440" tIns="45720" rIns="91440" bIns="45720" rtlCol="0" anchor="b"/>
+          <a:lstStyle>
+            <a:lvl1pPr algn="r">
+              <a:defRPr sz="1200"/>
+            </a:lvl1pPr>
+          </a:lstStyle>
+          <a:p>
+            <a:fld id="{A1E0FEC7-23AA-4FE2-9886-697A4B73E9C3}" type="slidenum">
+              <a:rPr lang="en-DE" smtClean="0"/>
+              <a:t>‹#›</a:t>
+            </a:fld>
+            <a:endParaRPr lang="en-DE"/>
+          </a:p>
+        </p:txBody>
+      </p:sp>
+    </p:spTree>
+    <p:extLst>
+      <p:ext uri="{BB962C8B-B14F-4D97-AF65-F5344CB8AC3E}">
+        <p14:creationId xmlns:p14="http://schemas.microsoft.com/office/powerpoint/2010/main" val="1382562141"/>
+      </p:ext>
+    </p:extLst>
+  </p:cSld>
+  <p:clrMap bg1="lt1" tx1="dk1" bg2="lt2" tx2="dk2" accent1="accent1" accent2="accent2" accent3="accent3" accent4="accent4" accent5="accent5" accent6="accent6" hlink="hlink" folHlink="folHlink"/>
+  <p:notesStyle>
+    <a:lvl1pPr marL="0" algn="l" defTabSz="914400" rtl="0" eaLnBrk="1" latinLnBrk="0" hangingPunct="1">
+      <a:defRPr sz="1200" kern="1200">
+        <a:solidFill>
+          <a:schemeClr val="tx1"/>
+        </a:solidFill>
+        <a:latin typeface="+mn-lt"/>
+        <a:ea typeface="+mn-ea"/>
+        <a:cs typeface="+mn-cs"/>
+      </a:defRPr>
+    </a:lvl1pPr>
+    <a:lvl2pPr marL="457200" algn="l" defTabSz="914400" rtl="0" eaLnBrk="1" latinLnBrk="0" hangingPunct="1">
+      <a:defRPr sz="1200" kern="1200">
+        <a:solidFill>
+          <a:schemeClr val="tx1"/>
+        </a:solidFill>
+        <a:latin typeface="+mn-lt"/>
+        <a:ea typeface="+mn-ea"/>
+        <a:cs typeface="+mn-cs"/>
+      </a:defRPr>
+    </a:lvl2pPr>
+    <a:lvl3pPr marL="914400" algn="l" defTabSz="914400" rtl="0" eaLnBrk="1" latinLnBrk="0" hangingPunct="1">
+      <a:defRPr sz="1200" kern="1200">
+        <a:solidFill>
+          <a:schemeClr val="tx1"/>
+        </a:solidFill>
+        <a:latin typeface="+mn-lt"/>
+        <a:ea typeface="+mn-ea"/>
+        <a:cs typeface="+mn-cs"/>
+      </a:defRPr>
+    </a:lvl3pPr>
+    <a:lvl4pPr marL="1371600" algn="l" defTabSz="914400" rtl="0" eaLnBrk="1" latinLnBrk="0" hangingPunct="1">
+      <a:defRPr sz="1200" kern="1200">
+        <a:solidFill>
+          <a:schemeClr val="tx1"/>
+        </a:solidFill>
+        <a:latin typeface="+mn-lt"/>
+        <a:ea typeface="+mn-ea"/>
+        <a:cs typeface="+mn-cs"/>
+      </a:defRPr>
+    </a:lvl4pPr>
+    <a:lvl5pPr marL="1828800" algn="l" defTabSz="914400" rtl="0" eaLnBrk="1" latinLnBrk="0" hangingPunct="1">
+      <a:defRPr sz="1200" kern="1200">
+        <a:solidFill>
+          <a:schemeClr val="tx1"/>
+        </a:solidFill>
+        <a:latin typeface="+mn-lt"/>
+        <a:ea typeface="+mn-ea"/>
+        <a:cs typeface="+mn-cs"/>
+      </a:defRPr>
+    </a:lvl5pPr>
+    <a:lvl6pPr marL="2286000" algn="l" defTabSz="914400" rtl="0" eaLnBrk="1" latinLnBrk="0" hangingPunct="1">
+      <a:defRPr sz="1200" kern="1200">
+        <a:solidFill>
+          <a:schemeClr val="tx1"/>
+        </a:solidFill>
+        <a:latin typeface="+mn-lt"/>
+        <a:ea typeface="+mn-ea"/>
+        <a:cs typeface="+mn-cs"/>
+      </a:defRPr>
+    </a:lvl6pPr>
+    <a:lvl7pPr marL="2743200" algn="l" defTabSz="914400" rtl="0" eaLnBrk="1" latinLnBrk="0" hangingPunct="1">
+      <a:defRPr sz="1200" kern="1200">
+        <a:solidFill>
+          <a:schemeClr val="tx1"/>
+        </a:solidFill>
+        <a:latin typeface="+mn-lt"/>
+        <a:ea typeface="+mn-ea"/>
+        <a:cs typeface="+mn-cs"/>
+      </a:defRPr>
+    </a:lvl7pPr>
+    <a:lvl8pPr marL="3200400" algn="l" defTabSz="914400" rtl="0" eaLnBrk="1" latinLnBrk="0" hangingPunct="1">
+      <a:defRPr sz="1200" kern="1200">
+        <a:solidFill>
+          <a:schemeClr val="tx1"/>
+        </a:solidFill>
+        <a:latin typeface="+mn-lt"/>
+        <a:ea typeface="+mn-ea"/>
+        <a:cs typeface="+mn-cs"/>
+      </a:defRPr>
+    </a:lvl8pPr>
+    <a:lvl9pPr marL="3657600" algn="l" defTabSz="914400" rtl="0" eaLnBrk="1" latinLnBrk="0" hangingPunct="1">
+      <a:defRPr sz="1200" kern="1200">
+        <a:solidFill>
+          <a:schemeClr val="tx1"/>
+        </a:solidFill>
+        <a:latin typeface="+mn-lt"/>
+        <a:ea typeface="+mn-ea"/>
+        <a:cs typeface="+mn-cs"/>
+      </a:defRPr>
+    </a:lvl9pPr>
+  </p:notesStyle>
+</p:notesMaster>
+</file>
+
 <file path=ppt/slideLayouts/slideLayout1.xml><?xml version="1.0" encoding="utf-8"?>
 <p:sldLayout xmlns:a="http://schemas.openxmlformats.org/drawingml/2006/main" xmlns:r="http://schemas.openxmlformats.org/officeDocument/2006/relationships" xmlns:p="http://schemas.openxmlformats.org/presentationml/2006/main" type="title" preserve="1">
   <p:cSld name="Title Slide">
@@ -263,9 +617,9 @@
           <a:bodyPr/>
           <a:lstStyle/>
           <a:p>
-            <a:fld id="{D869BF5C-421C-4526-8420-269AB2D37A68}" type="datetimeFigureOut">
+            <a:fld id="{8BF61571-DD67-4DB9-828E-8224F49D10F7}" type="datetime8">
               <a:rPr lang="en-DE" smtClean="0"/>
-              <a:t>10/10/2026</a:t>
+              <a:t>11/10/2026 10:28</a:t>
             </a:fld>
             <a:endParaRPr lang="en-DE"/>
           </a:p>
@@ -463,9 +817,9 @@
           <a:bodyPr/>
           <a:lstStyle/>
           <a:p>
-            <a:fld id="{D869BF5C-421C-4526-8420-269AB2D37A68}" type="datetimeFigureOut">
+            <a:fld id="{DE1D51F6-4284-4068-A837-7C1D9F8E0C33}" type="datetime8">
               <a:rPr lang="en-DE" smtClean="0"/>
-              <a:t>10/10/2026</a:t>
+              <a:t>11/10/2026 10:28</a:t>
             </a:fld>
             <a:endParaRPr lang="en-DE"/>
           </a:p>
@@ -673,9 +1027,9 @@
           <a:bodyPr/>
           <a:lstStyle/>
           <a:p>
-            <a:fld id="{D869BF5C-421C-4526-8420-269AB2D37A68}" type="datetimeFigureOut">
+            <a:fld id="{B84C5440-5D12-45B5-9174-2FE7550F8EDC}" type="datetime8">
               <a:rPr lang="en-DE" smtClean="0"/>
-              <a:t>10/10/2026</a:t>
+              <a:t>11/10/2026 10:28</a:t>
             </a:fld>
             <a:endParaRPr lang="en-DE"/>
           </a:p>
@@ -873,9 +1227,9 @@
           <a:bodyPr/>
           <a:lstStyle/>
           <a:p>
-            <a:fld id="{D869BF5C-421C-4526-8420-269AB2D37A68}" type="datetimeFigureOut">
+            <a:fld id="{BD762AD5-4B24-4ABD-947C-0B79DD411B70}" type="datetime8">
               <a:rPr lang="en-DE" smtClean="0"/>
-              <a:t>10/10/2026</a:t>
+              <a:t>11/10/2026 10:28</a:t>
             </a:fld>
             <a:endParaRPr lang="en-DE"/>
           </a:p>
@@ -1149,9 +1503,9 @@
           <a:bodyPr/>
           <a:lstStyle/>
           <a:p>
-            <a:fld id="{D869BF5C-421C-4526-8420-269AB2D37A68}" type="datetimeFigureOut">
+            <a:fld id="{D700E591-0DD3-4063-9353-B7994991AA26}" type="datetime8">
               <a:rPr lang="en-DE" smtClean="0"/>
-              <a:t>10/10/2026</a:t>
+              <a:t>11/10/2026 10:28</a:t>
             </a:fld>
             <a:endParaRPr lang="en-DE"/>
           </a:p>
@@ -1417,9 +1771,9 @@
           <a:bodyPr/>
           <a:lstStyle/>
           <a:p>
-            <a:fld id="{D869BF5C-421C-4526-8420-269AB2D37A68}" type="datetimeFigureOut">
+            <a:fld id="{75E1A21E-E696-4D3A-AC14-818B200362B9}" type="datetime8">
               <a:rPr lang="en-DE" smtClean="0"/>
-              <a:t>10/10/2026</a:t>
+              <a:t>11/10/2026 10:28</a:t>
             </a:fld>
             <a:endParaRPr lang="en-DE"/>
           </a:p>
@@ -1832,9 +2186,9 @@
           <a:bodyPr/>
           <a:lstStyle/>
           <a:p>
-            <a:fld id="{D869BF5C-421C-4526-8420-269AB2D37A68}" type="datetimeFigureOut">
+            <a:fld id="{2270BFA8-8A0B-429B-8866-F0F19839FE2A}" type="datetime8">
               <a:rPr lang="en-DE" smtClean="0"/>
-              <a:t>10/10/2026</a:t>
+              <a:t>11/10/2026 10:28</a:t>
             </a:fld>
             <a:endParaRPr lang="en-DE"/>
           </a:p>
@@ -1974,9 +2328,9 @@
           <a:bodyPr/>
           <a:lstStyle/>
           <a:p>
-            <a:fld id="{D869BF5C-421C-4526-8420-269AB2D37A68}" type="datetimeFigureOut">
+            <a:fld id="{A6BE2B78-6173-44EE-AA8A-9FDFCD4A202E}" type="datetime8">
               <a:rPr lang="en-DE" smtClean="0"/>
-              <a:t>10/10/2026</a:t>
+              <a:t>11/10/2026 10:28</a:t>
             </a:fld>
             <a:endParaRPr lang="en-DE"/>
           </a:p>
@@ -2087,9 +2441,9 @@
           <a:bodyPr/>
           <a:lstStyle/>
           <a:p>
-            <a:fld id="{D869BF5C-421C-4526-8420-269AB2D37A68}" type="datetimeFigureOut">
+            <a:fld id="{0CAC95DE-1BBF-4297-B01A-9D1D0DAB67F7}" type="datetime8">
               <a:rPr lang="en-DE" smtClean="0"/>
-              <a:t>10/10/2026</a:t>
+              <a:t>11/10/2026 10:28</a:t>
             </a:fld>
             <a:endParaRPr lang="en-DE"/>
           </a:p>
@@ -2400,9 +2754,9 @@
           <a:bodyPr/>
           <a:lstStyle/>
           <a:p>
-            <a:fld id="{D869BF5C-421C-4526-8420-269AB2D37A68}" type="datetimeFigureOut">
+            <a:fld id="{58BDAB5A-3AF1-455B-B52A-7F093A6F8B11}" type="datetime8">
               <a:rPr lang="en-DE" smtClean="0"/>
-              <a:t>10/10/2026</a:t>
+              <a:t>11/10/2026 10:28</a:t>
             </a:fld>
             <a:endParaRPr lang="en-DE"/>
           </a:p>
@@ -2689,9 +3043,9 @@
           <a:bodyPr/>
           <a:lstStyle/>
           <a:p>
-            <a:fld id="{D869BF5C-421C-4526-8420-269AB2D37A68}" type="datetimeFigureOut">
+            <a:fld id="{E2ED3544-4A9A-4482-8049-1F4A5A0FB2CC}" type="datetime8">
               <a:rPr lang="en-DE" smtClean="0"/>
-              <a:t>10/10/2026</a:t>
+              <a:t>11/10/2026 10:28</a:t>
             </a:fld>
             <a:endParaRPr lang="en-DE"/>
           </a:p>
@@ -2932,9 +3286,9 @@
             </a:lvl1pPr>
           </a:lstStyle>
           <a:p>
-            <a:fld id="{D869BF5C-421C-4526-8420-269AB2D37A68}" type="datetimeFigureOut">
+            <a:fld id="{F2BFB065-BC28-4C5F-8855-6FB69D25D066}" type="datetime8">
               <a:rPr lang="en-DE" smtClean="0"/>
-              <a:t>10/10/2026</a:t>
+              <a:t>11/10/2026 10:28</a:t>
             </a:fld>
             <a:endParaRPr lang="en-DE"/>
           </a:p>
@@ -3051,6 +3405,7 @@
     <p:sldLayoutId id="2147483658" r:id="rId10"/>
     <p:sldLayoutId id="2147483659" r:id="rId11"/>
   </p:sldLayoutIdLst>
+  <p:hf sldNum="0" hdr="0" ftr="0" dt="0"/>
   <p:txStyles>
     <p:titleStyle>
       <a:lvl1pPr algn="l" defTabSz="914400" rtl="0" eaLnBrk="1" latinLnBrk="0" hangingPunct="1">
@@ -3631,6 +3986,36 @@
           </a:prstGeom>
         </p:spPr>
       </p:pic>
+      <p:pic>
+        <p:nvPicPr>
+          <p:cNvPr id="3" name="Picture 2" descr="Leading Engineering &amp; Technology Services | Mirafra">
+            <a:extLst>
+              <a:ext uri="{FF2B5EF4-FFF2-40B4-BE49-F238E27FC236}">
+                <a16:creationId xmlns:a16="http://schemas.microsoft.com/office/drawing/2014/main" id="{A6330863-EDA7-B27F-B836-8E5C4AB0A4A6}"/>
+              </a:ext>
+            </a:extLst>
+          </p:cNvPr>
+          <p:cNvPicPr>
+            <a:picLocks noChangeAspect="1"/>
+          </p:cNvPicPr>
+          <p:nvPr/>
+        </p:nvPicPr>
+        <p:blipFill>
+          <a:blip r:embed="rId6"/>
+          <a:stretch>
+            <a:fillRect/>
+          </a:stretch>
+        </p:blipFill>
+        <p:spPr>
+          <a:xfrm>
+            <a:off x="10762406" y="365125"/>
+            <a:ext cx="1182788" cy="393277"/>
+          </a:xfrm>
+          <a:prstGeom prst="rect">
+            <a:avLst/>
+          </a:prstGeom>
+        </p:spPr>
+      </p:pic>
     </p:spTree>
     <p:extLst>
       <p:ext uri="{BB962C8B-B14F-4D97-AF65-F5344CB8AC3E}">
@@ -3839,6 +4224,36 @@
           </a:p>
         </p:txBody>
       </p:sp>
+      <p:pic>
+        <p:nvPicPr>
+          <p:cNvPr id="3" name="Picture 2" descr="Leading Engineering &amp; Technology Services | Mirafra">
+            <a:extLst>
+              <a:ext uri="{FF2B5EF4-FFF2-40B4-BE49-F238E27FC236}">
+                <a16:creationId xmlns:a16="http://schemas.microsoft.com/office/drawing/2014/main" id="{F0613DE6-8F75-4A7B-E887-DED473BE4844}"/>
+              </a:ext>
+            </a:extLst>
+          </p:cNvPr>
+          <p:cNvPicPr>
+            <a:picLocks noChangeAspect="1"/>
+          </p:cNvPicPr>
+          <p:nvPr/>
+        </p:nvPicPr>
+        <p:blipFill>
+          <a:blip r:embed="rId6"/>
+          <a:stretch>
+            <a:fillRect/>
+          </a:stretch>
+        </p:blipFill>
+        <p:spPr>
+          <a:xfrm>
+            <a:off x="9819509" y="176848"/>
+            <a:ext cx="2124469" cy="706386"/>
+          </a:xfrm>
+          <a:prstGeom prst="rect">
+            <a:avLst/>
+          </a:prstGeom>
+        </p:spPr>
+      </p:pic>
     </p:spTree>
     <p:extLst>
       <p:ext uri="{BB962C8B-B14F-4D97-AF65-F5344CB8AC3E}">
@@ -3853,6 +4268,401 @@
 </file>
 
 <file path=ppt/slides/slide4.xml><?xml version="1.0" encoding="utf-8"?>
+<p:sld xmlns:a="http://schemas.openxmlformats.org/drawingml/2006/main" xmlns:r="http://schemas.openxmlformats.org/officeDocument/2006/relationships" xmlns:p="http://schemas.openxmlformats.org/presentationml/2006/main">
+  <p:cSld>
+    <p:spTree>
+      <p:nvGrpSpPr>
+        <p:cNvPr id="1" name="">
+          <a:extLst>
+            <a:ext uri="{FF2B5EF4-FFF2-40B4-BE49-F238E27FC236}">
+              <a16:creationId xmlns:a16="http://schemas.microsoft.com/office/drawing/2014/main" id="{19CA0A4E-D05B-EA7C-5D7D-F7E7EDF66D1B}"/>
+            </a:ext>
+          </a:extLst>
+        </p:cNvPr>
+        <p:cNvGrpSpPr/>
+        <p:nvPr/>
+      </p:nvGrpSpPr>
+      <p:grpSpPr>
+        <a:xfrm>
+          <a:off x="0" y="0"/>
+          <a:ext cx="0" cy="0"/>
+          <a:chOff x="0" y="0"/>
+          <a:chExt cx="0" cy="0"/>
+        </a:xfrm>
+      </p:grpSpPr>
+      <p:pic>
+        <p:nvPicPr>
+          <p:cNvPr id="9" name="Content Placeholder 8">
+            <a:extLst>
+              <a:ext uri="{FF2B5EF4-FFF2-40B4-BE49-F238E27FC236}">
+                <a16:creationId xmlns:a16="http://schemas.microsoft.com/office/drawing/2014/main" id="{360AD9ED-011F-D3E7-4415-51B037DDB4E6}"/>
+              </a:ext>
+            </a:extLst>
+          </p:cNvPr>
+          <p:cNvPicPr>
+            <a:picLocks noGrp="1" noChangeAspect="1"/>
+          </p:cNvPicPr>
+          <p:nvPr>
+            <p:ph idx="1"/>
+          </p:nvPr>
+        </p:nvPicPr>
+        <p:blipFill>
+          <a:blip r:embed="rId2"/>
+          <a:srcRect l="4330"/>
+          <a:stretch>
+            <a:fillRect/>
+          </a:stretch>
+        </p:blipFill>
+        <p:spPr>
+          <a:xfrm>
+            <a:off x="-1" y="1258529"/>
+            <a:ext cx="12196438" cy="4667966"/>
+          </a:xfrm>
+          <a:prstGeom prst="rect">
+            <a:avLst/>
+          </a:prstGeom>
+        </p:spPr>
+      </p:pic>
+      <mc:AlternateContent xmlns:mc="http://schemas.openxmlformats.org/markup-compatibility/2006">
+        <mc:Choice xmlns:pslz="http://schemas.microsoft.com/office/powerpoint/2016/slidezoom" Requires="pslz">
+          <p:graphicFrame>
+            <p:nvGraphicFramePr>
+              <p:cNvPr id="11" name="Slide Zoom 10">
+                <a:extLst>
+                  <a:ext uri="{FF2B5EF4-FFF2-40B4-BE49-F238E27FC236}">
+                    <a16:creationId xmlns:a16="http://schemas.microsoft.com/office/drawing/2014/main" id="{E74E6645-C8C1-72BB-F45A-FEC7C532E483}"/>
+                  </a:ext>
+                </a:extLst>
+              </p:cNvPr>
+              <p:cNvGraphicFramePr>
+                <a:graphicFrameLocks noChangeAspect="1"/>
+              </p:cNvGraphicFramePr>
+              <p:nvPr/>
+            </p:nvGraphicFramePr>
+            <p:xfrm>
+              <a:off x="9057783" y="3134953"/>
+              <a:ext cx="716006" cy="402754"/>
+            </p:xfrm>
+            <a:graphic>
+              <a:graphicData uri="http://schemas.microsoft.com/office/powerpoint/2016/slidezoom">
+                <pslz:sldZm>
+                  <pslz:sldZmObj sldId="258" cId="15702998">
+                    <pslz:zmPr id="{719C769D-3CF8-4A89-894E-018796295D55}" returnToParent="0" transitionDur="1000">
+                      <p166:blipFill xmlns:p166="http://schemas.microsoft.com/office/powerpoint/2016/6/main">
+                        <a:blip r:embed="rId3"/>
+                        <a:stretch>
+                          <a:fillRect/>
+                        </a:stretch>
+                      </p166:blipFill>
+                      <p166:spPr xmlns:p166="http://schemas.microsoft.com/office/powerpoint/2016/6/main">
+                        <a:xfrm>
+                          <a:off x="0" y="0"/>
+                          <a:ext cx="716006" cy="402754"/>
+                        </a:xfrm>
+                        <a:prstGeom prst="rect">
+                          <a:avLst/>
+                        </a:prstGeom>
+                        <a:ln w="3175">
+                          <a:solidFill>
+                            <a:prstClr val="ltGray"/>
+                          </a:solidFill>
+                        </a:ln>
+                      </p166:spPr>
+                    </pslz:zmPr>
+                  </pslz:sldZmObj>
+                </pslz:sldZm>
+              </a:graphicData>
+            </a:graphic>
+          </p:graphicFrame>
+        </mc:Choice>
+        <mc:Fallback>
+          <p:pic>
+            <p:nvPicPr>
+              <p:cNvPr id="11" name="Slide Zoom 10">
+                <a:hlinkClick r:id="rId4" action="ppaction://hlinksldjump"/>
+                <a:extLst>
+                  <a:ext uri="{FF2B5EF4-FFF2-40B4-BE49-F238E27FC236}">
+                    <a16:creationId xmlns:a16="http://schemas.microsoft.com/office/drawing/2014/main" id="{E74E6645-C8C1-72BB-F45A-FEC7C532E483}"/>
+                  </a:ext>
+                </a:extLst>
+              </p:cNvPr>
+              <p:cNvPicPr>
+                <a:picLocks noGrp="1" noRot="1" noChangeAspect="1" noMove="1" noResize="1" noEditPoints="1" noAdjustHandles="1" noChangeArrowheads="1" noChangeShapeType="1"/>
+              </p:cNvPicPr>
+              <p:nvPr/>
+            </p:nvPicPr>
+            <p:blipFill>
+              <a:blip r:embed="rId3"/>
+              <a:stretch>
+                <a:fillRect/>
+              </a:stretch>
+            </p:blipFill>
+            <p:spPr>
+              <a:xfrm>
+                <a:off x="9057783" y="3134953"/>
+                <a:ext cx="716006" cy="402754"/>
+              </a:xfrm>
+              <a:prstGeom prst="rect">
+                <a:avLst/>
+              </a:prstGeom>
+              <a:ln w="3175">
+                <a:solidFill>
+                  <a:prstClr val="ltGray"/>
+                </a:solidFill>
+              </a:ln>
+            </p:spPr>
+          </p:pic>
+        </mc:Fallback>
+      </mc:AlternateContent>
+      <p:sp>
+        <p:nvSpPr>
+          <p:cNvPr id="7" name="Freeform: Shape 6">
+            <a:extLst>
+              <a:ext uri="{FF2B5EF4-FFF2-40B4-BE49-F238E27FC236}">
+                <a16:creationId xmlns:a16="http://schemas.microsoft.com/office/drawing/2014/main" id="{493E69A5-679C-F861-B428-21DDED247BF6}"/>
+              </a:ext>
+            </a:extLst>
+          </p:cNvPr>
+          <p:cNvSpPr/>
+          <p:nvPr/>
+        </p:nvSpPr>
+        <p:spPr>
+          <a:xfrm>
+            <a:off x="2261419" y="1258529"/>
+            <a:ext cx="9682559" cy="3431459"/>
+          </a:xfrm>
+          <a:custGeom>
+            <a:avLst/>
+            <a:gdLst>
+              <a:gd name="csX0" fmla="*/ 7973962 w 9682559"/>
+              <a:gd name="csY0" fmla="*/ 1676370 h 3431459"/>
+              <a:gd name="csX1" fmla="*/ 9682559 w 9682559"/>
+              <a:gd name="csY1" fmla="*/ 1676370 h 3431459"/>
+              <a:gd name="csX2" fmla="*/ 9682559 w 9682559"/>
+              <a:gd name="csY2" fmla="*/ 2763026 h 3431459"/>
+              <a:gd name="csX3" fmla="*/ 7973962 w 9682559"/>
+              <a:gd name="csY3" fmla="*/ 2763026 h 3431459"/>
+              <a:gd name="csX4" fmla="*/ 6312310 w 9682559"/>
+              <a:gd name="csY4" fmla="*/ 0 h 3431459"/>
+              <a:gd name="csX5" fmla="*/ 9682559 w 9682559"/>
+              <a:gd name="csY5" fmla="*/ 0 h 3431459"/>
+              <a:gd name="csX6" fmla="*/ 9682559 w 9682559"/>
+              <a:gd name="csY6" fmla="*/ 1676368 h 3431459"/>
+              <a:gd name="csX7" fmla="*/ 6312310 w 9682559"/>
+              <a:gd name="csY7" fmla="*/ 1676368 h 3431459"/>
+              <a:gd name="csX8" fmla="*/ 6312310 w 9682559"/>
+              <a:gd name="csY8" fmla="*/ 3431459 h 3431459"/>
+              <a:gd name="csX9" fmla="*/ 0 w 9682559"/>
+              <a:gd name="csY9" fmla="*/ 3431459 h 3431459"/>
+              <a:gd name="csX10" fmla="*/ 0 w 9682559"/>
+              <a:gd name="csY10" fmla="*/ 1 h 3431459"/>
+              <a:gd name="csX11" fmla="*/ 6312310 w 9682559"/>
+              <a:gd name="csY11" fmla="*/ 1 h 3431459"/>
+            </a:gdLst>
+            <a:ahLst/>
+            <a:cxnLst>
+              <a:cxn ang="0">
+                <a:pos x="csX0" y="csY0"/>
+              </a:cxn>
+              <a:cxn ang="0">
+                <a:pos x="csX1" y="csY1"/>
+              </a:cxn>
+              <a:cxn ang="0">
+                <a:pos x="csX2" y="csY2"/>
+              </a:cxn>
+              <a:cxn ang="0">
+                <a:pos x="csX3" y="csY3"/>
+              </a:cxn>
+              <a:cxn ang="0">
+                <a:pos x="csX4" y="csY4"/>
+              </a:cxn>
+              <a:cxn ang="0">
+                <a:pos x="csX5" y="csY5"/>
+              </a:cxn>
+              <a:cxn ang="0">
+                <a:pos x="csX6" y="csY6"/>
+              </a:cxn>
+              <a:cxn ang="0">
+                <a:pos x="csX7" y="csY7"/>
+              </a:cxn>
+              <a:cxn ang="0">
+                <a:pos x="csX8" y="csY8"/>
+              </a:cxn>
+              <a:cxn ang="0">
+                <a:pos x="csX9" y="csY9"/>
+              </a:cxn>
+              <a:cxn ang="0">
+                <a:pos x="csX10" y="csY10"/>
+              </a:cxn>
+              <a:cxn ang="0">
+                <a:pos x="csX11" y="csY11"/>
+              </a:cxn>
+            </a:cxnLst>
+            <a:rect l="l" t="t" r="r" b="b"/>
+            <a:pathLst>
+              <a:path w="9682559" h="3431459">
+                <a:moveTo>
+                  <a:pt x="7973962" y="1676370"/>
+                </a:moveTo>
+                <a:lnTo>
+                  <a:pt x="9682559" y="1676370"/>
+                </a:lnTo>
+                <a:lnTo>
+                  <a:pt x="9682559" y="2763026"/>
+                </a:lnTo>
+                <a:lnTo>
+                  <a:pt x="7973962" y="2763026"/>
+                </a:lnTo>
+                <a:close/>
+                <a:moveTo>
+                  <a:pt x="6312310" y="0"/>
+                </a:moveTo>
+                <a:lnTo>
+                  <a:pt x="9682559" y="0"/>
+                </a:lnTo>
+                <a:lnTo>
+                  <a:pt x="9682559" y="1676368"/>
+                </a:lnTo>
+                <a:lnTo>
+                  <a:pt x="6312310" y="1676368"/>
+                </a:lnTo>
+                <a:lnTo>
+                  <a:pt x="6312310" y="3431459"/>
+                </a:lnTo>
+                <a:lnTo>
+                  <a:pt x="0" y="3431459"/>
+                </a:lnTo>
+                <a:lnTo>
+                  <a:pt x="0" y="1"/>
+                </a:lnTo>
+                <a:lnTo>
+                  <a:pt x="6312310" y="1"/>
+                </a:lnTo>
+                <a:close/>
+              </a:path>
+            </a:pathLst>
+          </a:custGeom>
+          <a:noFill/>
+          <a:ln w="38100">
+            <a:solidFill>
+              <a:srgbClr val="FF0000"/>
+            </a:solidFill>
+            <a:prstDash val="sysDash"/>
+          </a:ln>
+        </p:spPr>
+        <p:style>
+          <a:lnRef idx="2">
+            <a:schemeClr val="accent1">
+              <a:shade val="15000"/>
+            </a:schemeClr>
+          </a:lnRef>
+          <a:fillRef idx="1">
+            <a:schemeClr val="accent1"/>
+          </a:fillRef>
+          <a:effectRef idx="0">
+            <a:schemeClr val="accent1"/>
+          </a:effectRef>
+          <a:fontRef idx="minor">
+            <a:schemeClr val="lt1"/>
+          </a:fontRef>
+        </p:style>
+        <p:txBody>
+          <a:bodyPr wrap="square" rtlCol="0" anchor="ctr">
+            <a:noAutofit/>
+          </a:bodyPr>
+          <a:lstStyle/>
+          <a:p>
+            <a:pPr algn="ctr"/>
+            <a:endParaRPr lang="en-DE"/>
+          </a:p>
+        </p:txBody>
+      </p:sp>
+      <p:sp>
+        <p:nvSpPr>
+          <p:cNvPr id="12" name="TextBox 11">
+            <a:extLst>
+              <a:ext uri="{FF2B5EF4-FFF2-40B4-BE49-F238E27FC236}">
+                <a16:creationId xmlns:a16="http://schemas.microsoft.com/office/drawing/2014/main" id="{93D2CB16-D880-A491-3CFE-CEAA43FCF67B}"/>
+              </a:ext>
+            </a:extLst>
+          </p:cNvPr>
+          <p:cNvSpPr txBox="1"/>
+          <p:nvPr/>
+        </p:nvSpPr>
+        <p:spPr>
+          <a:xfrm>
+            <a:off x="9139909" y="2934898"/>
+            <a:ext cx="551754" cy="200055"/>
+          </a:xfrm>
+          <a:prstGeom prst="rect">
+            <a:avLst/>
+          </a:prstGeom>
+          <a:noFill/>
+        </p:spPr>
+        <p:txBody>
+          <a:bodyPr wrap="none" rtlCol="0">
+            <a:spAutoFit/>
+          </a:bodyPr>
+          <a:lstStyle/>
+          <a:p>
+            <a:r>
+              <a:rPr lang="en-US" sz="700" b="1" dirty="0">
+                <a:latin typeface="Times New Roman" panose="02020603050405020304" pitchFamily="18" charset="0"/>
+                <a:cs typeface="Times New Roman" panose="02020603050405020304" pitchFamily="18" charset="0"/>
+              </a:rPr>
+              <a:t>Top mem</a:t>
+            </a:r>
+            <a:endParaRPr lang="en-DE" sz="700" b="1" dirty="0">
+              <a:latin typeface="Times New Roman" panose="02020603050405020304" pitchFamily="18" charset="0"/>
+              <a:cs typeface="Times New Roman" panose="02020603050405020304" pitchFamily="18" charset="0"/>
+            </a:endParaRPr>
+          </a:p>
+        </p:txBody>
+      </p:sp>
+      <p:pic>
+        <p:nvPicPr>
+          <p:cNvPr id="3" name="Picture 2" descr="Leading Engineering &amp; Technology Services | Mirafra">
+            <a:extLst>
+              <a:ext uri="{FF2B5EF4-FFF2-40B4-BE49-F238E27FC236}">
+                <a16:creationId xmlns:a16="http://schemas.microsoft.com/office/drawing/2014/main" id="{19E44436-BDB6-A546-F22F-28BB139D8E34}"/>
+              </a:ext>
+            </a:extLst>
+          </p:cNvPr>
+          <p:cNvPicPr>
+            <a:picLocks noChangeAspect="1"/>
+          </p:cNvPicPr>
+          <p:nvPr/>
+        </p:nvPicPr>
+        <p:blipFill>
+          <a:blip r:embed="rId5"/>
+          <a:stretch>
+            <a:fillRect/>
+          </a:stretch>
+        </p:blipFill>
+        <p:spPr>
+          <a:xfrm>
+            <a:off x="9819509" y="176848"/>
+            <a:ext cx="2124469" cy="706386"/>
+          </a:xfrm>
+          <a:prstGeom prst="rect">
+            <a:avLst/>
+          </a:prstGeom>
+        </p:spPr>
+      </p:pic>
+    </p:spTree>
+    <p:extLst>
+      <p:ext uri="{BB962C8B-B14F-4D97-AF65-F5344CB8AC3E}">
+        <p14:creationId xmlns:p14="http://schemas.microsoft.com/office/powerpoint/2010/main" val="1051019821"/>
+      </p:ext>
+    </p:extLst>
+  </p:cSld>
+  <p:clrMapOvr>
+    <a:masterClrMapping/>
+  </p:clrMapOvr>
+</p:sld>
+</file>
+
+<file path=ppt/slides/slide5.xml><?xml version="1.0" encoding="utf-8"?>
 <p:sld xmlns:a="http://schemas.openxmlformats.org/drawingml/2006/main" xmlns:r="http://schemas.openxmlformats.org/officeDocument/2006/relationships" xmlns:p="http://schemas.openxmlformats.org/presentationml/2006/main">
   <p:cSld>
     <p:spTree>
@@ -3932,6 +4742,36 @@
           </a:prstGeom>
         </p:spPr>
       </p:pic>
+      <p:pic>
+        <p:nvPicPr>
+          <p:cNvPr id="4" name="Picture 3" descr="Leading Engineering &amp; Technology Services | Mirafra">
+            <a:extLst>
+              <a:ext uri="{FF2B5EF4-FFF2-40B4-BE49-F238E27FC236}">
+                <a16:creationId xmlns:a16="http://schemas.microsoft.com/office/drawing/2014/main" id="{3C3F988E-C8CB-E61D-F0FB-F048101A177D}"/>
+              </a:ext>
+            </a:extLst>
+          </p:cNvPr>
+          <p:cNvPicPr>
+            <a:picLocks noChangeAspect="1"/>
+          </p:cNvPicPr>
+          <p:nvPr/>
+        </p:nvPicPr>
+        <p:blipFill>
+          <a:blip r:embed="rId3"/>
+          <a:stretch>
+            <a:fillRect/>
+          </a:stretch>
+        </p:blipFill>
+        <p:spPr>
+          <a:xfrm>
+            <a:off x="9819509" y="176848"/>
+            <a:ext cx="2124469" cy="706386"/>
+          </a:xfrm>
+          <a:prstGeom prst="rect">
+            <a:avLst/>
+          </a:prstGeom>
+        </p:spPr>
+      </p:pic>
     </p:spTree>
     <p:extLst>
       <p:ext uri="{BB962C8B-B14F-4D97-AF65-F5344CB8AC3E}">
@@ -3945,7 +4785,7 @@
 </p:sld>
 </file>
 
-<file path=ppt/slides/slide5.xml><?xml version="1.0" encoding="utf-8"?>
+<file path=ppt/slides/slide6.xml><?xml version="1.0" encoding="utf-8"?>
 <p:sld xmlns:a="http://schemas.openxmlformats.org/drawingml/2006/main" xmlns:r="http://schemas.openxmlformats.org/officeDocument/2006/relationships" xmlns:p="http://schemas.openxmlformats.org/presentationml/2006/main">
   <p:cSld>
     <p:spTree>
@@ -4019,6 +4859,36 @@
           <a:xfrm>
             <a:off x="4397700" y="116683"/>
             <a:ext cx="3396599" cy="6624633"/>
+          </a:xfrm>
+          <a:prstGeom prst="rect">
+            <a:avLst/>
+          </a:prstGeom>
+        </p:spPr>
+      </p:pic>
+      <p:pic>
+        <p:nvPicPr>
+          <p:cNvPr id="4" name="Picture 3" descr="Leading Engineering &amp; Technology Services | Mirafra">
+            <a:extLst>
+              <a:ext uri="{FF2B5EF4-FFF2-40B4-BE49-F238E27FC236}">
+                <a16:creationId xmlns:a16="http://schemas.microsoft.com/office/drawing/2014/main" id="{2B41532C-450D-442C-1EA3-58DE6465EF70}"/>
+              </a:ext>
+            </a:extLst>
+          </p:cNvPr>
+          <p:cNvPicPr>
+            <a:picLocks noChangeAspect="1"/>
+          </p:cNvPicPr>
+          <p:nvPr/>
+        </p:nvPicPr>
+        <p:blipFill>
+          <a:blip r:embed="rId3"/>
+          <a:stretch>
+            <a:fillRect/>
+          </a:stretch>
+        </p:blipFill>
+        <p:spPr>
+          <a:xfrm>
+            <a:off x="9819509" y="176848"/>
+            <a:ext cx="2124469" cy="706386"/>
           </a:xfrm>
           <a:prstGeom prst="rect">
             <a:avLst/>
@@ -4331,4 +5201,299 @@
     </a:ext>
   </a:extLst>
 </a:theme>
+</file>
+
+<file path=ppt/theme/theme2.xml><?xml version="1.0" encoding="utf-8"?>
+<a:theme xmlns:a="http://schemas.openxmlformats.org/drawingml/2006/main" name="Office Theme">
+  <a:themeElements>
+    <a:clrScheme name="Office">
+      <a:dk1>
+        <a:sysClr val="windowText" lastClr="000000"/>
+      </a:dk1>
+      <a:lt1>
+        <a:sysClr val="window" lastClr="FFFFFF"/>
+      </a:lt1>
+      <a:dk2>
+        <a:srgbClr val="44546A"/>
+      </a:dk2>
+      <a:lt2>
+        <a:srgbClr val="E7E6E6"/>
+      </a:lt2>
+      <a:accent1>
+        <a:srgbClr val="4472C4"/>
+      </a:accent1>
+      <a:accent2>
+        <a:srgbClr val="ED7D31"/>
+      </a:accent2>
+      <a:accent3>
+        <a:srgbClr val="A5A5A5"/>
+      </a:accent3>
+      <a:accent4>
+        <a:srgbClr val="FFC000"/>
+      </a:accent4>
+      <a:accent5>
+        <a:srgbClr val="5B9BD5"/>
+      </a:accent5>
+      <a:accent6>
+        <a:srgbClr val="70AD47"/>
+      </a:accent6>
+      <a:hlink>
+        <a:srgbClr val="0563C1"/>
+      </a:hlink>
+      <a:folHlink>
+        <a:srgbClr val="954F72"/>
+      </a:folHlink>
+    </a:clrScheme>
+    <a:fontScheme name="Office">
+      <a:majorFont>
+        <a:latin typeface="Calibri Light" panose="020F0302020204030204"/>
+        <a:ea typeface=""/>
+        <a:cs typeface=""/>
+        <a:font script="Jpan" typeface="游ゴシック Light"/>
+        <a:font script="Hang" typeface="맑은 고딕"/>
+        <a:font script="Hans" typeface="等线 Light"/>
+        <a:font script="Hant" typeface="新細明體"/>
+        <a:font script="Arab" typeface="Times New Roman"/>
+        <a:font script="Hebr" typeface="Times New Roman"/>
+        <a:font script="Thai" typeface="Angsana New"/>
+        <a:font script="Ethi" typeface="Nyala"/>
+        <a:font script="Beng" typeface="Vrinda"/>
+        <a:font script="Gujr" typeface="Shruti"/>
+        <a:font script="Khmr" typeface="MoolBoran"/>
+        <a:font script="Knda" typeface="Tunga"/>
+        <a:font script="Guru" typeface="Raavi"/>
+        <a:font script="Cans" typeface="Euphemia"/>
+        <a:font script="Cher" typeface="Plantagenet Cherokee"/>
+        <a:font script="Yiii" typeface="Microsoft Yi Baiti"/>
+        <a:font script="Tibt" typeface="Microsoft Himalaya"/>
+        <a:font script="Thaa" typeface="MV Boli"/>
+        <a:font script="Deva" typeface="Mangal"/>
+        <a:font script="Telu" typeface="Gautami"/>
+        <a:font script="Taml" typeface="Latha"/>
+        <a:font script="Syrc" typeface="Estrangelo Edessa"/>
+        <a:font script="Orya" typeface="Kalinga"/>
+        <a:font script="Mlym" typeface="Kartika"/>
+        <a:font script="Laoo" typeface="DokChampa"/>
+        <a:font script="Sinh" typeface="Iskoola Pota"/>
+        <a:font script="Mong" typeface="Mongolian Baiti"/>
+        <a:font script="Viet" typeface="Times New Roman"/>
+        <a:font script="Uigh" typeface="Microsoft Uighur"/>
+        <a:font script="Geor" typeface="Sylfaen"/>
+        <a:font script="Armn" typeface="Arial"/>
+        <a:font script="Bugi" typeface="Leelawadee UI"/>
+        <a:font script="Bopo" typeface="Microsoft JhengHei"/>
+        <a:font script="Java" typeface="Javanese Text"/>
+        <a:font script="Lisu" typeface="Segoe UI"/>
+        <a:font script="Mymr" typeface="Myanmar Text"/>
+        <a:font script="Nkoo" typeface="Ebrima"/>
+        <a:font script="Olck" typeface="Nirmala UI"/>
+        <a:font script="Osma" typeface="Ebrima"/>
+        <a:font script="Phag" typeface="Phagspa"/>
+        <a:font script="Syrn" typeface="Estrangelo Edessa"/>
+        <a:font script="Syrj" typeface="Estrangelo Edessa"/>
+        <a:font script="Syre" typeface="Estrangelo Edessa"/>
+        <a:font script="Sora" typeface="Nirmala UI"/>
+        <a:font script="Tale" typeface="Microsoft Tai Le"/>
+        <a:font script="Talu" typeface="Microsoft New Tai Lue"/>
+        <a:font script="Tfng" typeface="Ebrima"/>
+      </a:majorFont>
+      <a:minorFont>
+        <a:latin typeface="Calibri" panose="020F0502020204030204"/>
+        <a:ea typeface=""/>
+        <a:cs typeface=""/>
+        <a:font script="Jpan" typeface="游ゴシック"/>
+        <a:font script="Hang" typeface="맑은 고딕"/>
+        <a:font script="Hans" typeface="等线"/>
+        <a:font script="Hant" typeface="新細明體"/>
+        <a:font script="Arab" typeface="Arial"/>
+        <a:font script="Hebr" typeface="Arial"/>
+        <a:font script="Thai" typeface="Cordia New"/>
+        <a:font script="Ethi" typeface="Nyala"/>
+        <a:font script="Beng" typeface="Vrinda"/>
+        <a:font script="Gujr" typeface="Shruti"/>
+        <a:font script="Khmr" typeface="DaunPenh"/>
+        <a:font script="Knda" typeface="Tunga"/>
+        <a:font script="Guru" typeface="Raavi"/>
+        <a:font script="Cans" typeface="Euphemia"/>
+        <a:font script="Cher" typeface="Plantagenet Cherokee"/>
+        <a:font script="Yiii" typeface="Microsoft Yi Baiti"/>
+        <a:font script="Tibt" typeface="Microsoft Himalaya"/>
+        <a:font script="Thaa" typeface="MV Boli"/>
+        <a:font script="Deva" typeface="Mangal"/>
+        <a:font script="Telu" typeface="Gautami"/>
+        <a:font script="Taml" typeface="Latha"/>
+        <a:font script="Syrc" typeface="Estrangelo Edessa"/>
+        <a:font script="Orya" typeface="Kalinga"/>
+        <a:font script="Mlym" typeface="Kartika"/>
+        <a:font script="Laoo" typeface="DokChampa"/>
+        <a:font script="Sinh" typeface="Iskoola Pota"/>
+        <a:font script="Mong" typeface="Mongolian Baiti"/>
+        <a:font script="Viet" typeface="Arial"/>
+        <a:font script="Uigh" typeface="Microsoft Uighur"/>
+        <a:font script="Geor" typeface="Sylfaen"/>
+        <a:font script="Armn" typeface="Arial"/>
+        <a:font script="Bugi" typeface="Leelawadee UI"/>
+        <a:font script="Bopo" typeface="Microsoft JhengHei"/>
+        <a:font script="Java" typeface="Javanese Text"/>
+        <a:font script="Lisu" typeface="Segoe UI"/>
+        <a:font script="Mymr" typeface="Myanmar Text"/>
+        <a:font script="Nkoo" typeface="Ebrima"/>
+        <a:font script="Olck" typeface="Nirmala UI"/>
+        <a:font script="Osma" typeface="Ebrima"/>
+        <a:font script="Phag" typeface="Phagspa"/>
+        <a:font script="Syrn" typeface="Estrangelo Edessa"/>
+        <a:font script="Syrj" typeface="Estrangelo Edessa"/>
+        <a:font script="Syre" typeface="Estrangelo Edessa"/>
+        <a:font script="Sora" typeface="Nirmala UI"/>
+        <a:font script="Tale" typeface="Microsoft Tai Le"/>
+        <a:font script="Talu" typeface="Microsoft New Tai Lue"/>
+        <a:font script="Tfng" typeface="Ebrima"/>
+      </a:minorFont>
+    </a:fontScheme>
+    <a:fmtScheme name="Office">
+      <a:fillStyleLst>
+        <a:solidFill>
+          <a:schemeClr val="phClr"/>
+        </a:solidFill>
+        <a:gradFill rotWithShape="1">
+          <a:gsLst>
+            <a:gs pos="0">
+              <a:schemeClr val="phClr">
+                <a:lumMod val="110000"/>
+                <a:satMod val="105000"/>
+                <a:tint val="67000"/>
+              </a:schemeClr>
+            </a:gs>
+            <a:gs pos="50000">
+              <a:schemeClr val="phClr">
+                <a:lumMod val="105000"/>
+                <a:satMod val="103000"/>
+                <a:tint val="73000"/>
+              </a:schemeClr>
+            </a:gs>
+            <a:gs pos="100000">
+              <a:schemeClr val="phClr">
+                <a:lumMod val="105000"/>
+                <a:satMod val="109000"/>
+                <a:tint val="81000"/>
+              </a:schemeClr>
+            </a:gs>
+          </a:gsLst>
+          <a:lin ang="5400000" scaled="0"/>
+        </a:gradFill>
+        <a:gradFill rotWithShape="1">
+          <a:gsLst>
+            <a:gs pos="0">
+              <a:schemeClr val="phClr">
+                <a:satMod val="103000"/>
+                <a:lumMod val="102000"/>
+                <a:tint val="94000"/>
+              </a:schemeClr>
+            </a:gs>
+            <a:gs pos="50000">
+              <a:schemeClr val="phClr">
+                <a:satMod val="110000"/>
+                <a:lumMod val="100000"/>
+                <a:shade val="100000"/>
+              </a:schemeClr>
+            </a:gs>
+            <a:gs pos="100000">
+              <a:schemeClr val="phClr">
+                <a:lumMod val="99000"/>
+                <a:satMod val="120000"/>
+                <a:shade val="78000"/>
+              </a:schemeClr>
+            </a:gs>
+          </a:gsLst>
+          <a:lin ang="5400000" scaled="0"/>
+        </a:gradFill>
+      </a:fillStyleLst>
+      <a:lnStyleLst>
+        <a:ln w="6350" cap="flat" cmpd="sng" algn="ctr">
+          <a:solidFill>
+            <a:schemeClr val="phClr"/>
+          </a:solidFill>
+          <a:prstDash val="solid"/>
+          <a:miter lim="800000"/>
+        </a:ln>
+        <a:ln w="12700" cap="flat" cmpd="sng" algn="ctr">
+          <a:solidFill>
+            <a:schemeClr val="phClr"/>
+          </a:solidFill>
+          <a:prstDash val="solid"/>
+          <a:miter lim="800000"/>
+        </a:ln>
+        <a:ln w="19050" cap="flat" cmpd="sng" algn="ctr">
+          <a:solidFill>
+            <a:schemeClr val="phClr"/>
+          </a:solidFill>
+          <a:prstDash val="solid"/>
+          <a:miter lim="800000"/>
+        </a:ln>
+      </a:lnStyleLst>
+      <a:effectStyleLst>
+        <a:effectStyle>
+          <a:effectLst/>
+        </a:effectStyle>
+        <a:effectStyle>
+          <a:effectLst/>
+        </a:effectStyle>
+        <a:effectStyle>
+          <a:effectLst>
+            <a:outerShdw blurRad="57150" dist="19050" dir="5400000" algn="ctr" rotWithShape="0">
+              <a:srgbClr val="000000">
+                <a:alpha val="63000"/>
+              </a:srgbClr>
+            </a:outerShdw>
+          </a:effectLst>
+        </a:effectStyle>
+      </a:effectStyleLst>
+      <a:bgFillStyleLst>
+        <a:solidFill>
+          <a:schemeClr val="phClr"/>
+        </a:solidFill>
+        <a:solidFill>
+          <a:schemeClr val="phClr">
+            <a:tint val="95000"/>
+            <a:satMod val="170000"/>
+          </a:schemeClr>
+        </a:solidFill>
+        <a:gradFill rotWithShape="1">
+          <a:gsLst>
+            <a:gs pos="0">
+              <a:schemeClr val="phClr">
+                <a:tint val="93000"/>
+                <a:satMod val="150000"/>
+                <a:shade val="98000"/>
+                <a:lumMod val="102000"/>
+              </a:schemeClr>
+            </a:gs>
+            <a:gs pos="50000">
+              <a:schemeClr val="phClr">
+                <a:tint val="98000"/>
+                <a:satMod val="130000"/>
+                <a:shade val="90000"/>
+                <a:lumMod val="103000"/>
+              </a:schemeClr>
+            </a:gs>
+            <a:gs pos="100000">
+              <a:schemeClr val="phClr">
+                <a:shade val="63000"/>
+                <a:satMod val="120000"/>
+              </a:schemeClr>
+            </a:gs>
+          </a:gsLst>
+          <a:lin ang="5400000" scaled="0"/>
+        </a:gradFill>
+      </a:bgFillStyleLst>
+    </a:fmtScheme>
+  </a:themeElements>
+  <a:objectDefaults/>
+  <a:extraClrSchemeLst/>
+  <a:extLst>
+    <a:ext uri="{05A4C25C-085E-4340-85A3-A5531E510DB2}">
+      <thm15:themeFamily xmlns:thm15="http://schemas.microsoft.com/office/thememl/2012/main" name="Office Theme" id="{62F939B6-93AF-4DB8-9C6B-D6C7DFDC589F}" vid="{4A3C46E8-61CC-4603-A589-7422A47A8E4A}"/>
+    </a:ext>
+  </a:extLst>
+</a:theme>
 </file>
</xml_diff>

<commit_message>
Auto backup 15/10/2026 12:00:03,60
</commit_message>
<xml_diff>
--- a/CPU_Lite/CPU_Lite_PPT.pptx
+++ b/CPU_Lite/CPU_Lite_PPT.pptx
@@ -5,15 +5,23 @@
     <p:sldMasterId id="2147483648" r:id="rId1"/>
   </p:sldMasterIdLst>
   <p:notesMasterIdLst>
-    <p:notesMasterId r:id="rId8"/>
+    <p:notesMasterId r:id="rId16"/>
   </p:notesMasterIdLst>
   <p:sldIdLst>
     <p:sldId id="256" r:id="rId2"/>
     <p:sldId id="257" r:id="rId3"/>
-    <p:sldId id="259" r:id="rId4"/>
-    <p:sldId id="261" r:id="rId5"/>
-    <p:sldId id="258" r:id="rId6"/>
-    <p:sldId id="260" r:id="rId7"/>
+    <p:sldId id="261" r:id="rId4"/>
+    <p:sldId id="262" r:id="rId5"/>
+    <p:sldId id="259" r:id="rId6"/>
+    <p:sldId id="258" r:id="rId7"/>
+    <p:sldId id="263" r:id="rId8"/>
+    <p:sldId id="264" r:id="rId9"/>
+    <p:sldId id="260" r:id="rId10"/>
+    <p:sldId id="265" r:id="rId11"/>
+    <p:sldId id="266" r:id="rId12"/>
+    <p:sldId id="267" r:id="rId13"/>
+    <p:sldId id="268" r:id="rId14"/>
+    <p:sldId id="269" r:id="rId15"/>
   </p:sldIdLst>
   <p:sldSz cx="12192000" cy="6858000"/>
   <p:notesSz cx="6858000" cy="9144000"/>
@@ -202,7 +210,7 @@
           <a:p>
             <a:fld id="{40121602-EAA8-4F1C-9FF7-6AF9819ED24A}" type="datetimeFigureOut">
               <a:rPr lang="en-DE" smtClean="0"/>
-              <a:t>11/10/2026</a:t>
+              <a:t>15/10/2026</a:t>
             </a:fld>
             <a:endParaRPr lang="en-DE"/>
           </a:p>
@@ -619,7 +627,7 @@
           <a:p>
             <a:fld id="{8BF61571-DD67-4DB9-828E-8224F49D10F7}" type="datetime8">
               <a:rPr lang="en-DE" smtClean="0"/>
-              <a:t>11/10/2026 10:28</a:t>
+              <a:t>15/10/2026 03:43</a:t>
             </a:fld>
             <a:endParaRPr lang="en-DE"/>
           </a:p>
@@ -819,7 +827,7 @@
           <a:p>
             <a:fld id="{DE1D51F6-4284-4068-A837-7C1D9F8E0C33}" type="datetime8">
               <a:rPr lang="en-DE" smtClean="0"/>
-              <a:t>11/10/2026 10:28</a:t>
+              <a:t>15/10/2026 03:43</a:t>
             </a:fld>
             <a:endParaRPr lang="en-DE"/>
           </a:p>
@@ -1029,7 +1037,7 @@
           <a:p>
             <a:fld id="{B84C5440-5D12-45B5-9174-2FE7550F8EDC}" type="datetime8">
               <a:rPr lang="en-DE" smtClean="0"/>
-              <a:t>11/10/2026 10:28</a:t>
+              <a:t>15/10/2026 03:43</a:t>
             </a:fld>
             <a:endParaRPr lang="en-DE"/>
           </a:p>
@@ -1229,7 +1237,7 @@
           <a:p>
             <a:fld id="{BD762AD5-4B24-4ABD-947C-0B79DD411B70}" type="datetime8">
               <a:rPr lang="en-DE" smtClean="0"/>
-              <a:t>11/10/2026 10:28</a:t>
+              <a:t>15/10/2026 03:43</a:t>
             </a:fld>
             <a:endParaRPr lang="en-DE"/>
           </a:p>
@@ -1505,7 +1513,7 @@
           <a:p>
             <a:fld id="{D700E591-0DD3-4063-9353-B7994991AA26}" type="datetime8">
               <a:rPr lang="en-DE" smtClean="0"/>
-              <a:t>11/10/2026 10:28</a:t>
+              <a:t>15/10/2026 03:43</a:t>
             </a:fld>
             <a:endParaRPr lang="en-DE"/>
           </a:p>
@@ -1773,7 +1781,7 @@
           <a:p>
             <a:fld id="{75E1A21E-E696-4D3A-AC14-818B200362B9}" type="datetime8">
               <a:rPr lang="en-DE" smtClean="0"/>
-              <a:t>11/10/2026 10:28</a:t>
+              <a:t>15/10/2026 03:43</a:t>
             </a:fld>
             <a:endParaRPr lang="en-DE"/>
           </a:p>
@@ -2188,7 +2196,7 @@
           <a:p>
             <a:fld id="{2270BFA8-8A0B-429B-8866-F0F19839FE2A}" type="datetime8">
               <a:rPr lang="en-DE" smtClean="0"/>
-              <a:t>11/10/2026 10:28</a:t>
+              <a:t>15/10/2026 03:43</a:t>
             </a:fld>
             <a:endParaRPr lang="en-DE"/>
           </a:p>
@@ -2330,7 +2338,7 @@
           <a:p>
             <a:fld id="{A6BE2B78-6173-44EE-AA8A-9FDFCD4A202E}" type="datetime8">
               <a:rPr lang="en-DE" smtClean="0"/>
-              <a:t>11/10/2026 10:28</a:t>
+              <a:t>15/10/2026 03:43</a:t>
             </a:fld>
             <a:endParaRPr lang="en-DE"/>
           </a:p>
@@ -2443,7 +2451,7 @@
           <a:p>
             <a:fld id="{0CAC95DE-1BBF-4297-B01A-9D1D0DAB67F7}" type="datetime8">
               <a:rPr lang="en-DE" smtClean="0"/>
-              <a:t>11/10/2026 10:28</a:t>
+              <a:t>15/10/2026 03:43</a:t>
             </a:fld>
             <a:endParaRPr lang="en-DE"/>
           </a:p>
@@ -2756,7 +2764,7 @@
           <a:p>
             <a:fld id="{58BDAB5A-3AF1-455B-B52A-7F093A6F8B11}" type="datetime8">
               <a:rPr lang="en-DE" smtClean="0"/>
-              <a:t>11/10/2026 10:28</a:t>
+              <a:t>15/10/2026 03:43</a:t>
             </a:fld>
             <a:endParaRPr lang="en-DE"/>
           </a:p>
@@ -3045,7 +3053,7 @@
           <a:p>
             <a:fld id="{E2ED3544-4A9A-4482-8049-1F4A5A0FB2CC}" type="datetime8">
               <a:rPr lang="en-DE" smtClean="0"/>
-              <a:t>11/10/2026 10:28</a:t>
+              <a:t>15/10/2026 03:43</a:t>
             </a:fld>
             <a:endParaRPr lang="en-DE"/>
           </a:p>
@@ -3288,7 +3296,7 @@
           <a:p>
             <a:fld id="{F2BFB065-BC28-4C5F-8855-6FB69D25D066}" type="datetime8">
               <a:rPr lang="en-DE" smtClean="0"/>
-              <a:t>11/10/2026 10:28</a:t>
+              <a:t>15/10/2026 03:43</a:t>
             </a:fld>
             <a:endParaRPr lang="en-DE"/>
           </a:p>
@@ -3728,10 +3736,16 @@
           <a:lstStyle/>
           <a:p>
             <a:r>
-              <a:rPr lang="en-US" dirty="0" err="1"/>
-              <a:t>CPU_Lite</a:t>
-            </a:r>
-            <a:endParaRPr lang="en-DE" dirty="0"/>
+              <a:rPr lang="en-US" b="1" dirty="0">
+                <a:latin typeface="XB Niloofar" panose="02000503080000020003" pitchFamily="2" charset="-78"/>
+                <a:cs typeface="XB Niloofar" panose="02000503080000020003" pitchFamily="2" charset="-78"/>
+              </a:rPr>
+              <a:t>CPU Lite</a:t>
+            </a:r>
+            <a:endParaRPr lang="en-DE" b="1" dirty="0">
+              <a:latin typeface="XB Niloofar" panose="02000503080000020003" pitchFamily="2" charset="-78"/>
+              <a:cs typeface="XB Niloofar" panose="02000503080000020003" pitchFamily="2" charset="-78"/>
+            </a:endParaRPr>
           </a:p>
         </p:txBody>
       </p:sp>
@@ -3756,7 +3770,13 @@
           <a:bodyPr/>
           <a:lstStyle/>
           <a:p>
-            <a:endParaRPr lang="en-DE"/>
+            <a:r>
+              <a:rPr lang="en-DE" b="1" dirty="0">
+                <a:latin typeface="XB Niloofar" panose="02000503080000020003" pitchFamily="2" charset="-78"/>
+                <a:cs typeface="XB Niloofar" panose="02000503080000020003" pitchFamily="2" charset="-78"/>
+              </a:rPr>
+              <a:t>5-Stage Pipelined RISC Core with Write-Back Cache</a:t>
+            </a:r>
           </a:p>
         </p:txBody>
       </p:sp>
@@ -3764,6 +3784,481 @@
     <p:extLst>
       <p:ext uri="{BB962C8B-B14F-4D97-AF65-F5344CB8AC3E}">
         <p14:creationId xmlns:p14="http://schemas.microsoft.com/office/powerpoint/2010/main" val="3626298502"/>
+      </p:ext>
+    </p:extLst>
+  </p:cSld>
+  <p:clrMapOvr>
+    <a:masterClrMapping/>
+  </p:clrMapOvr>
+</p:sld>
+</file>
+
+<file path=ppt/slides/slide10.xml><?xml version="1.0" encoding="utf-8"?>
+<p:sld xmlns:a="http://schemas.openxmlformats.org/drawingml/2006/main" xmlns:r="http://schemas.openxmlformats.org/officeDocument/2006/relationships" xmlns:p="http://schemas.openxmlformats.org/presentationml/2006/main">
+  <p:cSld>
+    <p:spTree>
+      <p:nvGrpSpPr>
+        <p:cNvPr id="1" name=""/>
+        <p:cNvGrpSpPr/>
+        <p:nvPr/>
+      </p:nvGrpSpPr>
+      <p:grpSpPr>
+        <a:xfrm>
+          <a:off x="0" y="0"/>
+          <a:ext cx="0" cy="0"/>
+          <a:chOff x="0" y="0"/>
+          <a:chExt cx="0" cy="0"/>
+        </a:xfrm>
+      </p:grpSpPr>
+      <p:sp>
+        <p:nvSpPr>
+          <p:cNvPr id="2" name="Title 1">
+            <a:extLst>
+              <a:ext uri="{FF2B5EF4-FFF2-40B4-BE49-F238E27FC236}">
+                <a16:creationId xmlns:a16="http://schemas.microsoft.com/office/drawing/2014/main" id="{13F66ECA-1AD5-E995-DD7F-B4BC54AF6C65}"/>
+              </a:ext>
+            </a:extLst>
+          </p:cNvPr>
+          <p:cNvSpPr>
+            <a:spLocks noGrp="1"/>
+          </p:cNvSpPr>
+          <p:nvPr>
+            <p:ph type="title"/>
+          </p:nvPr>
+        </p:nvSpPr>
+        <p:spPr/>
+        <p:txBody>
+          <a:bodyPr/>
+          <a:lstStyle/>
+          <a:p>
+            <a:r>
+              <a:rPr lang="en-US" b="1" dirty="0">
+                <a:latin typeface="XB Niloofar" panose="02000503080000020003" pitchFamily="2" charset="-78"/>
+                <a:cs typeface="XB Niloofar" panose="02000503080000020003" pitchFamily="2" charset="-78"/>
+              </a:rPr>
+              <a:t>Forwarding Unit</a:t>
+            </a:r>
+            <a:endParaRPr lang="en-DE" b="1" dirty="0">
+              <a:latin typeface="XB Niloofar" panose="02000503080000020003" pitchFamily="2" charset="-78"/>
+              <a:cs typeface="XB Niloofar" panose="02000503080000020003" pitchFamily="2" charset="-78"/>
+            </a:endParaRPr>
+          </a:p>
+        </p:txBody>
+      </p:sp>
+      <p:pic>
+        <p:nvPicPr>
+          <p:cNvPr id="5" name="Content Placeholder 4">
+            <a:extLst>
+              <a:ext uri="{FF2B5EF4-FFF2-40B4-BE49-F238E27FC236}">
+                <a16:creationId xmlns:a16="http://schemas.microsoft.com/office/drawing/2014/main" id="{19E8D90D-3223-0DEF-CACA-8F9A24824777}"/>
+              </a:ext>
+            </a:extLst>
+          </p:cNvPr>
+          <p:cNvPicPr>
+            <a:picLocks noGrp="1" noChangeAspect="1"/>
+          </p:cNvPicPr>
+          <p:nvPr>
+            <p:ph idx="1"/>
+          </p:nvPr>
+        </p:nvPicPr>
+        <p:blipFill>
+          <a:blip r:embed="rId2"/>
+          <a:stretch>
+            <a:fillRect/>
+          </a:stretch>
+        </p:blipFill>
+        <p:spPr>
+          <a:xfrm>
+            <a:off x="1325466" y="2313317"/>
+            <a:ext cx="9541067" cy="3375953"/>
+          </a:xfrm>
+          <a:prstGeom prst="rect">
+            <a:avLst/>
+          </a:prstGeom>
+        </p:spPr>
+      </p:pic>
+    </p:spTree>
+    <p:extLst>
+      <p:ext uri="{BB962C8B-B14F-4D97-AF65-F5344CB8AC3E}">
+        <p14:creationId xmlns:p14="http://schemas.microsoft.com/office/powerpoint/2010/main" val="1137069749"/>
+      </p:ext>
+    </p:extLst>
+  </p:cSld>
+  <p:clrMapOvr>
+    <a:masterClrMapping/>
+  </p:clrMapOvr>
+</p:sld>
+</file>
+
+<file path=ppt/slides/slide11.xml><?xml version="1.0" encoding="utf-8"?>
+<p:sld xmlns:a="http://schemas.openxmlformats.org/drawingml/2006/main" xmlns:r="http://schemas.openxmlformats.org/officeDocument/2006/relationships" xmlns:p="http://schemas.openxmlformats.org/presentationml/2006/main">
+  <p:cSld>
+    <p:spTree>
+      <p:nvGrpSpPr>
+        <p:cNvPr id="1" name=""/>
+        <p:cNvGrpSpPr/>
+        <p:nvPr/>
+      </p:nvGrpSpPr>
+      <p:grpSpPr>
+        <a:xfrm>
+          <a:off x="0" y="0"/>
+          <a:ext cx="0" cy="0"/>
+          <a:chOff x="0" y="0"/>
+          <a:chExt cx="0" cy="0"/>
+        </a:xfrm>
+      </p:grpSpPr>
+      <p:sp>
+        <p:nvSpPr>
+          <p:cNvPr id="2" name="Title 1">
+            <a:extLst>
+              <a:ext uri="{FF2B5EF4-FFF2-40B4-BE49-F238E27FC236}">
+                <a16:creationId xmlns:a16="http://schemas.microsoft.com/office/drawing/2014/main" id="{42D683F8-A45C-661E-BBDA-F51FAE844080}"/>
+              </a:ext>
+            </a:extLst>
+          </p:cNvPr>
+          <p:cNvSpPr>
+            <a:spLocks noGrp="1"/>
+          </p:cNvSpPr>
+          <p:nvPr>
+            <p:ph type="title"/>
+          </p:nvPr>
+        </p:nvSpPr>
+        <p:spPr/>
+        <p:txBody>
+          <a:bodyPr/>
+          <a:lstStyle/>
+          <a:p>
+            <a:r>
+              <a:rPr lang="en-US" b="1" dirty="0">
+                <a:latin typeface="XB Niloofar" panose="02000503080000020003" pitchFamily="2" charset="-78"/>
+                <a:cs typeface="XB Niloofar" panose="02000503080000020003" pitchFamily="2" charset="-78"/>
+              </a:rPr>
+              <a:t>Lint results</a:t>
+            </a:r>
+            <a:endParaRPr lang="en-DE" b="1" dirty="0">
+              <a:latin typeface="XB Niloofar" panose="02000503080000020003" pitchFamily="2" charset="-78"/>
+              <a:cs typeface="XB Niloofar" panose="02000503080000020003" pitchFamily="2" charset="-78"/>
+            </a:endParaRPr>
+          </a:p>
+        </p:txBody>
+      </p:sp>
+      <p:sp>
+        <p:nvSpPr>
+          <p:cNvPr id="3" name="Content Placeholder 2">
+            <a:extLst>
+              <a:ext uri="{FF2B5EF4-FFF2-40B4-BE49-F238E27FC236}">
+                <a16:creationId xmlns:a16="http://schemas.microsoft.com/office/drawing/2014/main" id="{54B58747-CFA7-E112-C176-EE520E9FDABA}"/>
+              </a:ext>
+            </a:extLst>
+          </p:cNvPr>
+          <p:cNvSpPr>
+            <a:spLocks noGrp="1"/>
+          </p:cNvSpPr>
+          <p:nvPr>
+            <p:ph idx="1"/>
+          </p:nvPr>
+        </p:nvSpPr>
+        <p:spPr/>
+        <p:txBody>
+          <a:bodyPr/>
+          <a:lstStyle/>
+          <a:p>
+            <a:endParaRPr lang="en-DE"/>
+          </a:p>
+        </p:txBody>
+      </p:sp>
+    </p:spTree>
+    <p:extLst>
+      <p:ext uri="{BB962C8B-B14F-4D97-AF65-F5344CB8AC3E}">
+        <p14:creationId xmlns:p14="http://schemas.microsoft.com/office/powerpoint/2010/main" val="3632186111"/>
+      </p:ext>
+    </p:extLst>
+  </p:cSld>
+  <p:clrMapOvr>
+    <a:masterClrMapping/>
+  </p:clrMapOvr>
+</p:sld>
+</file>
+
+<file path=ppt/slides/slide12.xml><?xml version="1.0" encoding="utf-8"?>
+<p:sld xmlns:a="http://schemas.openxmlformats.org/drawingml/2006/main" xmlns:r="http://schemas.openxmlformats.org/officeDocument/2006/relationships" xmlns:p="http://schemas.openxmlformats.org/presentationml/2006/main">
+  <p:cSld>
+    <p:spTree>
+      <p:nvGrpSpPr>
+        <p:cNvPr id="1" name="">
+          <a:extLst>
+            <a:ext uri="{FF2B5EF4-FFF2-40B4-BE49-F238E27FC236}">
+              <a16:creationId xmlns:a16="http://schemas.microsoft.com/office/drawing/2014/main" id="{1CFFED44-31A0-CAB4-5A26-BABA1DD62A1E}"/>
+            </a:ext>
+          </a:extLst>
+        </p:cNvPr>
+        <p:cNvGrpSpPr/>
+        <p:nvPr/>
+      </p:nvGrpSpPr>
+      <p:grpSpPr>
+        <a:xfrm>
+          <a:off x="0" y="0"/>
+          <a:ext cx="0" cy="0"/>
+          <a:chOff x="0" y="0"/>
+          <a:chExt cx="0" cy="0"/>
+        </a:xfrm>
+      </p:grpSpPr>
+      <p:sp>
+        <p:nvSpPr>
+          <p:cNvPr id="2" name="Title 1">
+            <a:extLst>
+              <a:ext uri="{FF2B5EF4-FFF2-40B4-BE49-F238E27FC236}">
+                <a16:creationId xmlns:a16="http://schemas.microsoft.com/office/drawing/2014/main" id="{FCEA5049-9AE5-0CEE-2FFF-E5C9DDAC40B4}"/>
+              </a:ext>
+            </a:extLst>
+          </p:cNvPr>
+          <p:cNvSpPr>
+            <a:spLocks noGrp="1"/>
+          </p:cNvSpPr>
+          <p:nvPr>
+            <p:ph type="title"/>
+          </p:nvPr>
+        </p:nvSpPr>
+        <p:spPr/>
+        <p:txBody>
+          <a:bodyPr/>
+          <a:lstStyle/>
+          <a:p>
+            <a:r>
+              <a:rPr lang="en-US" b="1" dirty="0">
+                <a:latin typeface="XB Niloofar" panose="02000503080000020003" pitchFamily="2" charset="-78"/>
+                <a:cs typeface="XB Niloofar" panose="02000503080000020003" pitchFamily="2" charset="-78"/>
+              </a:rPr>
+              <a:t>CDC results</a:t>
+            </a:r>
+            <a:endParaRPr lang="en-DE" b="1" dirty="0">
+              <a:latin typeface="XB Niloofar" panose="02000503080000020003" pitchFamily="2" charset="-78"/>
+              <a:cs typeface="XB Niloofar" panose="02000503080000020003" pitchFamily="2" charset="-78"/>
+            </a:endParaRPr>
+          </a:p>
+        </p:txBody>
+      </p:sp>
+      <p:sp>
+        <p:nvSpPr>
+          <p:cNvPr id="3" name="Content Placeholder 2">
+            <a:extLst>
+              <a:ext uri="{FF2B5EF4-FFF2-40B4-BE49-F238E27FC236}">
+                <a16:creationId xmlns:a16="http://schemas.microsoft.com/office/drawing/2014/main" id="{A75FA2D4-0CCD-5D46-AA3A-3E285463F9B1}"/>
+              </a:ext>
+            </a:extLst>
+          </p:cNvPr>
+          <p:cNvSpPr>
+            <a:spLocks noGrp="1"/>
+          </p:cNvSpPr>
+          <p:nvPr>
+            <p:ph idx="1"/>
+          </p:nvPr>
+        </p:nvSpPr>
+        <p:spPr/>
+        <p:txBody>
+          <a:bodyPr/>
+          <a:lstStyle/>
+          <a:p>
+            <a:endParaRPr lang="en-DE"/>
+          </a:p>
+        </p:txBody>
+      </p:sp>
+    </p:spTree>
+    <p:extLst>
+      <p:ext uri="{BB962C8B-B14F-4D97-AF65-F5344CB8AC3E}">
+        <p14:creationId xmlns:p14="http://schemas.microsoft.com/office/powerpoint/2010/main" val="584382053"/>
+      </p:ext>
+    </p:extLst>
+  </p:cSld>
+  <p:clrMapOvr>
+    <a:masterClrMapping/>
+  </p:clrMapOvr>
+</p:sld>
+</file>
+
+<file path=ppt/slides/slide13.xml><?xml version="1.0" encoding="utf-8"?>
+<p:sld xmlns:a="http://schemas.openxmlformats.org/drawingml/2006/main" xmlns:r="http://schemas.openxmlformats.org/officeDocument/2006/relationships" xmlns:p="http://schemas.openxmlformats.org/presentationml/2006/main">
+  <p:cSld>
+    <p:spTree>
+      <p:nvGrpSpPr>
+        <p:cNvPr id="1" name="">
+          <a:extLst>
+            <a:ext uri="{FF2B5EF4-FFF2-40B4-BE49-F238E27FC236}">
+              <a16:creationId xmlns:a16="http://schemas.microsoft.com/office/drawing/2014/main" id="{30F9A523-DDFB-7E64-7A96-3719B9B43174}"/>
+            </a:ext>
+          </a:extLst>
+        </p:cNvPr>
+        <p:cNvGrpSpPr/>
+        <p:nvPr/>
+      </p:nvGrpSpPr>
+      <p:grpSpPr>
+        <a:xfrm>
+          <a:off x="0" y="0"/>
+          <a:ext cx="0" cy="0"/>
+          <a:chOff x="0" y="0"/>
+          <a:chExt cx="0" cy="0"/>
+        </a:xfrm>
+      </p:grpSpPr>
+      <p:sp>
+        <p:nvSpPr>
+          <p:cNvPr id="2" name="Title 1">
+            <a:extLst>
+              <a:ext uri="{FF2B5EF4-FFF2-40B4-BE49-F238E27FC236}">
+                <a16:creationId xmlns:a16="http://schemas.microsoft.com/office/drawing/2014/main" id="{89C7AEC0-5D52-3E45-D19D-4848FAF6BFD6}"/>
+              </a:ext>
+            </a:extLst>
+          </p:cNvPr>
+          <p:cNvSpPr>
+            <a:spLocks noGrp="1"/>
+          </p:cNvSpPr>
+          <p:nvPr>
+            <p:ph type="title"/>
+          </p:nvPr>
+        </p:nvSpPr>
+        <p:spPr/>
+        <p:txBody>
+          <a:bodyPr/>
+          <a:lstStyle/>
+          <a:p>
+            <a:r>
+              <a:rPr lang="en-US" b="1" dirty="0">
+                <a:latin typeface="XB Niloofar" panose="02000503080000020003" pitchFamily="2" charset="-78"/>
+                <a:cs typeface="XB Niloofar" panose="02000503080000020003" pitchFamily="2" charset="-78"/>
+              </a:rPr>
+              <a:t>Synthesis results</a:t>
+            </a:r>
+            <a:endParaRPr lang="en-DE" b="1" dirty="0">
+              <a:latin typeface="XB Niloofar" panose="02000503080000020003" pitchFamily="2" charset="-78"/>
+              <a:cs typeface="XB Niloofar" panose="02000503080000020003" pitchFamily="2" charset="-78"/>
+            </a:endParaRPr>
+          </a:p>
+        </p:txBody>
+      </p:sp>
+      <p:sp>
+        <p:nvSpPr>
+          <p:cNvPr id="3" name="Content Placeholder 2">
+            <a:extLst>
+              <a:ext uri="{FF2B5EF4-FFF2-40B4-BE49-F238E27FC236}">
+                <a16:creationId xmlns:a16="http://schemas.microsoft.com/office/drawing/2014/main" id="{01B0A543-4335-4890-21B8-D57438E9AB9C}"/>
+              </a:ext>
+            </a:extLst>
+          </p:cNvPr>
+          <p:cNvSpPr>
+            <a:spLocks noGrp="1"/>
+          </p:cNvSpPr>
+          <p:nvPr>
+            <p:ph idx="1"/>
+          </p:nvPr>
+        </p:nvSpPr>
+        <p:spPr/>
+        <p:txBody>
+          <a:bodyPr/>
+          <a:lstStyle/>
+          <a:p>
+            <a:endParaRPr lang="en-DE"/>
+          </a:p>
+        </p:txBody>
+      </p:sp>
+    </p:spTree>
+    <p:extLst>
+      <p:ext uri="{BB962C8B-B14F-4D97-AF65-F5344CB8AC3E}">
+        <p14:creationId xmlns:p14="http://schemas.microsoft.com/office/powerpoint/2010/main" val="2009340640"/>
+      </p:ext>
+    </p:extLst>
+  </p:cSld>
+  <p:clrMapOvr>
+    <a:masterClrMapping/>
+  </p:clrMapOvr>
+</p:sld>
+</file>
+
+<file path=ppt/slides/slide14.xml><?xml version="1.0" encoding="utf-8"?>
+<p:sld xmlns:a="http://schemas.openxmlformats.org/drawingml/2006/main" xmlns:r="http://schemas.openxmlformats.org/officeDocument/2006/relationships" xmlns:p="http://schemas.openxmlformats.org/presentationml/2006/main">
+  <p:cSld>
+    <p:spTree>
+      <p:nvGrpSpPr>
+        <p:cNvPr id="1" name="">
+          <a:extLst>
+            <a:ext uri="{FF2B5EF4-FFF2-40B4-BE49-F238E27FC236}">
+              <a16:creationId xmlns:a16="http://schemas.microsoft.com/office/drawing/2014/main" id="{8A170F37-85A0-A8E4-183F-C34DE7F1FFC0}"/>
+            </a:ext>
+          </a:extLst>
+        </p:cNvPr>
+        <p:cNvGrpSpPr/>
+        <p:nvPr/>
+      </p:nvGrpSpPr>
+      <p:grpSpPr>
+        <a:xfrm>
+          <a:off x="0" y="0"/>
+          <a:ext cx="0" cy="0"/>
+          <a:chOff x="0" y="0"/>
+          <a:chExt cx="0" cy="0"/>
+        </a:xfrm>
+      </p:grpSpPr>
+      <p:sp>
+        <p:nvSpPr>
+          <p:cNvPr id="2" name="Title 1">
+            <a:extLst>
+              <a:ext uri="{FF2B5EF4-FFF2-40B4-BE49-F238E27FC236}">
+                <a16:creationId xmlns:a16="http://schemas.microsoft.com/office/drawing/2014/main" id="{DFD0B336-057B-7514-F422-70F09A3C098A}"/>
+              </a:ext>
+            </a:extLst>
+          </p:cNvPr>
+          <p:cNvSpPr>
+            <a:spLocks noGrp="1"/>
+          </p:cNvSpPr>
+          <p:nvPr>
+            <p:ph type="title"/>
+          </p:nvPr>
+        </p:nvSpPr>
+        <p:spPr/>
+        <p:txBody>
+          <a:bodyPr/>
+          <a:lstStyle/>
+          <a:p>
+            <a:r>
+              <a:rPr lang="en-US" b="1" dirty="0">
+                <a:latin typeface="XB Niloofar" panose="02000503080000020003" pitchFamily="2" charset="-78"/>
+                <a:cs typeface="XB Niloofar" panose="02000503080000020003" pitchFamily="2" charset="-78"/>
+              </a:rPr>
+              <a:t>STA results</a:t>
+            </a:r>
+            <a:endParaRPr lang="en-DE" b="1" dirty="0">
+              <a:latin typeface="XB Niloofar" panose="02000503080000020003" pitchFamily="2" charset="-78"/>
+              <a:cs typeface="XB Niloofar" panose="02000503080000020003" pitchFamily="2" charset="-78"/>
+            </a:endParaRPr>
+          </a:p>
+        </p:txBody>
+      </p:sp>
+      <p:sp>
+        <p:nvSpPr>
+          <p:cNvPr id="3" name="Content Placeholder 2">
+            <a:extLst>
+              <a:ext uri="{FF2B5EF4-FFF2-40B4-BE49-F238E27FC236}">
+                <a16:creationId xmlns:a16="http://schemas.microsoft.com/office/drawing/2014/main" id="{9C96BC45-A276-90E8-C13A-36F1FB32767D}"/>
+              </a:ext>
+            </a:extLst>
+          </p:cNvPr>
+          <p:cNvSpPr>
+            <a:spLocks noGrp="1"/>
+          </p:cNvSpPr>
+          <p:nvPr>
+            <p:ph idx="1"/>
+          </p:nvPr>
+        </p:nvSpPr>
+        <p:spPr/>
+        <p:txBody>
+          <a:bodyPr/>
+          <a:lstStyle/>
+          <a:p>
+            <a:endParaRPr lang="en-DE"/>
+          </a:p>
+        </p:txBody>
+      </p:sp>
+    </p:spTree>
+    <p:extLst>
+      <p:ext uri="{BB962C8B-B14F-4D97-AF65-F5344CB8AC3E}">
+        <p14:creationId xmlns:p14="http://schemas.microsoft.com/office/powerpoint/2010/main" val="569207676"/>
       </p:ext>
     </p:extLst>
   </p:cSld>
@@ -3811,7 +4306,17 @@
           <a:bodyPr/>
           <a:lstStyle/>
           <a:p>
-            <a:endParaRPr lang="en-DE"/>
+            <a:r>
+              <a:rPr lang="en-US" b="1" dirty="0">
+                <a:latin typeface="XB Niloofar" panose="02000503080000020003" pitchFamily="2" charset="-78"/>
+                <a:cs typeface="XB Niloofar" panose="02000503080000020003" pitchFamily="2" charset="-78"/>
+              </a:rPr>
+              <a:t>Overview</a:t>
+            </a:r>
+            <a:endParaRPr lang="en-DE" b="1" dirty="0">
+              <a:latin typeface="XB Niloofar" panose="02000503080000020003" pitchFamily="2" charset="-78"/>
+              <a:cs typeface="XB Niloofar" panose="02000503080000020003" pitchFamily="2" charset="-78"/>
+            </a:endParaRPr>
           </a:p>
         </p:txBody>
       </p:sp>
@@ -3978,8 +4483,8 @@
         </p:blipFill>
         <p:spPr>
           <a:xfrm>
-            <a:off x="1651205" y="1401342"/>
-            <a:ext cx="8889590" cy="4541890"/>
+            <a:off x="4660489" y="1858639"/>
+            <a:ext cx="7099505" cy="3627296"/>
           </a:xfrm>
           <a:prstGeom prst="rect">
             <a:avLst/>
@@ -4016,6 +4521,119 @@
           </a:prstGeom>
         </p:spPr>
       </p:pic>
+      <p:sp>
+        <p:nvSpPr>
+          <p:cNvPr id="4" name="TextBox 3">
+            <a:extLst>
+              <a:ext uri="{FF2B5EF4-FFF2-40B4-BE49-F238E27FC236}">
+                <a16:creationId xmlns:a16="http://schemas.microsoft.com/office/drawing/2014/main" id="{DAA6B96E-5236-1063-243F-06E86708F0B4}"/>
+              </a:ext>
+            </a:extLst>
+          </p:cNvPr>
+          <p:cNvSpPr txBox="1"/>
+          <p:nvPr/>
+        </p:nvSpPr>
+        <p:spPr>
+          <a:xfrm>
+            <a:off x="730504" y="2103224"/>
+            <a:ext cx="3526864" cy="4247317"/>
+          </a:xfrm>
+          <a:prstGeom prst="rect">
+            <a:avLst/>
+          </a:prstGeom>
+          <a:noFill/>
+        </p:spPr>
+        <p:txBody>
+          <a:bodyPr wrap="square" rtlCol="0">
+            <a:spAutoFit/>
+          </a:bodyPr>
+          <a:lstStyle/>
+          <a:p>
+            <a:r>
+              <a:rPr lang="en-DE" dirty="0">
+                <a:latin typeface="XB Niloofar" panose="02000503080000020003" pitchFamily="2" charset="-78"/>
+                <a:cs typeface="XB Niloofar" panose="02000503080000020003" pitchFamily="2" charset="-78"/>
+              </a:rPr>
+              <a:t>A </a:t>
+            </a:r>
+            <a:r>
+              <a:rPr lang="en-DE" b="1" dirty="0">
+                <a:latin typeface="XB Niloofar" panose="02000503080000020003" pitchFamily="2" charset="-78"/>
+                <a:cs typeface="XB Niloofar" panose="02000503080000020003" pitchFamily="2" charset="-78"/>
+              </a:rPr>
+              <a:t>32-bit </a:t>
+            </a:r>
+            <a:r>
+              <a:rPr lang="en-DE" dirty="0">
+                <a:latin typeface="XB Niloofar" panose="02000503080000020003" pitchFamily="2" charset="-78"/>
+                <a:cs typeface="XB Niloofar" panose="02000503080000020003" pitchFamily="2" charset="-78"/>
+              </a:rPr>
+              <a:t>single-issue RISC CPU with a cached memory system spanning two asynchronous clock domains, designed in synthesizable Verilog.</a:t>
+            </a:r>
+            <a:endParaRPr lang="en-US" dirty="0">
+              <a:latin typeface="XB Niloofar" panose="02000503080000020003" pitchFamily="2" charset="-78"/>
+              <a:cs typeface="XB Niloofar" panose="02000503080000020003" pitchFamily="2" charset="-78"/>
+            </a:endParaRPr>
+          </a:p>
+          <a:p>
+            <a:pPr rtl="0">
+              <a:buNone/>
+            </a:pPr>
+            <a:endParaRPr lang="en-US" b="1" dirty="0">
+              <a:latin typeface="XB Niloofar" panose="02000503080000020003" pitchFamily="2" charset="-78"/>
+              <a:cs typeface="XB Niloofar" panose="02000503080000020003" pitchFamily="2" charset="-78"/>
+            </a:endParaRPr>
+          </a:p>
+          <a:p>
+            <a:pPr rtl="0">
+              <a:buNone/>
+            </a:pPr>
+            <a:r>
+              <a:rPr lang="en-DE" b="1" dirty="0">
+                <a:latin typeface="XB Niloofar" panose="02000503080000020003" pitchFamily="2" charset="-78"/>
+                <a:cs typeface="XB Niloofar" panose="02000503080000020003" pitchFamily="2" charset="-78"/>
+              </a:rPr>
+              <a:t>Objective</a:t>
+            </a:r>
+            <a:endParaRPr lang="en-DE" dirty="0">
+              <a:latin typeface="XB Niloofar" panose="02000503080000020003" pitchFamily="2" charset="-78"/>
+              <a:cs typeface="XB Niloofar" panose="02000503080000020003" pitchFamily="2" charset="-78"/>
+            </a:endParaRPr>
+          </a:p>
+          <a:p>
+            <a:pPr marL="342900" lvl="0" indent="-342900" rtl="0">
+              <a:buFont typeface="Arial" panose="020B0604020202020204" pitchFamily="34" charset="0"/>
+              <a:buChar char="•"/>
+            </a:pPr>
+            <a:r>
+              <a:rPr lang="en-DE" dirty="0">
+                <a:latin typeface="XB Niloofar" panose="02000503080000020003" pitchFamily="2" charset="-78"/>
+                <a:cs typeface="XB Niloofar" panose="02000503080000020003" pitchFamily="2" charset="-78"/>
+              </a:rPr>
+              <a:t>Design a RISC CPU that fetches from program memory and accesses data memory only through an L1 cache</a:t>
+            </a:r>
+          </a:p>
+          <a:p>
+            <a:pPr marL="342900" lvl="0" indent="-342900" rtl="0">
+              <a:buFont typeface="Arial" panose="020B0604020202020204" pitchFamily="34" charset="0"/>
+              <a:buChar char="•"/>
+            </a:pPr>
+            <a:r>
+              <a:rPr lang="en-DE" dirty="0">
+                <a:latin typeface="XB Niloofar" panose="02000503080000020003" pitchFamily="2" charset="-78"/>
+                <a:cs typeface="XB Niloofar" panose="02000503080000020003" pitchFamily="2" charset="-78"/>
+              </a:rPr>
+              <a:t>Safely connect a fast CPU domain to a slow memory domain</a:t>
+            </a:r>
+          </a:p>
+          <a:p>
+            <a:endParaRPr lang="en-DE" dirty="0">
+              <a:latin typeface="XB Niloofar" panose="02000503080000020003" pitchFamily="2" charset="-78"/>
+              <a:cs typeface="XB Niloofar" panose="02000503080000020003" pitchFamily="2" charset="-78"/>
+            </a:endParaRPr>
+          </a:p>
+        </p:txBody>
+      </p:sp>
     </p:spTree>
     <p:extLst>
       <p:ext uri="{BB962C8B-B14F-4D97-AF65-F5344CB8AC3E}">
@@ -4030,6 +4648,534 @@
 </file>
 
 <file path=ppt/slides/slide3.xml><?xml version="1.0" encoding="utf-8"?>
+<p:sld xmlns:a="http://schemas.openxmlformats.org/drawingml/2006/main" xmlns:r="http://schemas.openxmlformats.org/officeDocument/2006/relationships" xmlns:p="http://schemas.openxmlformats.org/presentationml/2006/main">
+  <p:cSld>
+    <p:spTree>
+      <p:nvGrpSpPr>
+        <p:cNvPr id="1" name="">
+          <a:extLst>
+            <a:ext uri="{FF2B5EF4-FFF2-40B4-BE49-F238E27FC236}">
+              <a16:creationId xmlns:a16="http://schemas.microsoft.com/office/drawing/2014/main" id="{234128D7-0419-E4A6-2325-D421F46AEABC}"/>
+            </a:ext>
+          </a:extLst>
+        </p:cNvPr>
+        <p:cNvGrpSpPr/>
+        <p:nvPr/>
+      </p:nvGrpSpPr>
+      <p:grpSpPr>
+        <a:xfrm>
+          <a:off x="0" y="0"/>
+          <a:ext cx="0" cy="0"/>
+          <a:chOff x="0" y="0"/>
+          <a:chExt cx="0" cy="0"/>
+        </a:xfrm>
+      </p:grpSpPr>
+      <p:sp>
+        <p:nvSpPr>
+          <p:cNvPr id="24" name="Title 23">
+            <a:extLst>
+              <a:ext uri="{FF2B5EF4-FFF2-40B4-BE49-F238E27FC236}">
+                <a16:creationId xmlns:a16="http://schemas.microsoft.com/office/drawing/2014/main" id="{FFBF94B5-8371-05BE-0B89-4544AD7FA623}"/>
+              </a:ext>
+            </a:extLst>
+          </p:cNvPr>
+          <p:cNvSpPr>
+            <a:spLocks noGrp="1"/>
+          </p:cNvSpPr>
+          <p:nvPr>
+            <p:ph type="title"/>
+          </p:nvPr>
+        </p:nvSpPr>
+        <p:spPr/>
+        <p:txBody>
+          <a:bodyPr/>
+          <a:lstStyle/>
+          <a:p>
+            <a:r>
+              <a:rPr lang="en-US" b="1" dirty="0">
+                <a:latin typeface="XB Niloofar" panose="02000503080000020003" pitchFamily="2" charset="-78"/>
+                <a:cs typeface="XB Niloofar" panose="02000503080000020003" pitchFamily="2" charset="-78"/>
+              </a:rPr>
+              <a:t>Key Specification</a:t>
+            </a:r>
+            <a:endParaRPr lang="en-DE" b="1" dirty="0">
+              <a:latin typeface="XB Niloofar" panose="02000503080000020003" pitchFamily="2" charset="-78"/>
+              <a:cs typeface="XB Niloofar" panose="02000503080000020003" pitchFamily="2" charset="-78"/>
+            </a:endParaRPr>
+          </a:p>
+        </p:txBody>
+      </p:sp>
+      <p:graphicFrame>
+        <p:nvGraphicFramePr>
+          <p:cNvPr id="27" name="Content Placeholder 26">
+            <a:extLst>
+              <a:ext uri="{FF2B5EF4-FFF2-40B4-BE49-F238E27FC236}">
+                <a16:creationId xmlns:a16="http://schemas.microsoft.com/office/drawing/2014/main" id="{75C85E1A-90FD-4198-4A10-C5520838CCE7}"/>
+              </a:ext>
+            </a:extLst>
+          </p:cNvPr>
+          <p:cNvGraphicFramePr>
+            <a:graphicFrameLocks noGrp="1"/>
+          </p:cNvGraphicFramePr>
+          <p:nvPr>
+            <p:ph idx="1"/>
+            <p:extLst>
+              <p:ext uri="{D42A27DB-BD31-4B8C-83A1-F6EECF244321}">
+                <p14:modId xmlns:p14="http://schemas.microsoft.com/office/powerpoint/2010/main" val="698114161"/>
+              </p:ext>
+            </p:extLst>
+          </p:nvPr>
+        </p:nvGraphicFramePr>
+        <p:xfrm>
+          <a:off x="838200" y="1926662"/>
+          <a:ext cx="10515600" cy="3931920"/>
+        </p:xfrm>
+        <a:graphic>
+          <a:graphicData uri="http://schemas.openxmlformats.org/drawingml/2006/table">
+            <a:tbl>
+              <a:tblPr>
+                <a:tableStyleId>{68D230F3-CF80-4859-8CE7-A43EE81993B5}</a:tableStyleId>
+              </a:tblPr>
+              <a:tblGrid>
+                <a:gridCol w="5257800">
+                  <a:extLst>
+                    <a:ext uri="{9D8B030D-6E8A-4147-A177-3AD203B41FA5}">
+                      <a16:colId xmlns:a16="http://schemas.microsoft.com/office/drawing/2014/main" val="560928428"/>
+                    </a:ext>
+                  </a:extLst>
+                </a:gridCol>
+                <a:gridCol w="5257800">
+                  <a:extLst>
+                    <a:ext uri="{9D8B030D-6E8A-4147-A177-3AD203B41FA5}">
+                      <a16:colId xmlns:a16="http://schemas.microsoft.com/office/drawing/2014/main" val="4006530656"/>
+                    </a:ext>
+                  </a:extLst>
+                </a:gridCol>
+              </a:tblGrid>
+              <a:tr h="0">
+                <a:tc>
+                  <a:txBody>
+                    <a:bodyPr/>
+                    <a:lstStyle/>
+                    <a:p>
+                      <a:pPr>
+                        <a:buNone/>
+                      </a:pPr>
+                      <a:r>
+                        <a:rPr lang="en-DE" b="1" dirty="0">
+                          <a:latin typeface="XB Niloofar" panose="02000503080000020003" pitchFamily="2" charset="-78"/>
+                          <a:cs typeface="XB Niloofar" panose="02000503080000020003" pitchFamily="2" charset="-78"/>
+                        </a:rPr>
+                        <a:t>Item</a:t>
+                      </a:r>
+                    </a:p>
+                  </a:txBody>
+                  <a:tcPr anchor="ctr"/>
+                </a:tc>
+                <a:tc>
+                  <a:txBody>
+                    <a:bodyPr/>
+                    <a:lstStyle/>
+                    <a:p>
+                      <a:pPr>
+                        <a:buNone/>
+                      </a:pPr>
+                      <a:r>
+                        <a:rPr lang="en-DE" b="1" dirty="0">
+                          <a:latin typeface="XB Niloofar" panose="02000503080000020003" pitchFamily="2" charset="-78"/>
+                          <a:cs typeface="XB Niloofar" panose="02000503080000020003" pitchFamily="2" charset="-78"/>
+                        </a:rPr>
+                        <a:t>Detail</a:t>
+                      </a:r>
+                    </a:p>
+                  </a:txBody>
+                  <a:tcPr anchor="ctr"/>
+                </a:tc>
+                <a:extLst>
+                  <a:ext uri="{0D108BD9-81ED-4DB2-BD59-A6C34878D82A}">
+                    <a16:rowId xmlns:a16="http://schemas.microsoft.com/office/drawing/2014/main" val="1979126605"/>
+                  </a:ext>
+                </a:extLst>
+              </a:tr>
+              <a:tr h="0">
+                <a:tc>
+                  <a:txBody>
+                    <a:bodyPr/>
+                    <a:lstStyle/>
+                    <a:p>
+                      <a:pPr>
+                        <a:buNone/>
+                      </a:pPr>
+                      <a:r>
+                        <a:rPr lang="en-DE" dirty="0">
+                          <a:latin typeface="XB Niloofar" panose="02000503080000020003" pitchFamily="2" charset="-78"/>
+                          <a:cs typeface="XB Niloofar" panose="02000503080000020003" pitchFamily="2" charset="-78"/>
+                        </a:rPr>
+                        <a:t>Datapath</a:t>
+                      </a:r>
+                    </a:p>
+                  </a:txBody>
+                  <a:tcPr anchor="ctr"/>
+                </a:tc>
+                <a:tc>
+                  <a:txBody>
+                    <a:bodyPr/>
+                    <a:lstStyle/>
+                    <a:p>
+                      <a:pPr>
+                        <a:buNone/>
+                      </a:pPr>
+                      <a:r>
+                        <a:rPr lang="en-DE">
+                          <a:latin typeface="XB Niloofar" panose="02000503080000020003" pitchFamily="2" charset="-78"/>
+                          <a:cs typeface="XB Niloofar" panose="02000503080000020003" pitchFamily="2" charset="-78"/>
+                        </a:rPr>
+                        <a:t>32-bit, 16 registers (R0–R15), 12-bit PC, 4-bit PSR (Z, N, C, V)</a:t>
+                      </a:r>
+                    </a:p>
+                  </a:txBody>
+                  <a:tcPr anchor="ctr"/>
+                </a:tc>
+                <a:extLst>
+                  <a:ext uri="{0D108BD9-81ED-4DB2-BD59-A6C34878D82A}">
+                    <a16:rowId xmlns:a16="http://schemas.microsoft.com/office/drawing/2014/main" val="165159083"/>
+                  </a:ext>
+                </a:extLst>
+              </a:tr>
+              <a:tr h="0">
+                <a:tc>
+                  <a:txBody>
+                    <a:bodyPr/>
+                    <a:lstStyle/>
+                    <a:p>
+                      <a:pPr>
+                        <a:buNone/>
+                      </a:pPr>
+                      <a:r>
+                        <a:rPr lang="en-DE">
+                          <a:latin typeface="XB Niloofar" panose="02000503080000020003" pitchFamily="2" charset="-78"/>
+                          <a:cs typeface="XB Niloofar" panose="02000503080000020003" pitchFamily="2" charset="-78"/>
+                        </a:rPr>
+                        <a:t>ISA</a:t>
+                      </a:r>
+                    </a:p>
+                  </a:txBody>
+                  <a:tcPr anchor="ctr"/>
+                </a:tc>
+                <a:tc>
+                  <a:txBody>
+                    <a:bodyPr/>
+                    <a:lstStyle/>
+                    <a:p>
+                      <a:pPr>
+                        <a:buNone/>
+                      </a:pPr>
+                      <a:r>
+                        <a:rPr lang="en-DE">
+                          <a:latin typeface="XB Niloofar" panose="02000503080000020003" pitchFamily="2" charset="-78"/>
+                          <a:cs typeface="XB Niloofar" panose="02000503080000020003" pitchFamily="2" charset="-78"/>
+                        </a:rPr>
+                        <a:t>Fixed 32-bit instructions, about 38 instructions (ALU, load/store, branches, shifts)</a:t>
+                      </a:r>
+                    </a:p>
+                  </a:txBody>
+                  <a:tcPr anchor="ctr"/>
+                </a:tc>
+                <a:extLst>
+                  <a:ext uri="{0D108BD9-81ED-4DB2-BD59-A6C34878D82A}">
+                    <a16:rowId xmlns:a16="http://schemas.microsoft.com/office/drawing/2014/main" val="1416958639"/>
+                  </a:ext>
+                </a:extLst>
+              </a:tr>
+              <a:tr h="0">
+                <a:tc>
+                  <a:txBody>
+                    <a:bodyPr/>
+                    <a:lstStyle/>
+                    <a:p>
+                      <a:pPr>
+                        <a:buNone/>
+                      </a:pPr>
+                      <a:r>
+                        <a:rPr lang="en-DE">
+                          <a:latin typeface="XB Niloofar" panose="02000503080000020003" pitchFamily="2" charset="-78"/>
+                          <a:cs typeface="XB Niloofar" panose="02000503080000020003" pitchFamily="2" charset="-78"/>
+                        </a:rPr>
+                        <a:t>Fast domain (150 MHz)</a:t>
+                      </a:r>
+                    </a:p>
+                  </a:txBody>
+                  <a:tcPr anchor="ctr"/>
+                </a:tc>
+                <a:tc>
+                  <a:txBody>
+                    <a:bodyPr/>
+                    <a:lstStyle/>
+                    <a:p>
+                      <a:pPr>
+                        <a:buNone/>
+                      </a:pPr>
+                      <a:r>
+                        <a:rPr lang="en-DE">
+                          <a:latin typeface="XB Niloofar" panose="02000503080000020003" pitchFamily="2" charset="-78"/>
+                          <a:cs typeface="XB Niloofar" panose="02000503080000020003" pitchFamily="2" charset="-78"/>
+                        </a:rPr>
+                        <a:t>CPU core, L1 data cache, program memory (4K × 32)</a:t>
+                      </a:r>
+                    </a:p>
+                  </a:txBody>
+                  <a:tcPr anchor="ctr"/>
+                </a:tc>
+                <a:extLst>
+                  <a:ext uri="{0D108BD9-81ED-4DB2-BD59-A6C34878D82A}">
+                    <a16:rowId xmlns:a16="http://schemas.microsoft.com/office/drawing/2014/main" val="994896505"/>
+                  </a:ext>
+                </a:extLst>
+              </a:tr>
+              <a:tr h="0">
+                <a:tc>
+                  <a:txBody>
+                    <a:bodyPr/>
+                    <a:lstStyle/>
+                    <a:p>
+                      <a:pPr>
+                        <a:buNone/>
+                      </a:pPr>
+                      <a:r>
+                        <a:rPr lang="en-DE" dirty="0">
+                          <a:latin typeface="XB Niloofar" panose="02000503080000020003" pitchFamily="2" charset="-78"/>
+                          <a:cs typeface="XB Niloofar" panose="02000503080000020003" pitchFamily="2" charset="-78"/>
+                        </a:rPr>
+                        <a:t>Slow domain (70 MHz)</a:t>
+                      </a:r>
+                    </a:p>
+                  </a:txBody>
+                  <a:tcPr anchor="ctr"/>
+                </a:tc>
+                <a:tc>
+                  <a:txBody>
+                    <a:bodyPr/>
+                    <a:lstStyle/>
+                    <a:p>
+                      <a:pPr>
+                        <a:buNone/>
+                      </a:pPr>
+                      <a:r>
+                        <a:rPr lang="en-DE">
+                          <a:latin typeface="XB Niloofar" panose="02000503080000020003" pitchFamily="2" charset="-78"/>
+                          <a:cs typeface="XB Niloofar" panose="02000503080000020003" pitchFamily="2" charset="-78"/>
+                        </a:rPr>
+                        <a:t>Data memory (16K × 32)</a:t>
+                      </a:r>
+                    </a:p>
+                  </a:txBody>
+                  <a:tcPr anchor="ctr"/>
+                </a:tc>
+                <a:extLst>
+                  <a:ext uri="{0D108BD9-81ED-4DB2-BD59-A6C34878D82A}">
+                    <a16:rowId xmlns:a16="http://schemas.microsoft.com/office/drawing/2014/main" val="1434414968"/>
+                  </a:ext>
+                </a:extLst>
+              </a:tr>
+              <a:tr h="0">
+                <a:tc>
+                  <a:txBody>
+                    <a:bodyPr/>
+                    <a:lstStyle/>
+                    <a:p>
+                      <a:pPr>
+                        <a:buNone/>
+                      </a:pPr>
+                      <a:r>
+                        <a:rPr lang="en-DE">
+                          <a:latin typeface="XB Niloofar" panose="02000503080000020003" pitchFamily="2" charset="-78"/>
+                          <a:cs typeface="XB Niloofar" panose="02000503080000020003" pitchFamily="2" charset="-78"/>
+                        </a:rPr>
+                        <a:t>Cache</a:t>
+                      </a:r>
+                    </a:p>
+                  </a:txBody>
+                  <a:tcPr anchor="ctr"/>
+                </a:tc>
+                <a:tc>
+                  <a:txBody>
+                    <a:bodyPr/>
+                    <a:lstStyle/>
+                    <a:p>
+                      <a:pPr>
+                        <a:buNone/>
+                      </a:pPr>
+                      <a:r>
+                        <a:rPr lang="en-DE">
+                          <a:latin typeface="XB Niloofar" panose="02000503080000020003" pitchFamily="2" charset="-78"/>
+                          <a:cs typeface="XB Niloofar" panose="02000503080000020003" pitchFamily="2" charset="-78"/>
+                        </a:rPr>
+                        <a:t>Direct-mapped, write-back with dirty bit, write-allocate</a:t>
+                      </a:r>
+                    </a:p>
+                  </a:txBody>
+                  <a:tcPr anchor="ctr"/>
+                </a:tc>
+                <a:extLst>
+                  <a:ext uri="{0D108BD9-81ED-4DB2-BD59-A6C34878D82A}">
+                    <a16:rowId xmlns:a16="http://schemas.microsoft.com/office/drawing/2014/main" val="2821637120"/>
+                  </a:ext>
+                </a:extLst>
+              </a:tr>
+              <a:tr h="0">
+                <a:tc>
+                  <a:txBody>
+                    <a:bodyPr/>
+                    <a:lstStyle/>
+                    <a:p>
+                      <a:pPr>
+                        <a:buNone/>
+                      </a:pPr>
+                      <a:r>
+                        <a:rPr lang="en-DE" dirty="0">
+                          <a:latin typeface="XB Niloofar" panose="02000503080000020003" pitchFamily="2" charset="-78"/>
+                          <a:cs typeface="XB Niloofar" panose="02000503080000020003" pitchFamily="2" charset="-78"/>
+                        </a:rPr>
+                        <a:t>CDC bridge</a:t>
+                      </a:r>
+                    </a:p>
+                  </a:txBody>
+                  <a:tcPr anchor="ctr"/>
+                </a:tc>
+                <a:tc>
+                  <a:txBody>
+                    <a:bodyPr/>
+                    <a:lstStyle/>
+                    <a:p>
+                      <a:pPr>
+                        <a:buNone/>
+                      </a:pPr>
+                      <a:r>
+                        <a:rPr lang="en-DE" dirty="0">
+                          <a:latin typeface="XB Niloofar" panose="02000503080000020003" pitchFamily="2" charset="-78"/>
+                          <a:cs typeface="XB Niloofar" panose="02000503080000020003" pitchFamily="2" charset="-78"/>
+                        </a:rPr>
+                        <a:t>Async FIFOs, Gray-coded pointers, 2-flop synchronizers (the only domain crossing)</a:t>
+                      </a:r>
+                    </a:p>
+                  </a:txBody>
+                  <a:tcPr anchor="ctr"/>
+                </a:tc>
+                <a:extLst>
+                  <a:ext uri="{0D108BD9-81ED-4DB2-BD59-A6C34878D82A}">
+                    <a16:rowId xmlns:a16="http://schemas.microsoft.com/office/drawing/2014/main" val="187713909"/>
+                  </a:ext>
+                </a:extLst>
+              </a:tr>
+            </a:tbl>
+          </a:graphicData>
+        </a:graphic>
+      </p:graphicFrame>
+    </p:spTree>
+    <p:extLst>
+      <p:ext uri="{BB962C8B-B14F-4D97-AF65-F5344CB8AC3E}">
+        <p14:creationId xmlns:p14="http://schemas.microsoft.com/office/powerpoint/2010/main" val="1132487478"/>
+      </p:ext>
+    </p:extLst>
+  </p:cSld>
+  <p:clrMapOvr>
+    <a:masterClrMapping/>
+  </p:clrMapOvr>
+</p:sld>
+</file>
+
+<file path=ppt/slides/slide4.xml><?xml version="1.0" encoding="utf-8"?>
+<p:sld xmlns:a="http://schemas.openxmlformats.org/drawingml/2006/main" xmlns:r="http://schemas.openxmlformats.org/officeDocument/2006/relationships" xmlns:p="http://schemas.openxmlformats.org/presentationml/2006/main">
+  <p:cSld>
+    <p:spTree>
+      <p:nvGrpSpPr>
+        <p:cNvPr id="1" name=""/>
+        <p:cNvGrpSpPr/>
+        <p:nvPr/>
+      </p:nvGrpSpPr>
+      <p:grpSpPr>
+        <a:xfrm>
+          <a:off x="0" y="0"/>
+          <a:ext cx="0" cy="0"/>
+          <a:chOff x="0" y="0"/>
+          <a:chExt cx="0" cy="0"/>
+        </a:xfrm>
+      </p:grpSpPr>
+      <p:sp>
+        <p:nvSpPr>
+          <p:cNvPr id="4" name="Title 3">
+            <a:extLst>
+              <a:ext uri="{FF2B5EF4-FFF2-40B4-BE49-F238E27FC236}">
+                <a16:creationId xmlns:a16="http://schemas.microsoft.com/office/drawing/2014/main" id="{B28DA5ED-3D91-FB6C-E7B1-57B461FC4FBC}"/>
+              </a:ext>
+            </a:extLst>
+          </p:cNvPr>
+          <p:cNvSpPr>
+            <a:spLocks noGrp="1"/>
+          </p:cNvSpPr>
+          <p:nvPr>
+            <p:ph type="title"/>
+          </p:nvPr>
+        </p:nvSpPr>
+        <p:spPr/>
+        <p:txBody>
+          <a:bodyPr anchor="ctr"/>
+          <a:lstStyle/>
+          <a:p>
+            <a:pPr algn="ctr"/>
+            <a:r>
+              <a:rPr lang="en-US" b="1" dirty="0">
+                <a:latin typeface="XB Niloofar" panose="02000503080000020003" pitchFamily="2" charset="-78"/>
+                <a:cs typeface="XB Niloofar" panose="02000503080000020003" pitchFamily="2" charset="-78"/>
+              </a:rPr>
+              <a:t>Micro Architecture</a:t>
+            </a:r>
+            <a:endParaRPr lang="en-DE" b="1" dirty="0">
+              <a:latin typeface="XB Niloofar" panose="02000503080000020003" pitchFamily="2" charset="-78"/>
+              <a:cs typeface="XB Niloofar" panose="02000503080000020003" pitchFamily="2" charset="-78"/>
+            </a:endParaRPr>
+          </a:p>
+        </p:txBody>
+      </p:sp>
+      <p:sp>
+        <p:nvSpPr>
+          <p:cNvPr id="5" name="Text Placeholder 4">
+            <a:extLst>
+              <a:ext uri="{FF2B5EF4-FFF2-40B4-BE49-F238E27FC236}">
+                <a16:creationId xmlns:a16="http://schemas.microsoft.com/office/drawing/2014/main" id="{909B27E6-1B67-68BA-E042-9031F227B0BA}"/>
+              </a:ext>
+            </a:extLst>
+          </p:cNvPr>
+          <p:cNvSpPr>
+            <a:spLocks noGrp="1"/>
+          </p:cNvSpPr>
+          <p:nvPr>
+            <p:ph type="body" idx="1"/>
+          </p:nvPr>
+        </p:nvSpPr>
+        <p:spPr/>
+        <p:txBody>
+          <a:bodyPr/>
+          <a:lstStyle/>
+          <a:p>
+            <a:endParaRPr lang="en-DE"/>
+          </a:p>
+        </p:txBody>
+      </p:sp>
+    </p:spTree>
+    <p:extLst>
+      <p:ext uri="{BB962C8B-B14F-4D97-AF65-F5344CB8AC3E}">
+        <p14:creationId xmlns:p14="http://schemas.microsoft.com/office/powerpoint/2010/main" val="2430598752"/>
+      </p:ext>
+    </p:extLst>
+  </p:cSld>
+  <p:clrMapOvr>
+    <a:masterClrMapping/>
+  </p:clrMapOvr>
+</p:sld>
+</file>
+
+<file path=ppt/slides/slide5.xml><?xml version="1.0" encoding="utf-8"?>
 <p:sld xmlns:a="http://schemas.openxmlformats.org/drawingml/2006/main" xmlns:r="http://schemas.openxmlformats.org/officeDocument/2006/relationships" xmlns:p="http://schemas.openxmlformats.org/presentationml/2006/main">
   <p:cSld>
     <p:spTree>
@@ -4226,10 +5372,10 @@
       </p:sp>
       <p:pic>
         <p:nvPicPr>
-          <p:cNvPr id="3" name="Picture 2" descr="Leading Engineering &amp; Technology Services | Mirafra">
-            <a:extLst>
-              <a:ext uri="{FF2B5EF4-FFF2-40B4-BE49-F238E27FC236}">
-                <a16:creationId xmlns:a16="http://schemas.microsoft.com/office/drawing/2014/main" id="{F0613DE6-8F75-4A7B-E887-DED473BE4844}"/>
+          <p:cNvPr id="4" name="Picture 3" descr="Leading Engineering &amp; Technology Services | Mirafra">
+            <a:extLst>
+              <a:ext uri="{FF2B5EF4-FFF2-40B4-BE49-F238E27FC236}">
+                <a16:creationId xmlns:a16="http://schemas.microsoft.com/office/drawing/2014/main" id="{70A12A80-A02B-16FD-4116-9CEE212513F9}"/>
               </a:ext>
             </a:extLst>
           </p:cNvPr>
@@ -4246,8 +5392,8 @@
         </p:blipFill>
         <p:spPr>
           <a:xfrm>
-            <a:off x="9819509" y="176848"/>
-            <a:ext cx="2124469" cy="706386"/>
+            <a:off x="10762406" y="365125"/>
+            <a:ext cx="1182788" cy="393277"/>
           </a:xfrm>
           <a:prstGeom prst="rect">
             <a:avLst/>
@@ -4267,402 +5413,7 @@
 </p:sld>
 </file>
 
-<file path=ppt/slides/slide4.xml><?xml version="1.0" encoding="utf-8"?>
-<p:sld xmlns:a="http://schemas.openxmlformats.org/drawingml/2006/main" xmlns:r="http://schemas.openxmlformats.org/officeDocument/2006/relationships" xmlns:p="http://schemas.openxmlformats.org/presentationml/2006/main">
-  <p:cSld>
-    <p:spTree>
-      <p:nvGrpSpPr>
-        <p:cNvPr id="1" name="">
-          <a:extLst>
-            <a:ext uri="{FF2B5EF4-FFF2-40B4-BE49-F238E27FC236}">
-              <a16:creationId xmlns:a16="http://schemas.microsoft.com/office/drawing/2014/main" id="{19CA0A4E-D05B-EA7C-5D7D-F7E7EDF66D1B}"/>
-            </a:ext>
-          </a:extLst>
-        </p:cNvPr>
-        <p:cNvGrpSpPr/>
-        <p:nvPr/>
-      </p:nvGrpSpPr>
-      <p:grpSpPr>
-        <a:xfrm>
-          <a:off x="0" y="0"/>
-          <a:ext cx="0" cy="0"/>
-          <a:chOff x="0" y="0"/>
-          <a:chExt cx="0" cy="0"/>
-        </a:xfrm>
-      </p:grpSpPr>
-      <p:pic>
-        <p:nvPicPr>
-          <p:cNvPr id="9" name="Content Placeholder 8">
-            <a:extLst>
-              <a:ext uri="{FF2B5EF4-FFF2-40B4-BE49-F238E27FC236}">
-                <a16:creationId xmlns:a16="http://schemas.microsoft.com/office/drawing/2014/main" id="{360AD9ED-011F-D3E7-4415-51B037DDB4E6}"/>
-              </a:ext>
-            </a:extLst>
-          </p:cNvPr>
-          <p:cNvPicPr>
-            <a:picLocks noGrp="1" noChangeAspect="1"/>
-          </p:cNvPicPr>
-          <p:nvPr>
-            <p:ph idx="1"/>
-          </p:nvPr>
-        </p:nvPicPr>
-        <p:blipFill>
-          <a:blip r:embed="rId2"/>
-          <a:srcRect l="4330"/>
-          <a:stretch>
-            <a:fillRect/>
-          </a:stretch>
-        </p:blipFill>
-        <p:spPr>
-          <a:xfrm>
-            <a:off x="-1" y="1258529"/>
-            <a:ext cx="12196438" cy="4667966"/>
-          </a:xfrm>
-          <a:prstGeom prst="rect">
-            <a:avLst/>
-          </a:prstGeom>
-        </p:spPr>
-      </p:pic>
-      <mc:AlternateContent xmlns:mc="http://schemas.openxmlformats.org/markup-compatibility/2006">
-        <mc:Choice xmlns:pslz="http://schemas.microsoft.com/office/powerpoint/2016/slidezoom" Requires="pslz">
-          <p:graphicFrame>
-            <p:nvGraphicFramePr>
-              <p:cNvPr id="11" name="Slide Zoom 10">
-                <a:extLst>
-                  <a:ext uri="{FF2B5EF4-FFF2-40B4-BE49-F238E27FC236}">
-                    <a16:creationId xmlns:a16="http://schemas.microsoft.com/office/drawing/2014/main" id="{E74E6645-C8C1-72BB-F45A-FEC7C532E483}"/>
-                  </a:ext>
-                </a:extLst>
-              </p:cNvPr>
-              <p:cNvGraphicFramePr>
-                <a:graphicFrameLocks noChangeAspect="1"/>
-              </p:cNvGraphicFramePr>
-              <p:nvPr/>
-            </p:nvGraphicFramePr>
-            <p:xfrm>
-              <a:off x="9057783" y="3134953"/>
-              <a:ext cx="716006" cy="402754"/>
-            </p:xfrm>
-            <a:graphic>
-              <a:graphicData uri="http://schemas.microsoft.com/office/powerpoint/2016/slidezoom">
-                <pslz:sldZm>
-                  <pslz:sldZmObj sldId="258" cId="15702998">
-                    <pslz:zmPr id="{719C769D-3CF8-4A89-894E-018796295D55}" returnToParent="0" transitionDur="1000">
-                      <p166:blipFill xmlns:p166="http://schemas.microsoft.com/office/powerpoint/2016/6/main">
-                        <a:blip r:embed="rId3"/>
-                        <a:stretch>
-                          <a:fillRect/>
-                        </a:stretch>
-                      </p166:blipFill>
-                      <p166:spPr xmlns:p166="http://schemas.microsoft.com/office/powerpoint/2016/6/main">
-                        <a:xfrm>
-                          <a:off x="0" y="0"/>
-                          <a:ext cx="716006" cy="402754"/>
-                        </a:xfrm>
-                        <a:prstGeom prst="rect">
-                          <a:avLst/>
-                        </a:prstGeom>
-                        <a:ln w="3175">
-                          <a:solidFill>
-                            <a:prstClr val="ltGray"/>
-                          </a:solidFill>
-                        </a:ln>
-                      </p166:spPr>
-                    </pslz:zmPr>
-                  </pslz:sldZmObj>
-                </pslz:sldZm>
-              </a:graphicData>
-            </a:graphic>
-          </p:graphicFrame>
-        </mc:Choice>
-        <mc:Fallback>
-          <p:pic>
-            <p:nvPicPr>
-              <p:cNvPr id="11" name="Slide Zoom 10">
-                <a:hlinkClick r:id="rId4" action="ppaction://hlinksldjump"/>
-                <a:extLst>
-                  <a:ext uri="{FF2B5EF4-FFF2-40B4-BE49-F238E27FC236}">
-                    <a16:creationId xmlns:a16="http://schemas.microsoft.com/office/drawing/2014/main" id="{E74E6645-C8C1-72BB-F45A-FEC7C532E483}"/>
-                  </a:ext>
-                </a:extLst>
-              </p:cNvPr>
-              <p:cNvPicPr>
-                <a:picLocks noGrp="1" noRot="1" noChangeAspect="1" noMove="1" noResize="1" noEditPoints="1" noAdjustHandles="1" noChangeArrowheads="1" noChangeShapeType="1"/>
-              </p:cNvPicPr>
-              <p:nvPr/>
-            </p:nvPicPr>
-            <p:blipFill>
-              <a:blip r:embed="rId3"/>
-              <a:stretch>
-                <a:fillRect/>
-              </a:stretch>
-            </p:blipFill>
-            <p:spPr>
-              <a:xfrm>
-                <a:off x="9057783" y="3134953"/>
-                <a:ext cx="716006" cy="402754"/>
-              </a:xfrm>
-              <a:prstGeom prst="rect">
-                <a:avLst/>
-              </a:prstGeom>
-              <a:ln w="3175">
-                <a:solidFill>
-                  <a:prstClr val="ltGray"/>
-                </a:solidFill>
-              </a:ln>
-            </p:spPr>
-          </p:pic>
-        </mc:Fallback>
-      </mc:AlternateContent>
-      <p:sp>
-        <p:nvSpPr>
-          <p:cNvPr id="7" name="Freeform: Shape 6">
-            <a:extLst>
-              <a:ext uri="{FF2B5EF4-FFF2-40B4-BE49-F238E27FC236}">
-                <a16:creationId xmlns:a16="http://schemas.microsoft.com/office/drawing/2014/main" id="{493E69A5-679C-F861-B428-21DDED247BF6}"/>
-              </a:ext>
-            </a:extLst>
-          </p:cNvPr>
-          <p:cNvSpPr/>
-          <p:nvPr/>
-        </p:nvSpPr>
-        <p:spPr>
-          <a:xfrm>
-            <a:off x="2261419" y="1258529"/>
-            <a:ext cx="9682559" cy="3431459"/>
-          </a:xfrm>
-          <a:custGeom>
-            <a:avLst/>
-            <a:gdLst>
-              <a:gd name="csX0" fmla="*/ 7973962 w 9682559"/>
-              <a:gd name="csY0" fmla="*/ 1676370 h 3431459"/>
-              <a:gd name="csX1" fmla="*/ 9682559 w 9682559"/>
-              <a:gd name="csY1" fmla="*/ 1676370 h 3431459"/>
-              <a:gd name="csX2" fmla="*/ 9682559 w 9682559"/>
-              <a:gd name="csY2" fmla="*/ 2763026 h 3431459"/>
-              <a:gd name="csX3" fmla="*/ 7973962 w 9682559"/>
-              <a:gd name="csY3" fmla="*/ 2763026 h 3431459"/>
-              <a:gd name="csX4" fmla="*/ 6312310 w 9682559"/>
-              <a:gd name="csY4" fmla="*/ 0 h 3431459"/>
-              <a:gd name="csX5" fmla="*/ 9682559 w 9682559"/>
-              <a:gd name="csY5" fmla="*/ 0 h 3431459"/>
-              <a:gd name="csX6" fmla="*/ 9682559 w 9682559"/>
-              <a:gd name="csY6" fmla="*/ 1676368 h 3431459"/>
-              <a:gd name="csX7" fmla="*/ 6312310 w 9682559"/>
-              <a:gd name="csY7" fmla="*/ 1676368 h 3431459"/>
-              <a:gd name="csX8" fmla="*/ 6312310 w 9682559"/>
-              <a:gd name="csY8" fmla="*/ 3431459 h 3431459"/>
-              <a:gd name="csX9" fmla="*/ 0 w 9682559"/>
-              <a:gd name="csY9" fmla="*/ 3431459 h 3431459"/>
-              <a:gd name="csX10" fmla="*/ 0 w 9682559"/>
-              <a:gd name="csY10" fmla="*/ 1 h 3431459"/>
-              <a:gd name="csX11" fmla="*/ 6312310 w 9682559"/>
-              <a:gd name="csY11" fmla="*/ 1 h 3431459"/>
-            </a:gdLst>
-            <a:ahLst/>
-            <a:cxnLst>
-              <a:cxn ang="0">
-                <a:pos x="csX0" y="csY0"/>
-              </a:cxn>
-              <a:cxn ang="0">
-                <a:pos x="csX1" y="csY1"/>
-              </a:cxn>
-              <a:cxn ang="0">
-                <a:pos x="csX2" y="csY2"/>
-              </a:cxn>
-              <a:cxn ang="0">
-                <a:pos x="csX3" y="csY3"/>
-              </a:cxn>
-              <a:cxn ang="0">
-                <a:pos x="csX4" y="csY4"/>
-              </a:cxn>
-              <a:cxn ang="0">
-                <a:pos x="csX5" y="csY5"/>
-              </a:cxn>
-              <a:cxn ang="0">
-                <a:pos x="csX6" y="csY6"/>
-              </a:cxn>
-              <a:cxn ang="0">
-                <a:pos x="csX7" y="csY7"/>
-              </a:cxn>
-              <a:cxn ang="0">
-                <a:pos x="csX8" y="csY8"/>
-              </a:cxn>
-              <a:cxn ang="0">
-                <a:pos x="csX9" y="csY9"/>
-              </a:cxn>
-              <a:cxn ang="0">
-                <a:pos x="csX10" y="csY10"/>
-              </a:cxn>
-              <a:cxn ang="0">
-                <a:pos x="csX11" y="csY11"/>
-              </a:cxn>
-            </a:cxnLst>
-            <a:rect l="l" t="t" r="r" b="b"/>
-            <a:pathLst>
-              <a:path w="9682559" h="3431459">
-                <a:moveTo>
-                  <a:pt x="7973962" y="1676370"/>
-                </a:moveTo>
-                <a:lnTo>
-                  <a:pt x="9682559" y="1676370"/>
-                </a:lnTo>
-                <a:lnTo>
-                  <a:pt x="9682559" y="2763026"/>
-                </a:lnTo>
-                <a:lnTo>
-                  <a:pt x="7973962" y="2763026"/>
-                </a:lnTo>
-                <a:close/>
-                <a:moveTo>
-                  <a:pt x="6312310" y="0"/>
-                </a:moveTo>
-                <a:lnTo>
-                  <a:pt x="9682559" y="0"/>
-                </a:lnTo>
-                <a:lnTo>
-                  <a:pt x="9682559" y="1676368"/>
-                </a:lnTo>
-                <a:lnTo>
-                  <a:pt x="6312310" y="1676368"/>
-                </a:lnTo>
-                <a:lnTo>
-                  <a:pt x="6312310" y="3431459"/>
-                </a:lnTo>
-                <a:lnTo>
-                  <a:pt x="0" y="3431459"/>
-                </a:lnTo>
-                <a:lnTo>
-                  <a:pt x="0" y="1"/>
-                </a:lnTo>
-                <a:lnTo>
-                  <a:pt x="6312310" y="1"/>
-                </a:lnTo>
-                <a:close/>
-              </a:path>
-            </a:pathLst>
-          </a:custGeom>
-          <a:noFill/>
-          <a:ln w="38100">
-            <a:solidFill>
-              <a:srgbClr val="FF0000"/>
-            </a:solidFill>
-            <a:prstDash val="sysDash"/>
-          </a:ln>
-        </p:spPr>
-        <p:style>
-          <a:lnRef idx="2">
-            <a:schemeClr val="accent1">
-              <a:shade val="15000"/>
-            </a:schemeClr>
-          </a:lnRef>
-          <a:fillRef idx="1">
-            <a:schemeClr val="accent1"/>
-          </a:fillRef>
-          <a:effectRef idx="0">
-            <a:schemeClr val="accent1"/>
-          </a:effectRef>
-          <a:fontRef idx="minor">
-            <a:schemeClr val="lt1"/>
-          </a:fontRef>
-        </p:style>
-        <p:txBody>
-          <a:bodyPr wrap="square" rtlCol="0" anchor="ctr">
-            <a:noAutofit/>
-          </a:bodyPr>
-          <a:lstStyle/>
-          <a:p>
-            <a:pPr algn="ctr"/>
-            <a:endParaRPr lang="en-DE"/>
-          </a:p>
-        </p:txBody>
-      </p:sp>
-      <p:sp>
-        <p:nvSpPr>
-          <p:cNvPr id="12" name="TextBox 11">
-            <a:extLst>
-              <a:ext uri="{FF2B5EF4-FFF2-40B4-BE49-F238E27FC236}">
-                <a16:creationId xmlns:a16="http://schemas.microsoft.com/office/drawing/2014/main" id="{93D2CB16-D880-A491-3CFE-CEAA43FCF67B}"/>
-              </a:ext>
-            </a:extLst>
-          </p:cNvPr>
-          <p:cNvSpPr txBox="1"/>
-          <p:nvPr/>
-        </p:nvSpPr>
-        <p:spPr>
-          <a:xfrm>
-            <a:off x="9139909" y="2934898"/>
-            <a:ext cx="551754" cy="200055"/>
-          </a:xfrm>
-          <a:prstGeom prst="rect">
-            <a:avLst/>
-          </a:prstGeom>
-          <a:noFill/>
-        </p:spPr>
-        <p:txBody>
-          <a:bodyPr wrap="none" rtlCol="0">
-            <a:spAutoFit/>
-          </a:bodyPr>
-          <a:lstStyle/>
-          <a:p>
-            <a:r>
-              <a:rPr lang="en-US" sz="700" b="1" dirty="0">
-                <a:latin typeface="Times New Roman" panose="02020603050405020304" pitchFamily="18" charset="0"/>
-                <a:cs typeface="Times New Roman" panose="02020603050405020304" pitchFamily="18" charset="0"/>
-              </a:rPr>
-              <a:t>Top mem</a:t>
-            </a:r>
-            <a:endParaRPr lang="en-DE" sz="700" b="1" dirty="0">
-              <a:latin typeface="Times New Roman" panose="02020603050405020304" pitchFamily="18" charset="0"/>
-              <a:cs typeface="Times New Roman" panose="02020603050405020304" pitchFamily="18" charset="0"/>
-            </a:endParaRPr>
-          </a:p>
-        </p:txBody>
-      </p:sp>
-      <p:pic>
-        <p:nvPicPr>
-          <p:cNvPr id="3" name="Picture 2" descr="Leading Engineering &amp; Technology Services | Mirafra">
-            <a:extLst>
-              <a:ext uri="{FF2B5EF4-FFF2-40B4-BE49-F238E27FC236}">
-                <a16:creationId xmlns:a16="http://schemas.microsoft.com/office/drawing/2014/main" id="{19E44436-BDB6-A546-F22F-28BB139D8E34}"/>
-              </a:ext>
-            </a:extLst>
-          </p:cNvPr>
-          <p:cNvPicPr>
-            <a:picLocks noChangeAspect="1"/>
-          </p:cNvPicPr>
-          <p:nvPr/>
-        </p:nvPicPr>
-        <p:blipFill>
-          <a:blip r:embed="rId5"/>
-          <a:stretch>
-            <a:fillRect/>
-          </a:stretch>
-        </p:blipFill>
-        <p:spPr>
-          <a:xfrm>
-            <a:off x="9819509" y="176848"/>
-            <a:ext cx="2124469" cy="706386"/>
-          </a:xfrm>
-          <a:prstGeom prst="rect">
-            <a:avLst/>
-          </a:prstGeom>
-        </p:spPr>
-      </p:pic>
-    </p:spTree>
-    <p:extLst>
-      <p:ext uri="{BB962C8B-B14F-4D97-AF65-F5344CB8AC3E}">
-        <p14:creationId xmlns:p14="http://schemas.microsoft.com/office/powerpoint/2010/main" val="1051019821"/>
-      </p:ext>
-    </p:extLst>
-  </p:cSld>
-  <p:clrMapOvr>
-    <a:masterClrMapping/>
-  </p:clrMapOvr>
-</p:sld>
-</file>
-
-<file path=ppt/slides/slide5.xml><?xml version="1.0" encoding="utf-8"?>
+<file path=ppt/slides/slide6.xml><?xml version="1.0" encoding="utf-8"?>
 <p:sld xmlns:a="http://schemas.openxmlformats.org/drawingml/2006/main" xmlns:r="http://schemas.openxmlformats.org/officeDocument/2006/relationships" xmlns:p="http://schemas.openxmlformats.org/presentationml/2006/main">
   <p:cSld>
     <p:spTree>
@@ -4744,10 +5495,10 @@
       </p:pic>
       <p:pic>
         <p:nvPicPr>
-          <p:cNvPr id="4" name="Picture 3" descr="Leading Engineering &amp; Technology Services | Mirafra">
-            <a:extLst>
-              <a:ext uri="{FF2B5EF4-FFF2-40B4-BE49-F238E27FC236}">
-                <a16:creationId xmlns:a16="http://schemas.microsoft.com/office/drawing/2014/main" id="{3C3F988E-C8CB-E61D-F0FB-F048101A177D}"/>
+          <p:cNvPr id="5" name="Picture 4" descr="Leading Engineering &amp; Technology Services | Mirafra">
+            <a:extLst>
+              <a:ext uri="{FF2B5EF4-FFF2-40B4-BE49-F238E27FC236}">
+                <a16:creationId xmlns:a16="http://schemas.microsoft.com/office/drawing/2014/main" id="{291C18B3-A5E9-7F40-9B92-D486749333EB}"/>
               </a:ext>
             </a:extLst>
           </p:cNvPr>
@@ -4764,8 +5515,8 @@
         </p:blipFill>
         <p:spPr>
           <a:xfrm>
-            <a:off x="9819509" y="176848"/>
-            <a:ext cx="2124469" cy="706386"/>
+            <a:off x="10762406" y="365125"/>
+            <a:ext cx="1182788" cy="393277"/>
           </a:xfrm>
           <a:prstGeom prst="rect">
             <a:avLst/>
@@ -4785,7 +5536,962 @@
 </p:sld>
 </file>
 
-<file path=ppt/slides/slide6.xml><?xml version="1.0" encoding="utf-8"?>
+<file path=ppt/slides/slide7.xml><?xml version="1.0" encoding="utf-8"?>
+<p:sld xmlns:a="http://schemas.openxmlformats.org/drawingml/2006/main" xmlns:r="http://schemas.openxmlformats.org/officeDocument/2006/relationships" xmlns:p="http://schemas.openxmlformats.org/presentationml/2006/main">
+  <p:cSld>
+    <p:spTree>
+      <p:nvGrpSpPr>
+        <p:cNvPr id="1" name="">
+          <a:extLst>
+            <a:ext uri="{FF2B5EF4-FFF2-40B4-BE49-F238E27FC236}">
+              <a16:creationId xmlns:a16="http://schemas.microsoft.com/office/drawing/2014/main" id="{F275E794-B558-FE10-F2C9-2DADC80F2771}"/>
+            </a:ext>
+          </a:extLst>
+        </p:cNvPr>
+        <p:cNvGrpSpPr/>
+        <p:nvPr/>
+      </p:nvGrpSpPr>
+      <p:grpSpPr>
+        <a:xfrm>
+          <a:off x="0" y="0"/>
+          <a:ext cx="0" cy="0"/>
+          <a:chOff x="0" y="0"/>
+          <a:chExt cx="0" cy="0"/>
+        </a:xfrm>
+      </p:grpSpPr>
+      <p:sp>
+        <p:nvSpPr>
+          <p:cNvPr id="24" name="Title 23">
+            <a:extLst>
+              <a:ext uri="{FF2B5EF4-FFF2-40B4-BE49-F238E27FC236}">
+                <a16:creationId xmlns:a16="http://schemas.microsoft.com/office/drawing/2014/main" id="{4A7BB6EF-1C7E-27B9-7D07-6B48A6C90A48}"/>
+              </a:ext>
+            </a:extLst>
+          </p:cNvPr>
+          <p:cNvSpPr>
+            <a:spLocks noGrp="1"/>
+          </p:cNvSpPr>
+          <p:nvPr>
+            <p:ph type="title"/>
+          </p:nvPr>
+        </p:nvSpPr>
+        <p:spPr/>
+        <p:txBody>
+          <a:bodyPr/>
+          <a:lstStyle/>
+          <a:p>
+            <a:r>
+              <a:rPr lang="en-US" b="1" dirty="0">
+                <a:latin typeface="XB Niloofar" panose="02000503080000020003" pitchFamily="2" charset="-78"/>
+                <a:cs typeface="XB Niloofar" panose="02000503080000020003" pitchFamily="2" charset="-78"/>
+              </a:rPr>
+              <a:t>L1 Cache Parameters</a:t>
+            </a:r>
+            <a:endParaRPr lang="en-DE" b="1" dirty="0">
+              <a:latin typeface="XB Niloofar" panose="02000503080000020003" pitchFamily="2" charset="-78"/>
+              <a:cs typeface="XB Niloofar" panose="02000503080000020003" pitchFamily="2" charset="-78"/>
+            </a:endParaRPr>
+          </a:p>
+        </p:txBody>
+      </p:sp>
+      <p:graphicFrame>
+        <p:nvGraphicFramePr>
+          <p:cNvPr id="27" name="Content Placeholder 26">
+            <a:extLst>
+              <a:ext uri="{FF2B5EF4-FFF2-40B4-BE49-F238E27FC236}">
+                <a16:creationId xmlns:a16="http://schemas.microsoft.com/office/drawing/2014/main" id="{1B1FB130-5E05-F326-8105-B74B2FFB37B9}"/>
+              </a:ext>
+            </a:extLst>
+          </p:cNvPr>
+          <p:cNvGraphicFramePr>
+            <a:graphicFrameLocks noGrp="1"/>
+          </p:cNvGraphicFramePr>
+          <p:nvPr>
+            <p:ph idx="1"/>
+            <p:extLst>
+              <p:ext uri="{D42A27DB-BD31-4B8C-83A1-F6EECF244321}">
+                <p14:modId xmlns:p14="http://schemas.microsoft.com/office/powerpoint/2010/main" val="2952129980"/>
+              </p:ext>
+            </p:extLst>
+          </p:nvPr>
+        </p:nvGraphicFramePr>
+        <p:xfrm>
+          <a:off x="838200" y="2148840"/>
+          <a:ext cx="10515600" cy="2560320"/>
+        </p:xfrm>
+        <a:graphic>
+          <a:graphicData uri="http://schemas.openxmlformats.org/drawingml/2006/table">
+            <a:tbl>
+              <a:tblPr>
+                <a:tableStyleId>{68D230F3-CF80-4859-8CE7-A43EE81993B5}</a:tableStyleId>
+              </a:tblPr>
+              <a:tblGrid>
+                <a:gridCol w="5257800">
+                  <a:extLst>
+                    <a:ext uri="{9D8B030D-6E8A-4147-A177-3AD203B41FA5}">
+                      <a16:colId xmlns:a16="http://schemas.microsoft.com/office/drawing/2014/main" val="560928428"/>
+                    </a:ext>
+                  </a:extLst>
+                </a:gridCol>
+                <a:gridCol w="5257800">
+                  <a:extLst>
+                    <a:ext uri="{9D8B030D-6E8A-4147-A177-3AD203B41FA5}">
+                      <a16:colId xmlns:a16="http://schemas.microsoft.com/office/drawing/2014/main" val="4006530656"/>
+                    </a:ext>
+                  </a:extLst>
+                </a:gridCol>
+              </a:tblGrid>
+              <a:tr h="0">
+                <a:tc>
+                  <a:txBody>
+                    <a:bodyPr/>
+                    <a:lstStyle/>
+                    <a:p>
+                      <a:pPr>
+                        <a:buNone/>
+                      </a:pPr>
+                      <a:r>
+                        <a:rPr lang="en-DE" b="1">
+                          <a:latin typeface="XB Niloofar" panose="02000503080000020003" pitchFamily="2" charset="-78"/>
+                          <a:cs typeface="XB Niloofar" panose="02000503080000020003" pitchFamily="2" charset="-78"/>
+                        </a:rPr>
+                        <a:t>Parameter</a:t>
+                      </a:r>
+                    </a:p>
+                  </a:txBody>
+                  <a:tcPr anchor="ctr"/>
+                </a:tc>
+                <a:tc>
+                  <a:txBody>
+                    <a:bodyPr/>
+                    <a:lstStyle/>
+                    <a:p>
+                      <a:pPr>
+                        <a:buNone/>
+                      </a:pPr>
+                      <a:r>
+                        <a:rPr lang="en-DE" b="1" dirty="0">
+                          <a:latin typeface="XB Niloofar" panose="02000503080000020003" pitchFamily="2" charset="-78"/>
+                          <a:cs typeface="XB Niloofar" panose="02000503080000020003" pitchFamily="2" charset="-78"/>
+                        </a:rPr>
+                        <a:t>Value</a:t>
+                      </a:r>
+                    </a:p>
+                  </a:txBody>
+                  <a:tcPr anchor="ctr"/>
+                </a:tc>
+                <a:extLst>
+                  <a:ext uri="{0D108BD9-81ED-4DB2-BD59-A6C34878D82A}">
+                    <a16:rowId xmlns:a16="http://schemas.microsoft.com/office/drawing/2014/main" val="1979126605"/>
+                  </a:ext>
+                </a:extLst>
+              </a:tr>
+              <a:tr h="0">
+                <a:tc>
+                  <a:txBody>
+                    <a:bodyPr/>
+                    <a:lstStyle/>
+                    <a:p>
+                      <a:pPr>
+                        <a:buNone/>
+                      </a:pPr>
+                      <a:r>
+                        <a:rPr lang="en-DE">
+                          <a:latin typeface="XB Niloofar" panose="02000503080000020003" pitchFamily="2" charset="-78"/>
+                          <a:cs typeface="XB Niloofar" panose="02000503080000020003" pitchFamily="2" charset="-78"/>
+                        </a:rPr>
+                        <a:t>Mapping</a:t>
+                      </a:r>
+                    </a:p>
+                  </a:txBody>
+                  <a:tcPr anchor="ctr"/>
+                </a:tc>
+                <a:tc>
+                  <a:txBody>
+                    <a:bodyPr/>
+                    <a:lstStyle/>
+                    <a:p>
+                      <a:pPr>
+                        <a:buNone/>
+                      </a:pPr>
+                      <a:r>
+                        <a:rPr lang="en-DE">
+                          <a:latin typeface="XB Niloofar" panose="02000503080000020003" pitchFamily="2" charset="-78"/>
+                          <a:cs typeface="XB Niloofar" panose="02000503080000020003" pitchFamily="2" charset="-78"/>
+                        </a:rPr>
+                        <a:t>Direct-mapped</a:t>
+                      </a:r>
+                    </a:p>
+                  </a:txBody>
+                  <a:tcPr anchor="ctr"/>
+                </a:tc>
+                <a:extLst>
+                  <a:ext uri="{0D108BD9-81ED-4DB2-BD59-A6C34878D82A}">
+                    <a16:rowId xmlns:a16="http://schemas.microsoft.com/office/drawing/2014/main" val="165159083"/>
+                  </a:ext>
+                </a:extLst>
+              </a:tr>
+              <a:tr h="0">
+                <a:tc>
+                  <a:txBody>
+                    <a:bodyPr/>
+                    <a:lstStyle/>
+                    <a:p>
+                      <a:pPr>
+                        <a:buNone/>
+                      </a:pPr>
+                      <a:r>
+                        <a:rPr lang="en-DE">
+                          <a:latin typeface="XB Niloofar" panose="02000503080000020003" pitchFamily="2" charset="-78"/>
+                          <a:cs typeface="XB Niloofar" panose="02000503080000020003" pitchFamily="2" charset="-78"/>
+                        </a:rPr>
+                        <a:t>Line size</a:t>
+                      </a:r>
+                    </a:p>
+                  </a:txBody>
+                  <a:tcPr anchor="ctr"/>
+                </a:tc>
+                <a:tc>
+                  <a:txBody>
+                    <a:bodyPr/>
+                    <a:lstStyle/>
+                    <a:p>
+                      <a:pPr>
+                        <a:buNone/>
+                      </a:pPr>
+                      <a:r>
+                        <a:rPr lang="en-DE">
+                          <a:latin typeface="XB Niloofar" panose="02000503080000020003" pitchFamily="2" charset="-78"/>
+                          <a:cs typeface="XB Niloofar" panose="02000503080000020003" pitchFamily="2" charset="-78"/>
+                        </a:rPr>
+                        <a:t>4 words (128 bits)</a:t>
+                      </a:r>
+                    </a:p>
+                  </a:txBody>
+                  <a:tcPr anchor="ctr"/>
+                </a:tc>
+                <a:extLst>
+                  <a:ext uri="{0D108BD9-81ED-4DB2-BD59-A6C34878D82A}">
+                    <a16:rowId xmlns:a16="http://schemas.microsoft.com/office/drawing/2014/main" val="1416958639"/>
+                  </a:ext>
+                </a:extLst>
+              </a:tr>
+              <a:tr h="0">
+                <a:tc>
+                  <a:txBody>
+                    <a:bodyPr/>
+                    <a:lstStyle/>
+                    <a:p>
+                      <a:pPr>
+                        <a:buNone/>
+                      </a:pPr>
+                      <a:r>
+                        <a:rPr lang="en-DE">
+                          <a:latin typeface="XB Niloofar" panose="02000503080000020003" pitchFamily="2" charset="-78"/>
+                          <a:cs typeface="XB Niloofar" panose="02000503080000020003" pitchFamily="2" charset="-78"/>
+                        </a:rPr>
+                        <a:t>Number of lines</a:t>
+                      </a:r>
+                    </a:p>
+                  </a:txBody>
+                  <a:tcPr anchor="ctr"/>
+                </a:tc>
+                <a:tc>
+                  <a:txBody>
+                    <a:bodyPr/>
+                    <a:lstStyle/>
+                    <a:p>
+                      <a:pPr>
+                        <a:buNone/>
+                      </a:pPr>
+                      <a:r>
+                        <a:rPr lang="en-DE">
+                          <a:latin typeface="XB Niloofar" panose="02000503080000020003" pitchFamily="2" charset="-78"/>
+                          <a:cs typeface="XB Niloofar" panose="02000503080000020003" pitchFamily="2" charset="-78"/>
+                        </a:rPr>
+                        <a:t>64 (parameterized)</a:t>
+                      </a:r>
+                    </a:p>
+                  </a:txBody>
+                  <a:tcPr anchor="ctr"/>
+                </a:tc>
+                <a:extLst>
+                  <a:ext uri="{0D108BD9-81ED-4DB2-BD59-A6C34878D82A}">
+                    <a16:rowId xmlns:a16="http://schemas.microsoft.com/office/drawing/2014/main" val="994896505"/>
+                  </a:ext>
+                </a:extLst>
+              </a:tr>
+              <a:tr h="0">
+                <a:tc>
+                  <a:txBody>
+                    <a:bodyPr/>
+                    <a:lstStyle/>
+                    <a:p>
+                      <a:pPr>
+                        <a:buNone/>
+                      </a:pPr>
+                      <a:r>
+                        <a:rPr lang="en-DE">
+                          <a:latin typeface="XB Niloofar" panose="02000503080000020003" pitchFamily="2" charset="-78"/>
+                          <a:cs typeface="XB Niloofar" panose="02000503080000020003" pitchFamily="2" charset="-78"/>
+                        </a:rPr>
+                        <a:t>Capacity</a:t>
+                      </a:r>
+                    </a:p>
+                  </a:txBody>
+                  <a:tcPr anchor="ctr"/>
+                </a:tc>
+                <a:tc>
+                  <a:txBody>
+                    <a:bodyPr/>
+                    <a:lstStyle/>
+                    <a:p>
+                      <a:pPr>
+                        <a:buNone/>
+                      </a:pPr>
+                      <a:r>
+                        <a:rPr lang="en-DE">
+                          <a:latin typeface="XB Niloofar" panose="02000503080000020003" pitchFamily="2" charset="-78"/>
+                          <a:cs typeface="XB Niloofar" panose="02000503080000020003" pitchFamily="2" charset="-78"/>
+                        </a:rPr>
+                        <a:t>256 words (1 KB)</a:t>
+                      </a:r>
+                    </a:p>
+                  </a:txBody>
+                  <a:tcPr anchor="ctr"/>
+                </a:tc>
+                <a:extLst>
+                  <a:ext uri="{0D108BD9-81ED-4DB2-BD59-A6C34878D82A}">
+                    <a16:rowId xmlns:a16="http://schemas.microsoft.com/office/drawing/2014/main" val="1434414968"/>
+                  </a:ext>
+                </a:extLst>
+              </a:tr>
+              <a:tr h="0">
+                <a:tc>
+                  <a:txBody>
+                    <a:bodyPr/>
+                    <a:lstStyle/>
+                    <a:p>
+                      <a:pPr>
+                        <a:buNone/>
+                      </a:pPr>
+                      <a:r>
+                        <a:rPr lang="en-DE">
+                          <a:latin typeface="XB Niloofar" panose="02000503080000020003" pitchFamily="2" charset="-78"/>
+                          <a:cs typeface="XB Niloofar" panose="02000503080000020003" pitchFamily="2" charset="-78"/>
+                        </a:rPr>
+                        <a:t>Address</a:t>
+                      </a:r>
+                    </a:p>
+                  </a:txBody>
+                  <a:tcPr anchor="ctr"/>
+                </a:tc>
+                <a:tc>
+                  <a:txBody>
+                    <a:bodyPr/>
+                    <a:lstStyle/>
+                    <a:p>
+                      <a:pPr>
+                        <a:buNone/>
+                      </a:pPr>
+                      <a:r>
+                        <a:rPr lang="en-DE">
+                          <a:latin typeface="XB Niloofar" panose="02000503080000020003" pitchFamily="2" charset="-78"/>
+                          <a:cs typeface="XB Niloofar" panose="02000503080000020003" pitchFamily="2" charset="-78"/>
+                        </a:rPr>
+                        <a:t>14-bit word address</a:t>
+                      </a:r>
+                    </a:p>
+                  </a:txBody>
+                  <a:tcPr anchor="ctr"/>
+                </a:tc>
+                <a:extLst>
+                  <a:ext uri="{0D108BD9-81ED-4DB2-BD59-A6C34878D82A}">
+                    <a16:rowId xmlns:a16="http://schemas.microsoft.com/office/drawing/2014/main" val="2821637120"/>
+                  </a:ext>
+                </a:extLst>
+              </a:tr>
+              <a:tr h="0">
+                <a:tc>
+                  <a:txBody>
+                    <a:bodyPr/>
+                    <a:lstStyle/>
+                    <a:p>
+                      <a:pPr>
+                        <a:buNone/>
+                      </a:pPr>
+                      <a:r>
+                        <a:rPr lang="en-DE">
+                          <a:latin typeface="XB Niloofar" panose="02000503080000020003" pitchFamily="2" charset="-78"/>
+                          <a:cs typeface="XB Niloofar" panose="02000503080000020003" pitchFamily="2" charset="-78"/>
+                        </a:rPr>
+                        <a:t>Write policy</a:t>
+                      </a:r>
+                    </a:p>
+                  </a:txBody>
+                  <a:tcPr anchor="ctr"/>
+                </a:tc>
+                <a:tc>
+                  <a:txBody>
+                    <a:bodyPr/>
+                    <a:lstStyle/>
+                    <a:p>
+                      <a:pPr>
+                        <a:buNone/>
+                      </a:pPr>
+                      <a:r>
+                        <a:rPr lang="en-DE" dirty="0">
+                          <a:latin typeface="XB Niloofar" panose="02000503080000020003" pitchFamily="2" charset="-78"/>
+                          <a:cs typeface="XB Niloofar" panose="02000503080000020003" pitchFamily="2" charset="-78"/>
+                        </a:rPr>
+                        <a:t>Write-back, write-allocate</a:t>
+                      </a:r>
+                    </a:p>
+                  </a:txBody>
+                  <a:tcPr anchor="ctr"/>
+                </a:tc>
+                <a:extLst>
+                  <a:ext uri="{0D108BD9-81ED-4DB2-BD59-A6C34878D82A}">
+                    <a16:rowId xmlns:a16="http://schemas.microsoft.com/office/drawing/2014/main" val="187713909"/>
+                  </a:ext>
+                </a:extLst>
+              </a:tr>
+            </a:tbl>
+          </a:graphicData>
+        </a:graphic>
+      </p:graphicFrame>
+    </p:spTree>
+    <p:extLst>
+      <p:ext uri="{BB962C8B-B14F-4D97-AF65-F5344CB8AC3E}">
+        <p14:creationId xmlns:p14="http://schemas.microsoft.com/office/powerpoint/2010/main" val="3962160580"/>
+      </p:ext>
+    </p:extLst>
+  </p:cSld>
+  <p:clrMapOvr>
+    <a:masterClrMapping/>
+  </p:clrMapOvr>
+</p:sld>
+</file>
+
+<file path=ppt/slides/slide8.xml><?xml version="1.0" encoding="utf-8"?>
+<p:sld xmlns:a="http://schemas.openxmlformats.org/drawingml/2006/main" xmlns:r="http://schemas.openxmlformats.org/officeDocument/2006/relationships" xmlns:p="http://schemas.openxmlformats.org/presentationml/2006/main">
+  <p:cSld>
+    <p:spTree>
+      <p:nvGrpSpPr>
+        <p:cNvPr id="1" name=""/>
+        <p:cNvGrpSpPr/>
+        <p:nvPr/>
+      </p:nvGrpSpPr>
+      <p:grpSpPr>
+        <a:xfrm>
+          <a:off x="0" y="0"/>
+          <a:ext cx="0" cy="0"/>
+          <a:chOff x="0" y="0"/>
+          <a:chExt cx="0" cy="0"/>
+        </a:xfrm>
+      </p:grpSpPr>
+      <p:sp>
+        <p:nvSpPr>
+          <p:cNvPr id="2" name="Title 1">
+            <a:extLst>
+              <a:ext uri="{FF2B5EF4-FFF2-40B4-BE49-F238E27FC236}">
+                <a16:creationId xmlns:a16="http://schemas.microsoft.com/office/drawing/2014/main" id="{170BF12C-F6EA-E818-050D-2EA741445B4A}"/>
+              </a:ext>
+            </a:extLst>
+          </p:cNvPr>
+          <p:cNvSpPr>
+            <a:spLocks noGrp="1"/>
+          </p:cNvSpPr>
+          <p:nvPr>
+            <p:ph type="title"/>
+          </p:nvPr>
+        </p:nvSpPr>
+        <p:spPr/>
+        <p:txBody>
+          <a:bodyPr/>
+          <a:lstStyle/>
+          <a:p>
+            <a:r>
+              <a:rPr lang="en-US" b="1" dirty="0">
+                <a:latin typeface="XB Niloofar" panose="02000503080000020003" pitchFamily="2" charset="-78"/>
+                <a:cs typeface="XB Niloofar" panose="02000503080000020003" pitchFamily="2" charset="-78"/>
+              </a:rPr>
+              <a:t>Cache Behavior</a:t>
+            </a:r>
+            <a:endParaRPr lang="en-DE" b="1" dirty="0">
+              <a:latin typeface="XB Niloofar" panose="02000503080000020003" pitchFamily="2" charset="-78"/>
+              <a:cs typeface="XB Niloofar" panose="02000503080000020003" pitchFamily="2" charset="-78"/>
+            </a:endParaRPr>
+          </a:p>
+        </p:txBody>
+      </p:sp>
+      <p:graphicFrame>
+        <p:nvGraphicFramePr>
+          <p:cNvPr id="4" name="Content Placeholder 3">
+            <a:extLst>
+              <a:ext uri="{FF2B5EF4-FFF2-40B4-BE49-F238E27FC236}">
+                <a16:creationId xmlns:a16="http://schemas.microsoft.com/office/drawing/2014/main" id="{D481B535-0342-F2D3-CEB0-E0813501801F}"/>
+              </a:ext>
+            </a:extLst>
+          </p:cNvPr>
+          <p:cNvGraphicFramePr>
+            <a:graphicFrameLocks noGrp="1"/>
+          </p:cNvGraphicFramePr>
+          <p:nvPr>
+            <p:ph idx="1"/>
+            <p:extLst>
+              <p:ext uri="{D42A27DB-BD31-4B8C-83A1-F6EECF244321}">
+                <p14:modId xmlns:p14="http://schemas.microsoft.com/office/powerpoint/2010/main" val="4234566358"/>
+              </p:ext>
+            </p:extLst>
+          </p:nvPr>
+        </p:nvGraphicFramePr>
+        <p:xfrm>
+          <a:off x="838200" y="2286000"/>
+          <a:ext cx="10515600" cy="2286000"/>
+        </p:xfrm>
+        <a:graphic>
+          <a:graphicData uri="http://schemas.openxmlformats.org/drawingml/2006/table">
+            <a:tbl>
+              <a:tblPr>
+                <a:tableStyleId>{93296810-A885-4BE3-A3E7-6D5BEEA58F35}</a:tableStyleId>
+              </a:tblPr>
+              <a:tblGrid>
+                <a:gridCol w="3505200">
+                  <a:extLst>
+                    <a:ext uri="{9D8B030D-6E8A-4147-A177-3AD203B41FA5}">
+                      <a16:colId xmlns:a16="http://schemas.microsoft.com/office/drawing/2014/main" val="1137275006"/>
+                    </a:ext>
+                  </a:extLst>
+                </a:gridCol>
+                <a:gridCol w="3505200">
+                  <a:extLst>
+                    <a:ext uri="{9D8B030D-6E8A-4147-A177-3AD203B41FA5}">
+                      <a16:colId xmlns:a16="http://schemas.microsoft.com/office/drawing/2014/main" val="2542971651"/>
+                    </a:ext>
+                  </a:extLst>
+                </a:gridCol>
+                <a:gridCol w="3505200">
+                  <a:extLst>
+                    <a:ext uri="{9D8B030D-6E8A-4147-A177-3AD203B41FA5}">
+                      <a16:colId xmlns:a16="http://schemas.microsoft.com/office/drawing/2014/main" val="1405833799"/>
+                    </a:ext>
+                  </a:extLst>
+                </a:gridCol>
+              </a:tblGrid>
+              <a:tr h="0">
+                <a:tc>
+                  <a:txBody>
+                    <a:bodyPr/>
+                    <a:lstStyle/>
+                    <a:p>
+                      <a:pPr>
+                        <a:buNone/>
+                      </a:pPr>
+                      <a:r>
+                        <a:rPr lang="en-DE" b="1">
+                          <a:latin typeface="XB Niloofar" panose="02000503080000020003" pitchFamily="2" charset="-78"/>
+                          <a:cs typeface="XB Niloofar" panose="02000503080000020003" pitchFamily="2" charset="-78"/>
+                        </a:rPr>
+                        <a:t>Access</a:t>
+                      </a:r>
+                    </a:p>
+                  </a:txBody>
+                  <a:tcPr anchor="ctr"/>
+                </a:tc>
+                <a:tc>
+                  <a:txBody>
+                    <a:bodyPr/>
+                    <a:lstStyle/>
+                    <a:p>
+                      <a:pPr>
+                        <a:buNone/>
+                      </a:pPr>
+                      <a:r>
+                        <a:rPr lang="en-DE" b="1">
+                          <a:latin typeface="XB Niloofar" panose="02000503080000020003" pitchFamily="2" charset="-78"/>
+                          <a:cs typeface="XB Niloofar" panose="02000503080000020003" pitchFamily="2" charset="-78"/>
+                        </a:rPr>
+                        <a:t>Hit</a:t>
+                      </a:r>
+                    </a:p>
+                  </a:txBody>
+                  <a:tcPr anchor="ctr"/>
+                </a:tc>
+                <a:tc>
+                  <a:txBody>
+                    <a:bodyPr/>
+                    <a:lstStyle/>
+                    <a:p>
+                      <a:pPr>
+                        <a:buNone/>
+                      </a:pPr>
+                      <a:r>
+                        <a:rPr lang="en-DE" b="1" dirty="0">
+                          <a:latin typeface="XB Niloofar" panose="02000503080000020003" pitchFamily="2" charset="-78"/>
+                          <a:cs typeface="XB Niloofar" panose="02000503080000020003" pitchFamily="2" charset="-78"/>
+                        </a:rPr>
+                        <a:t>Miss</a:t>
+                      </a:r>
+                    </a:p>
+                  </a:txBody>
+                  <a:tcPr anchor="ctr"/>
+                </a:tc>
+                <a:extLst>
+                  <a:ext uri="{0D108BD9-81ED-4DB2-BD59-A6C34878D82A}">
+                    <a16:rowId xmlns:a16="http://schemas.microsoft.com/office/drawing/2014/main" val="926235015"/>
+                  </a:ext>
+                </a:extLst>
+              </a:tr>
+              <a:tr h="0">
+                <a:tc>
+                  <a:txBody>
+                    <a:bodyPr/>
+                    <a:lstStyle/>
+                    <a:p>
+                      <a:pPr>
+                        <a:buNone/>
+                      </a:pPr>
+                      <a:r>
+                        <a:rPr lang="en-DE">
+                          <a:latin typeface="XB Niloofar" panose="02000503080000020003" pitchFamily="2" charset="-78"/>
+                          <a:cs typeface="XB Niloofar" panose="02000503080000020003" pitchFamily="2" charset="-78"/>
+                        </a:rPr>
+                        <a:t>Read</a:t>
+                      </a:r>
+                    </a:p>
+                  </a:txBody>
+                  <a:tcPr anchor="ctr"/>
+                </a:tc>
+                <a:tc>
+                  <a:txBody>
+                    <a:bodyPr/>
+                    <a:lstStyle/>
+                    <a:p>
+                      <a:pPr>
+                        <a:buNone/>
+                      </a:pPr>
+                      <a:r>
+                        <a:rPr lang="en-DE" dirty="0">
+                          <a:latin typeface="XB Niloofar" panose="02000503080000020003" pitchFamily="2" charset="-78"/>
+                          <a:cs typeface="XB Niloofar" panose="02000503080000020003" pitchFamily="2" charset="-78"/>
+                        </a:rPr>
+                        <a:t>Return word in 1 cycle, no memory traffic</a:t>
+                      </a:r>
+                    </a:p>
+                  </a:txBody>
+                  <a:tcPr anchor="ctr"/>
+                </a:tc>
+                <a:tc>
+                  <a:txBody>
+                    <a:bodyPr/>
+                    <a:lstStyle/>
+                    <a:p>
+                      <a:pPr>
+                        <a:buNone/>
+                      </a:pPr>
+                      <a:r>
+                        <a:rPr lang="en-DE">
+                          <a:latin typeface="XB Niloofar" panose="02000503080000020003" pitchFamily="2" charset="-78"/>
+                          <a:cs typeface="XB Niloofar" panose="02000503080000020003" pitchFamily="2" charset="-78"/>
+                        </a:rPr>
+                        <a:t>Fill line from memory, then return the word</a:t>
+                      </a:r>
+                    </a:p>
+                  </a:txBody>
+                  <a:tcPr anchor="ctr"/>
+                </a:tc>
+                <a:extLst>
+                  <a:ext uri="{0D108BD9-81ED-4DB2-BD59-A6C34878D82A}">
+                    <a16:rowId xmlns:a16="http://schemas.microsoft.com/office/drawing/2014/main" val="1118273957"/>
+                  </a:ext>
+                </a:extLst>
+              </a:tr>
+              <a:tr h="0">
+                <a:tc>
+                  <a:txBody>
+                    <a:bodyPr/>
+                    <a:lstStyle/>
+                    <a:p>
+                      <a:pPr>
+                        <a:buNone/>
+                      </a:pPr>
+                      <a:r>
+                        <a:rPr lang="en-DE" dirty="0">
+                          <a:latin typeface="XB Niloofar" panose="02000503080000020003" pitchFamily="2" charset="-78"/>
+                          <a:cs typeface="XB Niloofar" panose="02000503080000020003" pitchFamily="2" charset="-78"/>
+                        </a:rPr>
+                        <a:t>Write</a:t>
+                      </a:r>
+                    </a:p>
+                  </a:txBody>
+                  <a:tcPr anchor="ctr"/>
+                </a:tc>
+                <a:tc>
+                  <a:txBody>
+                    <a:bodyPr/>
+                    <a:lstStyle/>
+                    <a:p>
+                      <a:pPr>
+                        <a:buNone/>
+                      </a:pPr>
+                      <a:r>
+                        <a:rPr lang="en-DE">
+                          <a:latin typeface="XB Niloofar" panose="02000503080000020003" pitchFamily="2" charset="-78"/>
+                          <a:cs typeface="XB Niloofar" panose="02000503080000020003" pitchFamily="2" charset="-78"/>
+                        </a:rPr>
+                        <a:t>Update word, set dirty, no memory traffic</a:t>
+                      </a:r>
+                    </a:p>
+                  </a:txBody>
+                  <a:tcPr anchor="ctr"/>
+                </a:tc>
+                <a:tc>
+                  <a:txBody>
+                    <a:bodyPr/>
+                    <a:lstStyle/>
+                    <a:p>
+                      <a:pPr>
+                        <a:buNone/>
+                      </a:pPr>
+                      <a:r>
+                        <a:rPr lang="en-DE">
+                          <a:latin typeface="XB Niloofar" panose="02000503080000020003" pitchFamily="2" charset="-78"/>
+                          <a:cs typeface="XB Niloofar" panose="02000503080000020003" pitchFamily="2" charset="-78"/>
+                        </a:rPr>
+                        <a:t>Fill line (write-allocate), apply write, set dirty</a:t>
+                      </a:r>
+                    </a:p>
+                  </a:txBody>
+                  <a:tcPr anchor="ctr"/>
+                </a:tc>
+                <a:extLst>
+                  <a:ext uri="{0D108BD9-81ED-4DB2-BD59-A6C34878D82A}">
+                    <a16:rowId xmlns:a16="http://schemas.microsoft.com/office/drawing/2014/main" val="1112193705"/>
+                  </a:ext>
+                </a:extLst>
+              </a:tr>
+              <a:tr h="0">
+                <a:tc>
+                  <a:txBody>
+                    <a:bodyPr/>
+                    <a:lstStyle/>
+                    <a:p>
+                      <a:pPr>
+                        <a:buNone/>
+                      </a:pPr>
+                      <a:r>
+                        <a:rPr lang="en-DE">
+                          <a:latin typeface="XB Niloofar" panose="02000503080000020003" pitchFamily="2" charset="-78"/>
+                          <a:cs typeface="XB Niloofar" panose="02000503080000020003" pitchFamily="2" charset="-78"/>
+                        </a:rPr>
+                        <a:t>Miss on dirty line</a:t>
+                      </a:r>
+                    </a:p>
+                  </a:txBody>
+                  <a:tcPr anchor="ctr"/>
+                </a:tc>
+                <a:tc>
+                  <a:txBody>
+                    <a:bodyPr/>
+                    <a:lstStyle/>
+                    <a:p>
+                      <a:pPr>
+                        <a:buNone/>
+                      </a:pPr>
+                      <a:r>
+                        <a:rPr lang="en-DE" dirty="0">
+                          <a:latin typeface="XB Niloofar" panose="02000503080000020003" pitchFamily="2" charset="-78"/>
+                          <a:cs typeface="XB Niloofar" panose="02000503080000020003" pitchFamily="2" charset="-78"/>
+                        </a:rPr>
+                        <a:t>n/a</a:t>
+                      </a:r>
+                    </a:p>
+                  </a:txBody>
+                  <a:tcPr anchor="ctr"/>
+                </a:tc>
+                <a:tc>
+                  <a:txBody>
+                    <a:bodyPr/>
+                    <a:lstStyle/>
+                    <a:p>
+                      <a:pPr>
+                        <a:buNone/>
+                      </a:pPr>
+                      <a:r>
+                        <a:rPr lang="en-DE" dirty="0">
+                          <a:latin typeface="XB Niloofar" panose="02000503080000020003" pitchFamily="2" charset="-78"/>
+                          <a:cs typeface="XB Niloofar" panose="02000503080000020003" pitchFamily="2" charset="-78"/>
+                        </a:rPr>
+                        <a:t>Write back the old line first, then fill</a:t>
+                      </a:r>
+                    </a:p>
+                  </a:txBody>
+                  <a:tcPr anchor="ctr"/>
+                </a:tc>
+                <a:extLst>
+                  <a:ext uri="{0D108BD9-81ED-4DB2-BD59-A6C34878D82A}">
+                    <a16:rowId xmlns:a16="http://schemas.microsoft.com/office/drawing/2014/main" val="3630289626"/>
+                  </a:ext>
+                </a:extLst>
+              </a:tr>
+            </a:tbl>
+          </a:graphicData>
+        </a:graphic>
+      </p:graphicFrame>
+      <p:sp>
+        <p:nvSpPr>
+          <p:cNvPr id="6" name="TextBox 5">
+            <a:extLst>
+              <a:ext uri="{FF2B5EF4-FFF2-40B4-BE49-F238E27FC236}">
+                <a16:creationId xmlns:a16="http://schemas.microsoft.com/office/drawing/2014/main" id="{50A3623D-E98F-F90A-4178-09ECFCFCADA1}"/>
+              </a:ext>
+            </a:extLst>
+          </p:cNvPr>
+          <p:cNvSpPr txBox="1"/>
+          <p:nvPr/>
+        </p:nvSpPr>
+        <p:spPr>
+          <a:xfrm>
+            <a:off x="838200" y="4946925"/>
+            <a:ext cx="6096000" cy="1323439"/>
+          </a:xfrm>
+          <a:prstGeom prst="rect">
+            <a:avLst/>
+          </a:prstGeom>
+          <a:noFill/>
+        </p:spPr>
+        <p:txBody>
+          <a:bodyPr wrap="square">
+            <a:spAutoFit/>
+          </a:bodyPr>
+          <a:lstStyle/>
+          <a:p>
+            <a:r>
+              <a:rPr lang="en-US" b="1" dirty="0">
+                <a:latin typeface="XB Niloofar" panose="02000503080000020003" pitchFamily="2" charset="-78"/>
+                <a:cs typeface="XB Niloofar" panose="02000503080000020003" pitchFamily="2" charset="-78"/>
+              </a:rPr>
+              <a:t>Address Split:</a:t>
+            </a:r>
+          </a:p>
+          <a:p>
+            <a:endParaRPr lang="en-US" sz="800" dirty="0">
+              <a:latin typeface="XB Niloofar" panose="02000503080000020003" pitchFamily="2" charset="-78"/>
+              <a:cs typeface="XB Niloofar" panose="02000503080000020003" pitchFamily="2" charset="-78"/>
+            </a:endParaRPr>
+          </a:p>
+          <a:p>
+            <a:r>
+              <a:rPr lang="en-DE" dirty="0">
+                <a:latin typeface="XB Niloofar" panose="02000503080000020003" pitchFamily="2" charset="-78"/>
+                <a:cs typeface="XB Niloofar" panose="02000503080000020003" pitchFamily="2" charset="-78"/>
+              </a:rPr>
+              <a:t>| </a:t>
+            </a:r>
+            <a:r>
+              <a:rPr lang="en-DE" b="1" dirty="0">
+                <a:latin typeface="XB Niloofar" panose="02000503080000020003" pitchFamily="2" charset="-78"/>
+                <a:cs typeface="XB Niloofar" panose="02000503080000020003" pitchFamily="2" charset="-78"/>
+              </a:rPr>
+              <a:t>Tag [13:8] | Index [7:2] | Offset [1:0] </a:t>
+            </a:r>
+            <a:r>
+              <a:rPr lang="en-DE" dirty="0">
+                <a:latin typeface="XB Niloofar" panose="02000503080000020003" pitchFamily="2" charset="-78"/>
+                <a:cs typeface="XB Niloofar" panose="02000503080000020003" pitchFamily="2" charset="-78"/>
+              </a:rPr>
+              <a:t>|</a:t>
+            </a:r>
+            <a:endParaRPr lang="en-US" dirty="0">
+              <a:latin typeface="XB Niloofar" panose="02000503080000020003" pitchFamily="2" charset="-78"/>
+              <a:cs typeface="XB Niloofar" panose="02000503080000020003" pitchFamily="2" charset="-78"/>
+            </a:endParaRPr>
+          </a:p>
+          <a:p>
+            <a:r>
+              <a:rPr lang="en-US" dirty="0">
+                <a:latin typeface="XB Niloofar" panose="02000503080000020003" pitchFamily="2" charset="-78"/>
+                <a:cs typeface="XB Niloofar" panose="02000503080000020003" pitchFamily="2" charset="-78"/>
+              </a:rPr>
+              <a:t>-----------------------------------</a:t>
+            </a:r>
+            <a:r>
+              <a:rPr lang="en-DE" dirty="0">
+                <a:latin typeface="XB Niloofar" panose="02000503080000020003" pitchFamily="2" charset="-78"/>
+                <a:cs typeface="XB Niloofar" panose="02000503080000020003" pitchFamily="2" charset="-78"/>
+              </a:rPr>
+              <a:t> </a:t>
+            </a:r>
+            <a:endParaRPr lang="en-US" dirty="0">
+              <a:latin typeface="XB Niloofar" panose="02000503080000020003" pitchFamily="2" charset="-78"/>
+              <a:cs typeface="XB Niloofar" panose="02000503080000020003" pitchFamily="2" charset="-78"/>
+            </a:endParaRPr>
+          </a:p>
+          <a:p>
+            <a:r>
+              <a:rPr lang="en-DE" dirty="0">
+                <a:latin typeface="XB Niloofar" panose="02000503080000020003" pitchFamily="2" charset="-78"/>
+                <a:cs typeface="XB Niloofar" panose="02000503080000020003" pitchFamily="2" charset="-78"/>
+              </a:rPr>
+              <a:t>| 6 bits </a:t>
+            </a:r>
+            <a:r>
+              <a:rPr lang="en-US" dirty="0">
+                <a:latin typeface="XB Niloofar" panose="02000503080000020003" pitchFamily="2" charset="-78"/>
+                <a:cs typeface="XB Niloofar" panose="02000503080000020003" pitchFamily="2" charset="-78"/>
+              </a:rPr>
+              <a:t>          |</a:t>
+            </a:r>
+            <a:r>
+              <a:rPr lang="en-DE" dirty="0">
+                <a:latin typeface="XB Niloofar" panose="02000503080000020003" pitchFamily="2" charset="-78"/>
+                <a:cs typeface="XB Niloofar" panose="02000503080000020003" pitchFamily="2" charset="-78"/>
+              </a:rPr>
+              <a:t> 6 bits </a:t>
+            </a:r>
+            <a:r>
+              <a:rPr lang="en-US" dirty="0">
+                <a:latin typeface="XB Niloofar" panose="02000503080000020003" pitchFamily="2" charset="-78"/>
+                <a:cs typeface="XB Niloofar" panose="02000503080000020003" pitchFamily="2" charset="-78"/>
+              </a:rPr>
+              <a:t>            | </a:t>
+            </a:r>
+            <a:r>
+              <a:rPr lang="en-DE" dirty="0">
+                <a:latin typeface="XB Niloofar" panose="02000503080000020003" pitchFamily="2" charset="-78"/>
+                <a:cs typeface="XB Niloofar" panose="02000503080000020003" pitchFamily="2" charset="-78"/>
+              </a:rPr>
+              <a:t> 2 bits </a:t>
+            </a:r>
+            <a:r>
+              <a:rPr lang="en-US" dirty="0">
+                <a:latin typeface="XB Niloofar" panose="02000503080000020003" pitchFamily="2" charset="-78"/>
+                <a:cs typeface="XB Niloofar" panose="02000503080000020003" pitchFamily="2" charset="-78"/>
+              </a:rPr>
+              <a:t>           |</a:t>
+            </a:r>
+            <a:endParaRPr lang="en-DE" dirty="0">
+              <a:latin typeface="XB Niloofar" panose="02000503080000020003" pitchFamily="2" charset="-78"/>
+              <a:cs typeface="XB Niloofar" panose="02000503080000020003" pitchFamily="2" charset="-78"/>
+            </a:endParaRPr>
+          </a:p>
+        </p:txBody>
+      </p:sp>
+    </p:spTree>
+    <p:extLst>
+      <p:ext uri="{BB962C8B-B14F-4D97-AF65-F5344CB8AC3E}">
+        <p14:creationId xmlns:p14="http://schemas.microsoft.com/office/powerpoint/2010/main" val="3063900418"/>
+      </p:ext>
+    </p:extLst>
+  </p:cSld>
+  <p:clrMapOvr>
+    <a:masterClrMapping/>
+  </p:clrMapOvr>
+</p:sld>
+</file>
+
+<file path=ppt/slides/slide9.xml><?xml version="1.0" encoding="utf-8"?>
 <p:sld xmlns:a="http://schemas.openxmlformats.org/drawingml/2006/main" xmlns:r="http://schemas.openxmlformats.org/officeDocument/2006/relationships" xmlns:p="http://schemas.openxmlformats.org/presentationml/2006/main">
   <p:cSld>
     <p:spTree>
@@ -4857,7 +6563,7 @@
         </p:blipFill>
         <p:spPr>
           <a:xfrm>
-            <a:off x="4397700" y="116683"/>
+            <a:off x="6096000" y="116682"/>
             <a:ext cx="3396599" cy="6624633"/>
           </a:xfrm>
           <a:prstGeom prst="rect">
@@ -4867,10 +6573,10 @@
       </p:pic>
       <p:pic>
         <p:nvPicPr>
-          <p:cNvPr id="4" name="Picture 3" descr="Leading Engineering &amp; Technology Services | Mirafra">
-            <a:extLst>
-              <a:ext uri="{FF2B5EF4-FFF2-40B4-BE49-F238E27FC236}">
-                <a16:creationId xmlns:a16="http://schemas.microsoft.com/office/drawing/2014/main" id="{2B41532C-450D-442C-1EA3-58DE6465EF70}"/>
+          <p:cNvPr id="5" name="Picture 4" descr="Leading Engineering &amp; Technology Services | Mirafra">
+            <a:extLst>
+              <a:ext uri="{FF2B5EF4-FFF2-40B4-BE49-F238E27FC236}">
+                <a16:creationId xmlns:a16="http://schemas.microsoft.com/office/drawing/2014/main" id="{DBCE317A-4411-A09B-E8AF-8D64DBFA588E}"/>
               </a:ext>
             </a:extLst>
           </p:cNvPr>
@@ -4887,14 +6593,67 @@
         </p:blipFill>
         <p:spPr>
           <a:xfrm>
-            <a:off x="9819509" y="176848"/>
-            <a:ext cx="2124469" cy="706386"/>
+            <a:off x="10762406" y="365125"/>
+            <a:ext cx="1182788" cy="393277"/>
           </a:xfrm>
           <a:prstGeom prst="rect">
             <a:avLst/>
           </a:prstGeom>
         </p:spPr>
       </p:pic>
+      <p:sp>
+        <p:nvSpPr>
+          <p:cNvPr id="6" name="TextBox 5">
+            <a:extLst>
+              <a:ext uri="{FF2B5EF4-FFF2-40B4-BE49-F238E27FC236}">
+                <a16:creationId xmlns:a16="http://schemas.microsoft.com/office/drawing/2014/main" id="{6C2F568F-14BF-94A2-C4B9-7324C1DC9123}"/>
+              </a:ext>
+            </a:extLst>
+          </p:cNvPr>
+          <p:cNvSpPr txBox="1"/>
+          <p:nvPr/>
+        </p:nvSpPr>
+        <p:spPr>
+          <a:xfrm>
+            <a:off x="1108260" y="3428998"/>
+            <a:ext cx="3182281" cy="1077218"/>
+          </a:xfrm>
+          <a:prstGeom prst="rect">
+            <a:avLst/>
+          </a:prstGeom>
+          <a:noFill/>
+        </p:spPr>
+        <p:txBody>
+          <a:bodyPr wrap="none" rtlCol="0">
+            <a:spAutoFit/>
+          </a:bodyPr>
+          <a:lstStyle/>
+          <a:p>
+            <a:pPr algn="ctr"/>
+            <a:r>
+              <a:rPr lang="en-US" sz="3200" b="1" dirty="0">
+                <a:latin typeface="XB Niloofar" panose="02000503080000020003" pitchFamily="2" charset="-78"/>
+                <a:cs typeface="XB Niloofar" panose="02000503080000020003" pitchFamily="2" charset="-78"/>
+              </a:rPr>
+              <a:t>L1 Cache </a:t>
+            </a:r>
+          </a:p>
+          <a:p>
+            <a:pPr algn="ctr"/>
+            <a:r>
+              <a:rPr lang="en-US" sz="3200" b="1" dirty="0">
+                <a:latin typeface="XB Niloofar" panose="02000503080000020003" pitchFamily="2" charset="-78"/>
+                <a:cs typeface="XB Niloofar" panose="02000503080000020003" pitchFamily="2" charset="-78"/>
+              </a:rPr>
+              <a:t>Controller FSM</a:t>
+            </a:r>
+            <a:endParaRPr lang="en-DE" sz="3200" b="1" dirty="0">
+              <a:latin typeface="XB Niloofar" panose="02000503080000020003" pitchFamily="2" charset="-78"/>
+              <a:cs typeface="XB Niloofar" panose="02000503080000020003" pitchFamily="2" charset="-78"/>
+            </a:endParaRPr>
+          </a:p>
+        </p:txBody>
+      </p:sp>
     </p:spTree>
     <p:extLst>
       <p:ext uri="{BB962C8B-B14F-4D97-AF65-F5344CB8AC3E}">

</xml_diff>

<commit_message>
Auto backup 16/10/2026 12:00:02,39
</commit_message>
<xml_diff>
--- a/CPU_Lite/CPU_Lite_PPT.pptx
+++ b/CPU_Lite/CPU_Lite_PPT.pptx
@@ -5,7 +5,7 @@
     <p:sldMasterId id="2147483648" r:id="rId1"/>
   </p:sldMasterIdLst>
   <p:notesMasterIdLst>
-    <p:notesMasterId r:id="rId16"/>
+    <p:notesMasterId r:id="rId18"/>
   </p:notesMasterIdLst>
   <p:sldIdLst>
     <p:sldId id="256" r:id="rId2"/>
@@ -21,7 +21,9 @@
     <p:sldId id="266" r:id="rId12"/>
     <p:sldId id="267" r:id="rId13"/>
     <p:sldId id="268" r:id="rId14"/>
-    <p:sldId id="269" r:id="rId15"/>
+    <p:sldId id="270" r:id="rId15"/>
+    <p:sldId id="271" r:id="rId16"/>
+    <p:sldId id="272" r:id="rId17"/>
   </p:sldIdLst>
   <p:sldSz cx="12192000" cy="6858000"/>
   <p:notesSz cx="6858000" cy="9144000"/>
@@ -210,7 +212,7 @@
           <a:p>
             <a:fld id="{40121602-EAA8-4F1C-9FF7-6AF9819ED24A}" type="datetimeFigureOut">
               <a:rPr lang="en-DE" smtClean="0"/>
-              <a:t>15/10/2026</a:t>
+              <a:t>16/10/2026</a:t>
             </a:fld>
             <a:endParaRPr lang="en-DE"/>
           </a:p>
@@ -627,7 +629,7 @@
           <a:p>
             <a:fld id="{8BF61571-DD67-4DB9-828E-8224F49D10F7}" type="datetime8">
               <a:rPr lang="en-DE" smtClean="0"/>
-              <a:t>15/10/2026 03:43</a:t>
+              <a:t>16/10/2026 10:16</a:t>
             </a:fld>
             <a:endParaRPr lang="en-DE"/>
           </a:p>
@@ -827,7 +829,7 @@
           <a:p>
             <a:fld id="{DE1D51F6-4284-4068-A837-7C1D9F8E0C33}" type="datetime8">
               <a:rPr lang="en-DE" smtClean="0"/>
-              <a:t>15/10/2026 03:43</a:t>
+              <a:t>16/10/2026 10:16</a:t>
             </a:fld>
             <a:endParaRPr lang="en-DE"/>
           </a:p>
@@ -1037,7 +1039,7 @@
           <a:p>
             <a:fld id="{B84C5440-5D12-45B5-9174-2FE7550F8EDC}" type="datetime8">
               <a:rPr lang="en-DE" smtClean="0"/>
-              <a:t>15/10/2026 03:43</a:t>
+              <a:t>16/10/2026 10:16</a:t>
             </a:fld>
             <a:endParaRPr lang="en-DE"/>
           </a:p>
@@ -1237,7 +1239,7 @@
           <a:p>
             <a:fld id="{BD762AD5-4B24-4ABD-947C-0B79DD411B70}" type="datetime8">
               <a:rPr lang="en-DE" smtClean="0"/>
-              <a:t>15/10/2026 03:43</a:t>
+              <a:t>16/10/2026 10:16</a:t>
             </a:fld>
             <a:endParaRPr lang="en-DE"/>
           </a:p>
@@ -1513,7 +1515,7 @@
           <a:p>
             <a:fld id="{D700E591-0DD3-4063-9353-B7994991AA26}" type="datetime8">
               <a:rPr lang="en-DE" smtClean="0"/>
-              <a:t>15/10/2026 03:43</a:t>
+              <a:t>16/10/2026 10:16</a:t>
             </a:fld>
             <a:endParaRPr lang="en-DE"/>
           </a:p>
@@ -1781,7 +1783,7 @@
           <a:p>
             <a:fld id="{75E1A21E-E696-4D3A-AC14-818B200362B9}" type="datetime8">
               <a:rPr lang="en-DE" smtClean="0"/>
-              <a:t>15/10/2026 03:43</a:t>
+              <a:t>16/10/2026 10:16</a:t>
             </a:fld>
             <a:endParaRPr lang="en-DE"/>
           </a:p>
@@ -2196,7 +2198,7 @@
           <a:p>
             <a:fld id="{2270BFA8-8A0B-429B-8866-F0F19839FE2A}" type="datetime8">
               <a:rPr lang="en-DE" smtClean="0"/>
-              <a:t>15/10/2026 03:43</a:t>
+              <a:t>16/10/2026 10:16</a:t>
             </a:fld>
             <a:endParaRPr lang="en-DE"/>
           </a:p>
@@ -2338,7 +2340,7 @@
           <a:p>
             <a:fld id="{A6BE2B78-6173-44EE-AA8A-9FDFCD4A202E}" type="datetime8">
               <a:rPr lang="en-DE" smtClean="0"/>
-              <a:t>15/10/2026 03:43</a:t>
+              <a:t>16/10/2026 10:16</a:t>
             </a:fld>
             <a:endParaRPr lang="en-DE"/>
           </a:p>
@@ -2451,7 +2453,7 @@
           <a:p>
             <a:fld id="{0CAC95DE-1BBF-4297-B01A-9D1D0DAB67F7}" type="datetime8">
               <a:rPr lang="en-DE" smtClean="0"/>
-              <a:t>15/10/2026 03:43</a:t>
+              <a:t>16/10/2026 10:16</a:t>
             </a:fld>
             <a:endParaRPr lang="en-DE"/>
           </a:p>
@@ -2764,7 +2766,7 @@
           <a:p>
             <a:fld id="{58BDAB5A-3AF1-455B-B52A-7F093A6F8B11}" type="datetime8">
               <a:rPr lang="en-DE" smtClean="0"/>
-              <a:t>15/10/2026 03:43</a:t>
+              <a:t>16/10/2026 10:16</a:t>
             </a:fld>
             <a:endParaRPr lang="en-DE"/>
           </a:p>
@@ -3053,7 +3055,7 @@
           <a:p>
             <a:fld id="{E2ED3544-4A9A-4482-8049-1F4A5A0FB2CC}" type="datetime8">
               <a:rPr lang="en-DE" smtClean="0"/>
-              <a:t>15/10/2026 03:43</a:t>
+              <a:t>16/10/2026 10:16</a:t>
             </a:fld>
             <a:endParaRPr lang="en-DE"/>
           </a:p>
@@ -3296,7 +3298,7 @@
           <a:p>
             <a:fld id="{F2BFB065-BC28-4C5F-8855-6FB69D25D066}" type="datetime8">
               <a:rPr lang="en-DE" smtClean="0"/>
-              <a:t>15/10/2026 03:43</a:t>
+              <a:t>16/10/2026 10:16</a:t>
             </a:fld>
             <a:endParaRPr lang="en-DE"/>
           </a:p>
@@ -3942,31 +3944,70 @@
           </a:p>
         </p:txBody>
       </p:sp>
-      <p:sp>
-        <p:nvSpPr>
-          <p:cNvPr id="3" name="Content Placeholder 2">
-            <a:extLst>
-              <a:ext uri="{FF2B5EF4-FFF2-40B4-BE49-F238E27FC236}">
-                <a16:creationId xmlns:a16="http://schemas.microsoft.com/office/drawing/2014/main" id="{54B58747-CFA7-E112-C176-EE520E9FDABA}"/>
-              </a:ext>
-            </a:extLst>
-          </p:cNvPr>
-          <p:cNvSpPr>
-            <a:spLocks noGrp="1"/>
-          </p:cNvSpPr>
+      <p:pic>
+        <p:nvPicPr>
+          <p:cNvPr id="5" name="Content Placeholder 4">
+            <a:extLst>
+              <a:ext uri="{FF2B5EF4-FFF2-40B4-BE49-F238E27FC236}">
+                <a16:creationId xmlns:a16="http://schemas.microsoft.com/office/drawing/2014/main" id="{B0A9AACD-98C9-A071-FD4C-C556914ADEBB}"/>
+              </a:ext>
+            </a:extLst>
+          </p:cNvPr>
+          <p:cNvPicPr>
+            <a:picLocks noGrp="1" noChangeAspect="1"/>
+          </p:cNvPicPr>
           <p:nvPr>
             <p:ph idx="1"/>
           </p:nvPr>
-        </p:nvSpPr>
-        <p:spPr/>
-        <p:txBody>
-          <a:bodyPr/>
-          <a:lstStyle/>
-          <a:p>
-            <a:endParaRPr lang="en-DE"/>
-          </a:p>
-        </p:txBody>
-      </p:sp>
+        </p:nvPicPr>
+        <p:blipFill>
+          <a:blip r:embed="rId2"/>
+          <a:srcRect t="21259"/>
+          <a:stretch>
+            <a:fillRect/>
+          </a:stretch>
+        </p:blipFill>
+        <p:spPr>
+          <a:xfrm>
+            <a:off x="1248698" y="2074606"/>
+            <a:ext cx="8878528" cy="1799832"/>
+          </a:xfrm>
+          <a:prstGeom prst="rect">
+            <a:avLst/>
+          </a:prstGeom>
+        </p:spPr>
+      </p:pic>
+      <p:pic>
+        <p:nvPicPr>
+          <p:cNvPr id="6" name="Picture 5">
+            <a:extLst>
+              <a:ext uri="{FF2B5EF4-FFF2-40B4-BE49-F238E27FC236}">
+                <a16:creationId xmlns:a16="http://schemas.microsoft.com/office/drawing/2014/main" id="{261928D2-7C00-C24F-E234-FA43434DE0C2}"/>
+              </a:ext>
+            </a:extLst>
+          </p:cNvPr>
+          <p:cNvPicPr>
+            <a:picLocks noChangeAspect="1"/>
+          </p:cNvPicPr>
+          <p:nvPr/>
+        </p:nvPicPr>
+        <p:blipFill>
+          <a:blip r:embed="rId3"/>
+          <a:srcRect t="13610" b="4104"/>
+          <a:stretch>
+            <a:fillRect/>
+          </a:stretch>
+        </p:blipFill>
+        <p:spPr>
+          <a:xfrm>
+            <a:off x="1248698" y="4258357"/>
+            <a:ext cx="8878528" cy="2083450"/>
+          </a:xfrm>
+          <a:prstGeom prst="rect">
+            <a:avLst/>
+          </a:prstGeom>
+        </p:spPr>
+      </p:pic>
     </p:spTree>
     <p:extLst>
       <p:ext uri="{BB962C8B-B14F-4D97-AF65-F5344CB8AC3E}">
@@ -4038,31 +4079,39 @@
           </a:p>
         </p:txBody>
       </p:sp>
-      <p:sp>
-        <p:nvSpPr>
-          <p:cNvPr id="3" name="Content Placeholder 2">
-            <a:extLst>
-              <a:ext uri="{FF2B5EF4-FFF2-40B4-BE49-F238E27FC236}">
-                <a16:creationId xmlns:a16="http://schemas.microsoft.com/office/drawing/2014/main" id="{A75FA2D4-0CCD-5D46-AA3A-3E285463F9B1}"/>
-              </a:ext>
-            </a:extLst>
-          </p:cNvPr>
-          <p:cNvSpPr>
-            <a:spLocks noGrp="1"/>
-          </p:cNvSpPr>
+      <p:pic>
+        <p:nvPicPr>
+          <p:cNvPr id="9" name="Content Placeholder 8">
+            <a:extLst>
+              <a:ext uri="{FF2B5EF4-FFF2-40B4-BE49-F238E27FC236}">
+                <a16:creationId xmlns:a16="http://schemas.microsoft.com/office/drawing/2014/main" id="{7D436B56-4ED5-5E01-8406-3DB68E1629C2}"/>
+              </a:ext>
+            </a:extLst>
+          </p:cNvPr>
+          <p:cNvPicPr>
+            <a:picLocks noGrp="1" noChangeAspect="1"/>
+          </p:cNvPicPr>
           <p:nvPr>
             <p:ph idx="1"/>
           </p:nvPr>
-        </p:nvSpPr>
-        <p:spPr/>
-        <p:txBody>
-          <a:bodyPr/>
-          <a:lstStyle/>
-          <a:p>
-            <a:endParaRPr lang="en-DE"/>
-          </a:p>
-        </p:txBody>
-      </p:sp>
+        </p:nvPicPr>
+        <p:blipFill>
+          <a:blip r:embed="rId2"/>
+          <a:srcRect t="9300"/>
+          <a:stretch>
+            <a:fillRect/>
+          </a:stretch>
+        </p:blipFill>
+        <p:spPr>
+          <a:xfrm>
+            <a:off x="1134871" y="2094270"/>
+            <a:ext cx="9922258" cy="3936131"/>
+          </a:xfrm>
+          <a:prstGeom prst="rect">
+            <a:avLst/>
+          </a:prstGeom>
+        </p:spPr>
+      </p:pic>
     </p:spTree>
     <p:extLst>
       <p:ext uri="{BB962C8B-B14F-4D97-AF65-F5344CB8AC3E}">
@@ -4125,7 +4174,7 @@
                 <a:latin typeface="XB Niloofar" panose="02000503080000020003" pitchFamily="2" charset="-78"/>
                 <a:cs typeface="XB Niloofar" panose="02000503080000020003" pitchFamily="2" charset="-78"/>
               </a:rPr>
-              <a:t>Synthesis results</a:t>
+              <a:t>SDC Constraints</a:t>
             </a:r>
             <a:endParaRPr lang="en-DE" b="1" dirty="0">
               <a:latin typeface="XB Niloofar" panose="02000503080000020003" pitchFamily="2" charset="-78"/>
@@ -4136,10 +4185,10 @@
       </p:sp>
       <p:sp>
         <p:nvSpPr>
-          <p:cNvPr id="3" name="Content Placeholder 2">
-            <a:extLst>
-              <a:ext uri="{FF2B5EF4-FFF2-40B4-BE49-F238E27FC236}">
-                <a16:creationId xmlns:a16="http://schemas.microsoft.com/office/drawing/2014/main" id="{01B0A543-4335-4890-21B8-D57438E9AB9C}"/>
+          <p:cNvPr id="4" name="Content Placeholder 3">
+            <a:extLst>
+              <a:ext uri="{FF2B5EF4-FFF2-40B4-BE49-F238E27FC236}">
+                <a16:creationId xmlns:a16="http://schemas.microsoft.com/office/drawing/2014/main" id="{BD58DD6D-EBAB-2203-39BF-884CA4594CBE}"/>
               </a:ext>
             </a:extLst>
           </p:cNvPr>
@@ -4147,15 +4196,1422 @@
             <a:spLocks noGrp="1"/>
           </p:cNvSpPr>
           <p:nvPr>
-            <p:ph idx="1"/>
+            <p:ph sz="half" idx="1"/>
           </p:nvPr>
         </p:nvSpPr>
         <p:spPr/>
         <p:txBody>
-          <a:bodyPr/>
+          <a:bodyPr>
+            <a:normAutofit fontScale="40000" lnSpcReduction="20000"/>
+          </a:bodyPr>
           <a:lstStyle/>
           <a:p>
-            <a:endParaRPr lang="en-DE"/>
+            <a:pPr>
+              <a:buFont typeface="XB Niloofar" panose="02000503080000020003" pitchFamily="2" charset="-78"/>
+              <a:buChar char="&gt;"/>
+            </a:pPr>
+            <a:r>
+              <a:rPr lang="en-IN" dirty="0" err="1">
+                <a:latin typeface="XB Niloofar" panose="02000503080000020003" pitchFamily="2" charset="-78"/>
+                <a:cs typeface="XB Niloofar" panose="02000503080000020003" pitchFamily="2" charset="-78"/>
+              </a:rPr>
+              <a:t>create_clock</a:t>
+            </a:r>
+            <a:r>
+              <a:rPr lang="en-IN" dirty="0">
+                <a:latin typeface="XB Niloofar" panose="02000503080000020003" pitchFamily="2" charset="-78"/>
+                <a:cs typeface="XB Niloofar" panose="02000503080000020003" pitchFamily="2" charset="-78"/>
+              </a:rPr>
+              <a:t> -name </a:t>
+            </a:r>
+            <a:r>
+              <a:rPr lang="en-IN" dirty="0" err="1">
+                <a:latin typeface="XB Niloofar" panose="02000503080000020003" pitchFamily="2" charset="-78"/>
+                <a:cs typeface="XB Niloofar" panose="02000503080000020003" pitchFamily="2" charset="-78"/>
+              </a:rPr>
+              <a:t>Clk_Fast</a:t>
+            </a:r>
+            <a:r>
+              <a:rPr lang="en-IN" dirty="0">
+                <a:latin typeface="XB Niloofar" panose="02000503080000020003" pitchFamily="2" charset="-78"/>
+                <a:cs typeface="XB Niloofar" panose="02000503080000020003" pitchFamily="2" charset="-78"/>
+              </a:rPr>
+              <a:t> -period 6.6667 -waveform </a:t>
+            </a:r>
+          </a:p>
+          <a:p>
+            <a:pPr marL="0" indent="0">
+              <a:buNone/>
+            </a:pPr>
+            <a:r>
+              <a:rPr lang="en-IN" dirty="0">
+                <a:latin typeface="XB Niloofar" panose="02000503080000020003" pitchFamily="2" charset="-78"/>
+                <a:cs typeface="XB Niloofar" panose="02000503080000020003" pitchFamily="2" charset="-78"/>
+              </a:rPr>
+              <a:t>		{0 3.3333}  [</a:t>
+            </a:r>
+            <a:r>
+              <a:rPr lang="en-IN" dirty="0" err="1">
+                <a:latin typeface="XB Niloofar" panose="02000503080000020003" pitchFamily="2" charset="-78"/>
+                <a:cs typeface="XB Niloofar" panose="02000503080000020003" pitchFamily="2" charset="-78"/>
+              </a:rPr>
+              <a:t>get_ports</a:t>
+            </a:r>
+            <a:r>
+              <a:rPr lang="en-IN" dirty="0">
+                <a:latin typeface="XB Niloofar" panose="02000503080000020003" pitchFamily="2" charset="-78"/>
+                <a:cs typeface="XB Niloofar" panose="02000503080000020003" pitchFamily="2" charset="-78"/>
+              </a:rPr>
+              <a:t> </a:t>
+            </a:r>
+            <a:r>
+              <a:rPr lang="en-IN" dirty="0" err="1">
+                <a:latin typeface="XB Niloofar" panose="02000503080000020003" pitchFamily="2" charset="-78"/>
+                <a:cs typeface="XB Niloofar" panose="02000503080000020003" pitchFamily="2" charset="-78"/>
+              </a:rPr>
+              <a:t>Clk_Fast</a:t>
+            </a:r>
+            <a:r>
+              <a:rPr lang="en-IN" dirty="0">
+                <a:latin typeface="XB Niloofar" panose="02000503080000020003" pitchFamily="2" charset="-78"/>
+                <a:cs typeface="XB Niloofar" panose="02000503080000020003" pitchFamily="2" charset="-78"/>
+              </a:rPr>
+              <a:t>]</a:t>
+            </a:r>
+            <a:endParaRPr lang="en-DE" dirty="0">
+              <a:latin typeface="XB Niloofar" panose="02000503080000020003" pitchFamily="2" charset="-78"/>
+              <a:cs typeface="XB Niloofar" panose="02000503080000020003" pitchFamily="2" charset="-78"/>
+            </a:endParaRPr>
+          </a:p>
+          <a:p>
+            <a:pPr>
+              <a:buFont typeface="XB Niloofar" panose="02000503080000020003" pitchFamily="2" charset="-78"/>
+              <a:buChar char="&gt;"/>
+            </a:pPr>
+            <a:r>
+              <a:rPr lang="en-IN" dirty="0" err="1">
+                <a:latin typeface="XB Niloofar" panose="02000503080000020003" pitchFamily="2" charset="-78"/>
+                <a:cs typeface="XB Niloofar" panose="02000503080000020003" pitchFamily="2" charset="-78"/>
+              </a:rPr>
+              <a:t>create_clock</a:t>
+            </a:r>
+            <a:r>
+              <a:rPr lang="en-IN" dirty="0">
+                <a:latin typeface="XB Niloofar" panose="02000503080000020003" pitchFamily="2" charset="-78"/>
+                <a:cs typeface="XB Niloofar" panose="02000503080000020003" pitchFamily="2" charset="-78"/>
+              </a:rPr>
+              <a:t> -name </a:t>
+            </a:r>
+            <a:r>
+              <a:rPr lang="en-IN" dirty="0" err="1">
+                <a:latin typeface="XB Niloofar" panose="02000503080000020003" pitchFamily="2" charset="-78"/>
+                <a:cs typeface="XB Niloofar" panose="02000503080000020003" pitchFamily="2" charset="-78"/>
+              </a:rPr>
+              <a:t>Clk_Slow</a:t>
+            </a:r>
+            <a:r>
+              <a:rPr lang="en-IN" dirty="0">
+                <a:latin typeface="XB Niloofar" panose="02000503080000020003" pitchFamily="2" charset="-78"/>
+                <a:cs typeface="XB Niloofar" panose="02000503080000020003" pitchFamily="2" charset="-78"/>
+              </a:rPr>
+              <a:t> -period 14.2857 –</a:t>
+            </a:r>
+          </a:p>
+          <a:p>
+            <a:pPr marL="0" indent="0">
+              <a:buNone/>
+            </a:pPr>
+            <a:r>
+              <a:rPr lang="en-IN" dirty="0">
+                <a:latin typeface="XB Niloofar" panose="02000503080000020003" pitchFamily="2" charset="-78"/>
+                <a:cs typeface="XB Niloofar" panose="02000503080000020003" pitchFamily="2" charset="-78"/>
+              </a:rPr>
+              <a:t>	\waveform {0 7.1429} [</a:t>
+            </a:r>
+            <a:r>
+              <a:rPr lang="en-IN" dirty="0" err="1">
+                <a:latin typeface="XB Niloofar" panose="02000503080000020003" pitchFamily="2" charset="-78"/>
+                <a:cs typeface="XB Niloofar" panose="02000503080000020003" pitchFamily="2" charset="-78"/>
+              </a:rPr>
+              <a:t>get_ports</a:t>
+            </a:r>
+            <a:r>
+              <a:rPr lang="en-IN" dirty="0">
+                <a:latin typeface="XB Niloofar" panose="02000503080000020003" pitchFamily="2" charset="-78"/>
+                <a:cs typeface="XB Niloofar" panose="02000503080000020003" pitchFamily="2" charset="-78"/>
+              </a:rPr>
+              <a:t> </a:t>
+            </a:r>
+            <a:r>
+              <a:rPr lang="en-IN" dirty="0" err="1">
+                <a:latin typeface="XB Niloofar" panose="02000503080000020003" pitchFamily="2" charset="-78"/>
+                <a:cs typeface="XB Niloofar" panose="02000503080000020003" pitchFamily="2" charset="-78"/>
+              </a:rPr>
+              <a:t>Clk_Slow</a:t>
+            </a:r>
+            <a:r>
+              <a:rPr lang="en-IN" dirty="0">
+                <a:latin typeface="XB Niloofar" panose="02000503080000020003" pitchFamily="2" charset="-78"/>
+                <a:cs typeface="XB Niloofar" panose="02000503080000020003" pitchFamily="2" charset="-78"/>
+              </a:rPr>
+              <a:t>]</a:t>
+            </a:r>
+            <a:endParaRPr lang="en-DE" dirty="0">
+              <a:latin typeface="XB Niloofar" panose="02000503080000020003" pitchFamily="2" charset="-78"/>
+              <a:cs typeface="XB Niloofar" panose="02000503080000020003" pitchFamily="2" charset="-78"/>
+            </a:endParaRPr>
+          </a:p>
+          <a:p>
+            <a:pPr>
+              <a:buFont typeface="XB Niloofar" panose="02000503080000020003" pitchFamily="2" charset="-78"/>
+              <a:buChar char="&gt;"/>
+            </a:pPr>
+            <a:r>
+              <a:rPr lang="en-IN" dirty="0" err="1">
+                <a:latin typeface="XB Niloofar" panose="02000503080000020003" pitchFamily="2" charset="-78"/>
+                <a:cs typeface="XB Niloofar" panose="02000503080000020003" pitchFamily="2" charset="-78"/>
+              </a:rPr>
+              <a:t>set_clock_uncertainty</a:t>
+            </a:r>
+            <a:r>
+              <a:rPr lang="en-IN" dirty="0">
+                <a:latin typeface="XB Niloofar" panose="02000503080000020003" pitchFamily="2" charset="-78"/>
+                <a:cs typeface="XB Niloofar" panose="02000503080000020003" pitchFamily="2" charset="-78"/>
+              </a:rPr>
+              <a:t> -setup 0.20 [</a:t>
+            </a:r>
+            <a:r>
+              <a:rPr lang="en-IN" dirty="0" err="1">
+                <a:latin typeface="XB Niloofar" panose="02000503080000020003" pitchFamily="2" charset="-78"/>
+                <a:cs typeface="XB Niloofar" panose="02000503080000020003" pitchFamily="2" charset="-78"/>
+              </a:rPr>
+              <a:t>get_clocks</a:t>
+            </a:r>
+            <a:r>
+              <a:rPr lang="en-IN" dirty="0">
+                <a:latin typeface="XB Niloofar" panose="02000503080000020003" pitchFamily="2" charset="-78"/>
+                <a:cs typeface="XB Niloofar" panose="02000503080000020003" pitchFamily="2" charset="-78"/>
+              </a:rPr>
+              <a:t> </a:t>
+            </a:r>
+            <a:r>
+              <a:rPr lang="en-IN" dirty="0" err="1">
+                <a:latin typeface="XB Niloofar" panose="02000503080000020003" pitchFamily="2" charset="-78"/>
+                <a:cs typeface="XB Niloofar" panose="02000503080000020003" pitchFamily="2" charset="-78"/>
+              </a:rPr>
+              <a:t>Clk_Fast</a:t>
+            </a:r>
+            <a:r>
+              <a:rPr lang="en-IN" dirty="0">
+                <a:latin typeface="XB Niloofar" panose="02000503080000020003" pitchFamily="2" charset="-78"/>
+                <a:cs typeface="XB Niloofar" panose="02000503080000020003" pitchFamily="2" charset="-78"/>
+              </a:rPr>
+              <a:t>]</a:t>
+            </a:r>
+            <a:endParaRPr lang="en-DE" dirty="0">
+              <a:latin typeface="XB Niloofar" panose="02000503080000020003" pitchFamily="2" charset="-78"/>
+              <a:cs typeface="XB Niloofar" panose="02000503080000020003" pitchFamily="2" charset="-78"/>
+            </a:endParaRPr>
+          </a:p>
+          <a:p>
+            <a:pPr>
+              <a:buFont typeface="XB Niloofar" panose="02000503080000020003" pitchFamily="2" charset="-78"/>
+              <a:buChar char="&gt;"/>
+            </a:pPr>
+            <a:r>
+              <a:rPr lang="en-IN" dirty="0" err="1">
+                <a:latin typeface="XB Niloofar" panose="02000503080000020003" pitchFamily="2" charset="-78"/>
+                <a:cs typeface="XB Niloofar" panose="02000503080000020003" pitchFamily="2" charset="-78"/>
+              </a:rPr>
+              <a:t>set_clock_uncertainty</a:t>
+            </a:r>
+            <a:r>
+              <a:rPr lang="en-IN" dirty="0">
+                <a:latin typeface="XB Niloofar" panose="02000503080000020003" pitchFamily="2" charset="-78"/>
+                <a:cs typeface="XB Niloofar" panose="02000503080000020003" pitchFamily="2" charset="-78"/>
+              </a:rPr>
+              <a:t> -hold  0.10 [</a:t>
+            </a:r>
+            <a:r>
+              <a:rPr lang="en-IN" dirty="0" err="1">
+                <a:latin typeface="XB Niloofar" panose="02000503080000020003" pitchFamily="2" charset="-78"/>
+                <a:cs typeface="XB Niloofar" panose="02000503080000020003" pitchFamily="2" charset="-78"/>
+              </a:rPr>
+              <a:t>get_clocks</a:t>
+            </a:r>
+            <a:r>
+              <a:rPr lang="en-IN" dirty="0">
+                <a:latin typeface="XB Niloofar" panose="02000503080000020003" pitchFamily="2" charset="-78"/>
+                <a:cs typeface="XB Niloofar" panose="02000503080000020003" pitchFamily="2" charset="-78"/>
+              </a:rPr>
+              <a:t> </a:t>
+            </a:r>
+            <a:r>
+              <a:rPr lang="en-IN" dirty="0" err="1">
+                <a:latin typeface="XB Niloofar" panose="02000503080000020003" pitchFamily="2" charset="-78"/>
+                <a:cs typeface="XB Niloofar" panose="02000503080000020003" pitchFamily="2" charset="-78"/>
+              </a:rPr>
+              <a:t>Clk_Fast</a:t>
+            </a:r>
+            <a:r>
+              <a:rPr lang="en-IN" dirty="0">
+                <a:latin typeface="XB Niloofar" panose="02000503080000020003" pitchFamily="2" charset="-78"/>
+                <a:cs typeface="XB Niloofar" panose="02000503080000020003" pitchFamily="2" charset="-78"/>
+              </a:rPr>
+              <a:t>]</a:t>
+            </a:r>
+            <a:endParaRPr lang="en-DE" dirty="0">
+              <a:latin typeface="XB Niloofar" panose="02000503080000020003" pitchFamily="2" charset="-78"/>
+              <a:cs typeface="XB Niloofar" panose="02000503080000020003" pitchFamily="2" charset="-78"/>
+            </a:endParaRPr>
+          </a:p>
+          <a:p>
+            <a:pPr>
+              <a:buFont typeface="XB Niloofar" panose="02000503080000020003" pitchFamily="2" charset="-78"/>
+              <a:buChar char="&gt;"/>
+            </a:pPr>
+            <a:r>
+              <a:rPr lang="en-IN" dirty="0" err="1">
+                <a:latin typeface="XB Niloofar" panose="02000503080000020003" pitchFamily="2" charset="-78"/>
+                <a:cs typeface="XB Niloofar" panose="02000503080000020003" pitchFamily="2" charset="-78"/>
+              </a:rPr>
+              <a:t>set_clock_uncertainty</a:t>
+            </a:r>
+            <a:r>
+              <a:rPr lang="en-IN" dirty="0">
+                <a:latin typeface="XB Niloofar" panose="02000503080000020003" pitchFamily="2" charset="-78"/>
+                <a:cs typeface="XB Niloofar" panose="02000503080000020003" pitchFamily="2" charset="-78"/>
+              </a:rPr>
+              <a:t> -setup 0.40 [</a:t>
+            </a:r>
+            <a:r>
+              <a:rPr lang="en-IN" dirty="0" err="1">
+                <a:latin typeface="XB Niloofar" panose="02000503080000020003" pitchFamily="2" charset="-78"/>
+                <a:cs typeface="XB Niloofar" panose="02000503080000020003" pitchFamily="2" charset="-78"/>
+              </a:rPr>
+              <a:t>get_clocks</a:t>
+            </a:r>
+            <a:r>
+              <a:rPr lang="en-IN" dirty="0">
+                <a:latin typeface="XB Niloofar" panose="02000503080000020003" pitchFamily="2" charset="-78"/>
+                <a:cs typeface="XB Niloofar" panose="02000503080000020003" pitchFamily="2" charset="-78"/>
+              </a:rPr>
+              <a:t> </a:t>
+            </a:r>
+            <a:r>
+              <a:rPr lang="en-IN" dirty="0" err="1">
+                <a:latin typeface="XB Niloofar" panose="02000503080000020003" pitchFamily="2" charset="-78"/>
+                <a:cs typeface="XB Niloofar" panose="02000503080000020003" pitchFamily="2" charset="-78"/>
+              </a:rPr>
+              <a:t>Clk_Slow</a:t>
+            </a:r>
+            <a:r>
+              <a:rPr lang="en-IN" dirty="0">
+                <a:latin typeface="XB Niloofar" panose="02000503080000020003" pitchFamily="2" charset="-78"/>
+                <a:cs typeface="XB Niloofar" panose="02000503080000020003" pitchFamily="2" charset="-78"/>
+              </a:rPr>
+              <a:t>]</a:t>
+            </a:r>
+            <a:endParaRPr lang="en-DE" dirty="0">
+              <a:latin typeface="XB Niloofar" panose="02000503080000020003" pitchFamily="2" charset="-78"/>
+              <a:cs typeface="XB Niloofar" panose="02000503080000020003" pitchFamily="2" charset="-78"/>
+            </a:endParaRPr>
+          </a:p>
+          <a:p>
+            <a:pPr>
+              <a:buFont typeface="XB Niloofar" panose="02000503080000020003" pitchFamily="2" charset="-78"/>
+              <a:buChar char="&gt;"/>
+            </a:pPr>
+            <a:r>
+              <a:rPr lang="en-IN" dirty="0" err="1">
+                <a:latin typeface="XB Niloofar" panose="02000503080000020003" pitchFamily="2" charset="-78"/>
+                <a:cs typeface="XB Niloofar" panose="02000503080000020003" pitchFamily="2" charset="-78"/>
+              </a:rPr>
+              <a:t>set_clock_uncertainty</a:t>
+            </a:r>
+            <a:r>
+              <a:rPr lang="en-IN" dirty="0">
+                <a:latin typeface="XB Niloofar" panose="02000503080000020003" pitchFamily="2" charset="-78"/>
+                <a:cs typeface="XB Niloofar" panose="02000503080000020003" pitchFamily="2" charset="-78"/>
+              </a:rPr>
+              <a:t> -hold  0.30 [</a:t>
+            </a:r>
+            <a:r>
+              <a:rPr lang="en-IN" dirty="0" err="1">
+                <a:latin typeface="XB Niloofar" panose="02000503080000020003" pitchFamily="2" charset="-78"/>
+                <a:cs typeface="XB Niloofar" panose="02000503080000020003" pitchFamily="2" charset="-78"/>
+              </a:rPr>
+              <a:t>get_clocks</a:t>
+            </a:r>
+            <a:r>
+              <a:rPr lang="en-IN" dirty="0">
+                <a:latin typeface="XB Niloofar" panose="02000503080000020003" pitchFamily="2" charset="-78"/>
+                <a:cs typeface="XB Niloofar" panose="02000503080000020003" pitchFamily="2" charset="-78"/>
+              </a:rPr>
+              <a:t> </a:t>
+            </a:r>
+            <a:r>
+              <a:rPr lang="en-IN" dirty="0" err="1">
+                <a:latin typeface="XB Niloofar" panose="02000503080000020003" pitchFamily="2" charset="-78"/>
+                <a:cs typeface="XB Niloofar" panose="02000503080000020003" pitchFamily="2" charset="-78"/>
+              </a:rPr>
+              <a:t>Clk_Slow</a:t>
+            </a:r>
+            <a:r>
+              <a:rPr lang="en-IN" dirty="0">
+                <a:latin typeface="XB Niloofar" panose="02000503080000020003" pitchFamily="2" charset="-78"/>
+                <a:cs typeface="XB Niloofar" panose="02000503080000020003" pitchFamily="2" charset="-78"/>
+              </a:rPr>
+              <a:t>]</a:t>
+            </a:r>
+            <a:endParaRPr lang="en-DE" dirty="0">
+              <a:latin typeface="XB Niloofar" panose="02000503080000020003" pitchFamily="2" charset="-78"/>
+              <a:cs typeface="XB Niloofar" panose="02000503080000020003" pitchFamily="2" charset="-78"/>
+            </a:endParaRPr>
+          </a:p>
+          <a:p>
+            <a:pPr>
+              <a:buFont typeface="XB Niloofar" panose="02000503080000020003" pitchFamily="2" charset="-78"/>
+              <a:buChar char="&gt;"/>
+            </a:pPr>
+            <a:r>
+              <a:rPr lang="en-IN" dirty="0" err="1">
+                <a:latin typeface="XB Niloofar" panose="02000503080000020003" pitchFamily="2" charset="-78"/>
+                <a:cs typeface="XB Niloofar" panose="02000503080000020003" pitchFamily="2" charset="-78"/>
+              </a:rPr>
+              <a:t>set_clock_latency</a:t>
+            </a:r>
+            <a:r>
+              <a:rPr lang="en-IN" dirty="0">
+                <a:latin typeface="XB Niloofar" panose="02000503080000020003" pitchFamily="2" charset="-78"/>
+                <a:cs typeface="XB Niloofar" panose="02000503080000020003" pitchFamily="2" charset="-78"/>
+              </a:rPr>
+              <a:t>    -source 0.5 [</a:t>
+            </a:r>
+            <a:r>
+              <a:rPr lang="en-IN" dirty="0" err="1">
+                <a:latin typeface="XB Niloofar" panose="02000503080000020003" pitchFamily="2" charset="-78"/>
+                <a:cs typeface="XB Niloofar" panose="02000503080000020003" pitchFamily="2" charset="-78"/>
+              </a:rPr>
+              <a:t>get_clocks</a:t>
+            </a:r>
+            <a:r>
+              <a:rPr lang="en-IN" dirty="0">
+                <a:latin typeface="XB Niloofar" panose="02000503080000020003" pitchFamily="2" charset="-78"/>
+                <a:cs typeface="XB Niloofar" panose="02000503080000020003" pitchFamily="2" charset="-78"/>
+              </a:rPr>
+              <a:t> </a:t>
+            </a:r>
+            <a:r>
+              <a:rPr lang="en-IN" dirty="0" err="1">
+                <a:latin typeface="XB Niloofar" panose="02000503080000020003" pitchFamily="2" charset="-78"/>
+                <a:cs typeface="XB Niloofar" panose="02000503080000020003" pitchFamily="2" charset="-78"/>
+              </a:rPr>
+              <a:t>Clk_Fast</a:t>
+            </a:r>
+            <a:r>
+              <a:rPr lang="en-IN" dirty="0">
+                <a:latin typeface="XB Niloofar" panose="02000503080000020003" pitchFamily="2" charset="-78"/>
+                <a:cs typeface="XB Niloofar" panose="02000503080000020003" pitchFamily="2" charset="-78"/>
+              </a:rPr>
+              <a:t>]</a:t>
+            </a:r>
+            <a:endParaRPr lang="en-DE" dirty="0">
+              <a:latin typeface="XB Niloofar" panose="02000503080000020003" pitchFamily="2" charset="-78"/>
+              <a:cs typeface="XB Niloofar" panose="02000503080000020003" pitchFamily="2" charset="-78"/>
+            </a:endParaRPr>
+          </a:p>
+          <a:p>
+            <a:pPr>
+              <a:buFont typeface="XB Niloofar" panose="02000503080000020003" pitchFamily="2" charset="-78"/>
+              <a:buChar char="&gt;"/>
+            </a:pPr>
+            <a:r>
+              <a:rPr lang="en-IN" dirty="0" err="1">
+                <a:latin typeface="XB Niloofar" panose="02000503080000020003" pitchFamily="2" charset="-78"/>
+                <a:cs typeface="XB Niloofar" panose="02000503080000020003" pitchFamily="2" charset="-78"/>
+              </a:rPr>
+              <a:t>set_clock_latency</a:t>
+            </a:r>
+            <a:r>
+              <a:rPr lang="en-IN" dirty="0">
+                <a:latin typeface="XB Niloofar" panose="02000503080000020003" pitchFamily="2" charset="-78"/>
+                <a:cs typeface="XB Niloofar" panose="02000503080000020003" pitchFamily="2" charset="-78"/>
+              </a:rPr>
+              <a:t>    -source 0.5 [</a:t>
+            </a:r>
+            <a:r>
+              <a:rPr lang="en-IN" dirty="0" err="1">
+                <a:latin typeface="XB Niloofar" panose="02000503080000020003" pitchFamily="2" charset="-78"/>
+                <a:cs typeface="XB Niloofar" panose="02000503080000020003" pitchFamily="2" charset="-78"/>
+              </a:rPr>
+              <a:t>get_clocks</a:t>
+            </a:r>
+            <a:r>
+              <a:rPr lang="en-IN" dirty="0">
+                <a:latin typeface="XB Niloofar" panose="02000503080000020003" pitchFamily="2" charset="-78"/>
+                <a:cs typeface="XB Niloofar" panose="02000503080000020003" pitchFamily="2" charset="-78"/>
+              </a:rPr>
+              <a:t> </a:t>
+            </a:r>
+            <a:r>
+              <a:rPr lang="en-IN" dirty="0" err="1">
+                <a:latin typeface="XB Niloofar" panose="02000503080000020003" pitchFamily="2" charset="-78"/>
+                <a:cs typeface="XB Niloofar" panose="02000503080000020003" pitchFamily="2" charset="-78"/>
+              </a:rPr>
+              <a:t>Clk_Slow</a:t>
+            </a:r>
+            <a:r>
+              <a:rPr lang="en-IN" dirty="0">
+                <a:latin typeface="XB Niloofar" panose="02000503080000020003" pitchFamily="2" charset="-78"/>
+                <a:cs typeface="XB Niloofar" panose="02000503080000020003" pitchFamily="2" charset="-78"/>
+              </a:rPr>
+              <a:t>]</a:t>
+            </a:r>
+            <a:endParaRPr lang="en-DE" dirty="0">
+              <a:latin typeface="XB Niloofar" panose="02000503080000020003" pitchFamily="2" charset="-78"/>
+              <a:cs typeface="XB Niloofar" panose="02000503080000020003" pitchFamily="2" charset="-78"/>
+            </a:endParaRPr>
+          </a:p>
+          <a:p>
+            <a:pPr>
+              <a:buFont typeface="XB Niloofar" panose="02000503080000020003" pitchFamily="2" charset="-78"/>
+              <a:buChar char="&gt;"/>
+            </a:pPr>
+            <a:r>
+              <a:rPr lang="en-IN" dirty="0" err="1">
+                <a:latin typeface="XB Niloofar" panose="02000503080000020003" pitchFamily="2" charset="-78"/>
+                <a:cs typeface="XB Niloofar" panose="02000503080000020003" pitchFamily="2" charset="-78"/>
+              </a:rPr>
+              <a:t>set_clock_transition</a:t>
+            </a:r>
+            <a:r>
+              <a:rPr lang="en-IN" dirty="0">
+                <a:latin typeface="XB Niloofar" panose="02000503080000020003" pitchFamily="2" charset="-78"/>
+                <a:cs typeface="XB Niloofar" panose="02000503080000020003" pitchFamily="2" charset="-78"/>
+              </a:rPr>
+              <a:t> 0.10        [</a:t>
+            </a:r>
+            <a:r>
+              <a:rPr lang="en-IN" dirty="0" err="1">
+                <a:latin typeface="XB Niloofar" panose="02000503080000020003" pitchFamily="2" charset="-78"/>
+                <a:cs typeface="XB Niloofar" panose="02000503080000020003" pitchFamily="2" charset="-78"/>
+              </a:rPr>
+              <a:t>get_clocks</a:t>
+            </a:r>
+            <a:r>
+              <a:rPr lang="en-IN" dirty="0">
+                <a:latin typeface="XB Niloofar" panose="02000503080000020003" pitchFamily="2" charset="-78"/>
+                <a:cs typeface="XB Niloofar" panose="02000503080000020003" pitchFamily="2" charset="-78"/>
+              </a:rPr>
+              <a:t> </a:t>
+            </a:r>
+            <a:r>
+              <a:rPr lang="en-IN" dirty="0" err="1">
+                <a:latin typeface="XB Niloofar" panose="02000503080000020003" pitchFamily="2" charset="-78"/>
+                <a:cs typeface="XB Niloofar" panose="02000503080000020003" pitchFamily="2" charset="-78"/>
+              </a:rPr>
+              <a:t>Clk_Fast</a:t>
+            </a:r>
+            <a:r>
+              <a:rPr lang="en-IN" dirty="0">
+                <a:latin typeface="XB Niloofar" panose="02000503080000020003" pitchFamily="2" charset="-78"/>
+                <a:cs typeface="XB Niloofar" panose="02000503080000020003" pitchFamily="2" charset="-78"/>
+              </a:rPr>
+              <a:t>]</a:t>
+            </a:r>
+            <a:endParaRPr lang="en-DE" dirty="0">
+              <a:latin typeface="XB Niloofar" panose="02000503080000020003" pitchFamily="2" charset="-78"/>
+              <a:cs typeface="XB Niloofar" panose="02000503080000020003" pitchFamily="2" charset="-78"/>
+            </a:endParaRPr>
+          </a:p>
+          <a:p>
+            <a:pPr>
+              <a:buFont typeface="XB Niloofar" panose="02000503080000020003" pitchFamily="2" charset="-78"/>
+              <a:buChar char="&gt;"/>
+            </a:pPr>
+            <a:r>
+              <a:rPr lang="en-IN" dirty="0" err="1">
+                <a:latin typeface="XB Niloofar" panose="02000503080000020003" pitchFamily="2" charset="-78"/>
+                <a:cs typeface="XB Niloofar" panose="02000503080000020003" pitchFamily="2" charset="-78"/>
+              </a:rPr>
+              <a:t>set_clock_transition</a:t>
+            </a:r>
+            <a:r>
+              <a:rPr lang="en-IN" dirty="0">
+                <a:latin typeface="XB Niloofar" panose="02000503080000020003" pitchFamily="2" charset="-78"/>
+                <a:cs typeface="XB Niloofar" panose="02000503080000020003" pitchFamily="2" charset="-78"/>
+              </a:rPr>
+              <a:t> 0.15        [</a:t>
+            </a:r>
+            <a:r>
+              <a:rPr lang="en-IN" dirty="0" err="1">
+                <a:latin typeface="XB Niloofar" panose="02000503080000020003" pitchFamily="2" charset="-78"/>
+                <a:cs typeface="XB Niloofar" panose="02000503080000020003" pitchFamily="2" charset="-78"/>
+              </a:rPr>
+              <a:t>get_clocks</a:t>
+            </a:r>
+            <a:r>
+              <a:rPr lang="en-IN" dirty="0">
+                <a:latin typeface="XB Niloofar" panose="02000503080000020003" pitchFamily="2" charset="-78"/>
+                <a:cs typeface="XB Niloofar" panose="02000503080000020003" pitchFamily="2" charset="-78"/>
+              </a:rPr>
+              <a:t> </a:t>
+            </a:r>
+            <a:r>
+              <a:rPr lang="en-IN" dirty="0" err="1">
+                <a:latin typeface="XB Niloofar" panose="02000503080000020003" pitchFamily="2" charset="-78"/>
+                <a:cs typeface="XB Niloofar" panose="02000503080000020003" pitchFamily="2" charset="-78"/>
+              </a:rPr>
+              <a:t>Clk_Slow</a:t>
+            </a:r>
+            <a:r>
+              <a:rPr lang="en-IN" dirty="0">
+                <a:latin typeface="XB Niloofar" panose="02000503080000020003" pitchFamily="2" charset="-78"/>
+                <a:cs typeface="XB Niloofar" panose="02000503080000020003" pitchFamily="2" charset="-78"/>
+              </a:rPr>
+              <a:t>]</a:t>
+            </a:r>
+          </a:p>
+          <a:p>
+            <a:pPr>
+              <a:buFont typeface="XB Niloofar" panose="02000503080000020003" pitchFamily="2" charset="-78"/>
+              <a:buChar char="&gt;"/>
+            </a:pPr>
+            <a:r>
+              <a:rPr lang="en-IN" dirty="0" err="1">
+                <a:latin typeface="XB Niloofar" panose="02000503080000020003" pitchFamily="2" charset="-78"/>
+                <a:cs typeface="XB Niloofar" panose="02000503080000020003" pitchFamily="2" charset="-78"/>
+              </a:rPr>
+              <a:t>set_clock_groups</a:t>
+            </a:r>
+            <a:r>
+              <a:rPr lang="en-IN" dirty="0">
+                <a:latin typeface="XB Niloofar" panose="02000503080000020003" pitchFamily="2" charset="-78"/>
+                <a:cs typeface="XB Niloofar" panose="02000503080000020003" pitchFamily="2" charset="-78"/>
+              </a:rPr>
+              <a:t> -asynchronous  -group [</a:t>
+            </a:r>
+            <a:r>
+              <a:rPr lang="en-IN" dirty="0" err="1">
+                <a:latin typeface="XB Niloofar" panose="02000503080000020003" pitchFamily="2" charset="-78"/>
+                <a:cs typeface="XB Niloofar" panose="02000503080000020003" pitchFamily="2" charset="-78"/>
+              </a:rPr>
+              <a:t>get_clocks</a:t>
+            </a:r>
+            <a:r>
+              <a:rPr lang="en-IN" dirty="0">
+                <a:latin typeface="XB Niloofar" panose="02000503080000020003" pitchFamily="2" charset="-78"/>
+                <a:cs typeface="XB Niloofar" panose="02000503080000020003" pitchFamily="2" charset="-78"/>
+              </a:rPr>
+              <a:t> </a:t>
+            </a:r>
+            <a:r>
+              <a:rPr lang="en-IN" dirty="0" err="1">
+                <a:latin typeface="XB Niloofar" panose="02000503080000020003" pitchFamily="2" charset="-78"/>
+                <a:cs typeface="XB Niloofar" panose="02000503080000020003" pitchFamily="2" charset="-78"/>
+              </a:rPr>
+              <a:t>Clk_Fast</a:t>
+            </a:r>
+            <a:r>
+              <a:rPr lang="en-IN" dirty="0">
+                <a:latin typeface="XB Niloofar" panose="02000503080000020003" pitchFamily="2" charset="-78"/>
+                <a:cs typeface="XB Niloofar" panose="02000503080000020003" pitchFamily="2" charset="-78"/>
+              </a:rPr>
+              <a:t>] </a:t>
+            </a:r>
+          </a:p>
+          <a:p>
+            <a:pPr marL="0" indent="0">
+              <a:buNone/>
+            </a:pPr>
+            <a:r>
+              <a:rPr lang="en-IN" dirty="0">
+                <a:latin typeface="XB Niloofar" panose="02000503080000020003" pitchFamily="2" charset="-78"/>
+                <a:cs typeface="XB Niloofar" panose="02000503080000020003" pitchFamily="2" charset="-78"/>
+              </a:rPr>
+              <a:t>		\  -group [</a:t>
+            </a:r>
+            <a:r>
+              <a:rPr lang="en-IN" dirty="0" err="1">
+                <a:latin typeface="XB Niloofar" panose="02000503080000020003" pitchFamily="2" charset="-78"/>
+                <a:cs typeface="XB Niloofar" panose="02000503080000020003" pitchFamily="2" charset="-78"/>
+              </a:rPr>
+              <a:t>get_clocks</a:t>
+            </a:r>
+            <a:r>
+              <a:rPr lang="en-IN" dirty="0">
+                <a:latin typeface="XB Niloofar" panose="02000503080000020003" pitchFamily="2" charset="-78"/>
+                <a:cs typeface="XB Niloofar" panose="02000503080000020003" pitchFamily="2" charset="-78"/>
+              </a:rPr>
+              <a:t> </a:t>
+            </a:r>
+            <a:r>
+              <a:rPr lang="en-IN" dirty="0" err="1">
+                <a:latin typeface="XB Niloofar" panose="02000503080000020003" pitchFamily="2" charset="-78"/>
+                <a:cs typeface="XB Niloofar" panose="02000503080000020003" pitchFamily="2" charset="-78"/>
+              </a:rPr>
+              <a:t>Clk_Slow</a:t>
+            </a:r>
+            <a:r>
+              <a:rPr lang="en-IN" dirty="0">
+                <a:latin typeface="XB Niloofar" panose="02000503080000020003" pitchFamily="2" charset="-78"/>
+                <a:cs typeface="XB Niloofar" panose="02000503080000020003" pitchFamily="2" charset="-78"/>
+              </a:rPr>
+              <a:t>]</a:t>
+            </a:r>
+            <a:endParaRPr lang="en-DE" dirty="0">
+              <a:latin typeface="XB Niloofar" panose="02000503080000020003" pitchFamily="2" charset="-78"/>
+              <a:cs typeface="XB Niloofar" panose="02000503080000020003" pitchFamily="2" charset="-78"/>
+            </a:endParaRPr>
+          </a:p>
+          <a:p>
+            <a:pPr>
+              <a:buFont typeface="XB Niloofar" panose="02000503080000020003" pitchFamily="2" charset="-78"/>
+              <a:buChar char="&gt;"/>
+            </a:pPr>
+            <a:r>
+              <a:rPr lang="en-IN" dirty="0" err="1">
+                <a:latin typeface="XB Niloofar" panose="02000503080000020003" pitchFamily="2" charset="-78"/>
+                <a:cs typeface="XB Niloofar" panose="02000503080000020003" pitchFamily="2" charset="-78"/>
+              </a:rPr>
+              <a:t>set_false_path</a:t>
+            </a:r>
+            <a:r>
+              <a:rPr lang="en-IN" dirty="0">
+                <a:latin typeface="XB Niloofar" panose="02000503080000020003" pitchFamily="2" charset="-78"/>
+                <a:cs typeface="XB Niloofar" panose="02000503080000020003" pitchFamily="2" charset="-78"/>
+              </a:rPr>
+              <a:t> -from [</a:t>
+            </a:r>
+            <a:r>
+              <a:rPr lang="en-IN" dirty="0" err="1">
+                <a:latin typeface="XB Niloofar" panose="02000503080000020003" pitchFamily="2" charset="-78"/>
+                <a:cs typeface="XB Niloofar" panose="02000503080000020003" pitchFamily="2" charset="-78"/>
+              </a:rPr>
+              <a:t>get_ports</a:t>
+            </a:r>
+            <a:r>
+              <a:rPr lang="en-IN" dirty="0">
+                <a:latin typeface="XB Niloofar" panose="02000503080000020003" pitchFamily="2" charset="-78"/>
+                <a:cs typeface="XB Niloofar" panose="02000503080000020003" pitchFamily="2" charset="-78"/>
+              </a:rPr>
+              <a:t> </a:t>
+            </a:r>
+            <a:r>
+              <a:rPr lang="en-IN" dirty="0" err="1">
+                <a:latin typeface="XB Niloofar" panose="02000503080000020003" pitchFamily="2" charset="-78"/>
+                <a:cs typeface="XB Niloofar" panose="02000503080000020003" pitchFamily="2" charset="-78"/>
+              </a:rPr>
+              <a:t>Rst</a:t>
+            </a:r>
+            <a:r>
+              <a:rPr lang="en-IN" dirty="0">
+                <a:latin typeface="XB Niloofar" panose="02000503080000020003" pitchFamily="2" charset="-78"/>
+                <a:cs typeface="XB Niloofar" panose="02000503080000020003" pitchFamily="2" charset="-78"/>
+              </a:rPr>
+              <a:t>]</a:t>
+            </a:r>
+            <a:endParaRPr lang="en-DE" dirty="0">
+              <a:latin typeface="XB Niloofar" panose="02000503080000020003" pitchFamily="2" charset="-78"/>
+              <a:cs typeface="XB Niloofar" panose="02000503080000020003" pitchFamily="2" charset="-78"/>
+            </a:endParaRPr>
+          </a:p>
+        </p:txBody>
+      </p:sp>
+      <p:sp>
+        <p:nvSpPr>
+          <p:cNvPr id="5" name="Content Placeholder 4">
+            <a:extLst>
+              <a:ext uri="{FF2B5EF4-FFF2-40B4-BE49-F238E27FC236}">
+                <a16:creationId xmlns:a16="http://schemas.microsoft.com/office/drawing/2014/main" id="{5D181573-CAD3-2EDC-38FE-137FAFED88E4}"/>
+              </a:ext>
+            </a:extLst>
+          </p:cNvPr>
+          <p:cNvSpPr>
+            <a:spLocks noGrp="1"/>
+          </p:cNvSpPr>
+          <p:nvPr>
+            <p:ph sz="half" idx="2"/>
+          </p:nvPr>
+        </p:nvSpPr>
+        <p:spPr/>
+        <p:txBody>
+          <a:bodyPr>
+            <a:normAutofit fontScale="40000" lnSpcReduction="20000"/>
+          </a:bodyPr>
+          <a:lstStyle/>
+          <a:p>
+            <a:pPr>
+              <a:buFont typeface="XB Niloofar" panose="02000503080000020003" pitchFamily="2" charset="-78"/>
+              <a:buChar char="&gt;"/>
+            </a:pPr>
+            <a:r>
+              <a:rPr lang="en-IN" sz="2700" dirty="0" err="1">
+                <a:latin typeface="XB Niloofar" panose="02000503080000020003" pitchFamily="2" charset="-78"/>
+                <a:cs typeface="XB Niloofar" panose="02000503080000020003" pitchFamily="2" charset="-78"/>
+              </a:rPr>
+              <a:t>set_input_delay</a:t>
+            </a:r>
+            <a:r>
+              <a:rPr lang="en-IN" sz="2700" dirty="0">
+                <a:latin typeface="XB Niloofar" panose="02000503080000020003" pitchFamily="2" charset="-78"/>
+                <a:cs typeface="XB Niloofar" panose="02000503080000020003" pitchFamily="2" charset="-78"/>
+              </a:rPr>
+              <a:t> -clock </a:t>
+            </a:r>
+            <a:r>
+              <a:rPr lang="en-IN" sz="2700" dirty="0" err="1">
+                <a:latin typeface="XB Niloofar" panose="02000503080000020003" pitchFamily="2" charset="-78"/>
+                <a:cs typeface="XB Niloofar" panose="02000503080000020003" pitchFamily="2" charset="-78"/>
+              </a:rPr>
+              <a:t>Clk_Fast</a:t>
+            </a:r>
+            <a:r>
+              <a:rPr lang="en-IN" sz="2700" dirty="0">
+                <a:latin typeface="XB Niloofar" panose="02000503080000020003" pitchFamily="2" charset="-78"/>
+                <a:cs typeface="XB Niloofar" panose="02000503080000020003" pitchFamily="2" charset="-78"/>
+              </a:rPr>
+              <a:t> -max 2.2 </a:t>
+            </a:r>
+          </a:p>
+          <a:p>
+            <a:pPr marL="0" indent="0">
+              <a:buNone/>
+            </a:pPr>
+            <a:r>
+              <a:rPr lang="en-IN" sz="2700" dirty="0">
+                <a:latin typeface="XB Niloofar" panose="02000503080000020003" pitchFamily="2" charset="-78"/>
+                <a:cs typeface="XB Niloofar" panose="02000503080000020003" pitchFamily="2" charset="-78"/>
+              </a:rPr>
+              <a:t>	\[</a:t>
+            </a:r>
+            <a:r>
+              <a:rPr lang="en-IN" sz="2700" dirty="0" err="1">
+                <a:latin typeface="XB Niloofar" panose="02000503080000020003" pitchFamily="2" charset="-78"/>
+                <a:cs typeface="XB Niloofar" panose="02000503080000020003" pitchFamily="2" charset="-78"/>
+              </a:rPr>
+              <a:t>get_ports</a:t>
+            </a:r>
+            <a:r>
+              <a:rPr lang="en-IN" sz="2700" dirty="0">
+                <a:latin typeface="XB Niloofar" panose="02000503080000020003" pitchFamily="2" charset="-78"/>
+                <a:cs typeface="XB Niloofar" panose="02000503080000020003" pitchFamily="2" charset="-78"/>
+              </a:rPr>
+              <a:t> {Prog_Data[*]}]</a:t>
+            </a:r>
+            <a:endParaRPr lang="en-DE" sz="2700" dirty="0">
+              <a:latin typeface="XB Niloofar" panose="02000503080000020003" pitchFamily="2" charset="-78"/>
+              <a:cs typeface="XB Niloofar" panose="02000503080000020003" pitchFamily="2" charset="-78"/>
+            </a:endParaRPr>
+          </a:p>
+          <a:p>
+            <a:pPr>
+              <a:buFont typeface="XB Niloofar" panose="02000503080000020003" pitchFamily="2" charset="-78"/>
+              <a:buChar char="&gt;"/>
+            </a:pPr>
+            <a:r>
+              <a:rPr lang="en-IN" sz="2700" dirty="0" err="1">
+                <a:latin typeface="XB Niloofar" panose="02000503080000020003" pitchFamily="2" charset="-78"/>
+                <a:cs typeface="XB Niloofar" panose="02000503080000020003" pitchFamily="2" charset="-78"/>
+              </a:rPr>
+              <a:t>set_input_delay</a:t>
+            </a:r>
+            <a:r>
+              <a:rPr lang="en-IN" sz="2700" dirty="0">
+                <a:latin typeface="XB Niloofar" panose="02000503080000020003" pitchFamily="2" charset="-78"/>
+                <a:cs typeface="XB Niloofar" panose="02000503080000020003" pitchFamily="2" charset="-78"/>
+              </a:rPr>
+              <a:t> -clock </a:t>
+            </a:r>
+            <a:r>
+              <a:rPr lang="en-IN" sz="2700" dirty="0" err="1">
+                <a:latin typeface="XB Niloofar" panose="02000503080000020003" pitchFamily="2" charset="-78"/>
+                <a:cs typeface="XB Niloofar" panose="02000503080000020003" pitchFamily="2" charset="-78"/>
+              </a:rPr>
+              <a:t>Clk_Fast</a:t>
+            </a:r>
+            <a:r>
+              <a:rPr lang="en-IN" sz="2700" dirty="0">
+                <a:latin typeface="XB Niloofar" panose="02000503080000020003" pitchFamily="2" charset="-78"/>
+                <a:cs typeface="XB Niloofar" panose="02000503080000020003" pitchFamily="2" charset="-78"/>
+              </a:rPr>
+              <a:t> -min 1.0 </a:t>
+            </a:r>
+          </a:p>
+          <a:p>
+            <a:pPr marL="0" indent="0">
+              <a:buNone/>
+            </a:pPr>
+            <a:r>
+              <a:rPr lang="en-IN" sz="2700" dirty="0">
+                <a:latin typeface="XB Niloofar" panose="02000503080000020003" pitchFamily="2" charset="-78"/>
+                <a:cs typeface="XB Niloofar" panose="02000503080000020003" pitchFamily="2" charset="-78"/>
+              </a:rPr>
+              <a:t>	\[</a:t>
+            </a:r>
+            <a:r>
+              <a:rPr lang="en-IN" sz="2700" dirty="0" err="1">
+                <a:latin typeface="XB Niloofar" panose="02000503080000020003" pitchFamily="2" charset="-78"/>
+                <a:cs typeface="XB Niloofar" panose="02000503080000020003" pitchFamily="2" charset="-78"/>
+              </a:rPr>
+              <a:t>get_ports</a:t>
+            </a:r>
+            <a:r>
+              <a:rPr lang="en-IN" sz="2700" dirty="0">
+                <a:latin typeface="XB Niloofar" panose="02000503080000020003" pitchFamily="2" charset="-78"/>
+                <a:cs typeface="XB Niloofar" panose="02000503080000020003" pitchFamily="2" charset="-78"/>
+              </a:rPr>
+              <a:t> {Prog_Data[*]}]</a:t>
+            </a:r>
+            <a:endParaRPr lang="en-DE" sz="2700" dirty="0">
+              <a:latin typeface="XB Niloofar" panose="02000503080000020003" pitchFamily="2" charset="-78"/>
+              <a:cs typeface="XB Niloofar" panose="02000503080000020003" pitchFamily="2" charset="-78"/>
+            </a:endParaRPr>
+          </a:p>
+          <a:p>
+            <a:pPr>
+              <a:buFont typeface="XB Niloofar" panose="02000503080000020003" pitchFamily="2" charset="-78"/>
+              <a:buChar char="&gt;"/>
+            </a:pPr>
+            <a:r>
+              <a:rPr lang="en-IN" sz="2700" dirty="0" err="1">
+                <a:latin typeface="XB Niloofar" panose="02000503080000020003" pitchFamily="2" charset="-78"/>
+                <a:cs typeface="XB Niloofar" panose="02000503080000020003" pitchFamily="2" charset="-78"/>
+              </a:rPr>
+              <a:t>set_input_delay</a:t>
+            </a:r>
+            <a:r>
+              <a:rPr lang="en-IN" sz="2700" dirty="0">
+                <a:latin typeface="XB Niloofar" panose="02000503080000020003" pitchFamily="2" charset="-78"/>
+                <a:cs typeface="XB Niloofar" panose="02000503080000020003" pitchFamily="2" charset="-78"/>
+              </a:rPr>
+              <a:t> -clock </a:t>
+            </a:r>
+            <a:r>
+              <a:rPr lang="en-IN" sz="2700" dirty="0" err="1">
+                <a:latin typeface="XB Niloofar" panose="02000503080000020003" pitchFamily="2" charset="-78"/>
+                <a:cs typeface="XB Niloofar" panose="02000503080000020003" pitchFamily="2" charset="-78"/>
+              </a:rPr>
+              <a:t>Clk_Slow</a:t>
+            </a:r>
+            <a:r>
+              <a:rPr lang="en-IN" sz="2700" dirty="0">
+                <a:latin typeface="XB Niloofar" panose="02000503080000020003" pitchFamily="2" charset="-78"/>
+                <a:cs typeface="XB Niloofar" panose="02000503080000020003" pitchFamily="2" charset="-78"/>
+              </a:rPr>
+              <a:t> -max 2.0 </a:t>
+            </a:r>
+          </a:p>
+          <a:p>
+            <a:pPr marL="0" indent="0">
+              <a:buNone/>
+            </a:pPr>
+            <a:r>
+              <a:rPr lang="en-IN" sz="2700" dirty="0">
+                <a:latin typeface="XB Niloofar" panose="02000503080000020003" pitchFamily="2" charset="-78"/>
+                <a:cs typeface="XB Niloofar" panose="02000503080000020003" pitchFamily="2" charset="-78"/>
+              </a:rPr>
+              <a:t>	\[</a:t>
+            </a:r>
+            <a:r>
+              <a:rPr lang="en-IN" sz="2700" dirty="0" err="1">
+                <a:latin typeface="XB Niloofar" panose="02000503080000020003" pitchFamily="2" charset="-78"/>
+                <a:cs typeface="XB Niloofar" panose="02000503080000020003" pitchFamily="2" charset="-78"/>
+              </a:rPr>
+              <a:t>get_ports</a:t>
+            </a:r>
+            <a:r>
+              <a:rPr lang="en-IN" sz="2700" dirty="0">
+                <a:latin typeface="XB Niloofar" panose="02000503080000020003" pitchFamily="2" charset="-78"/>
+                <a:cs typeface="XB Niloofar" panose="02000503080000020003" pitchFamily="2" charset="-78"/>
+              </a:rPr>
+              <a:t> {</a:t>
+            </a:r>
+            <a:r>
+              <a:rPr lang="en-IN" sz="2700" dirty="0" err="1">
+                <a:latin typeface="XB Niloofar" panose="02000503080000020003" pitchFamily="2" charset="-78"/>
+                <a:cs typeface="XB Niloofar" panose="02000503080000020003" pitchFamily="2" charset="-78"/>
+              </a:rPr>
+              <a:t>Data_Rd_Data</a:t>
+            </a:r>
+            <a:r>
+              <a:rPr lang="en-IN" sz="2700" dirty="0">
+                <a:latin typeface="XB Niloofar" panose="02000503080000020003" pitchFamily="2" charset="-78"/>
+                <a:cs typeface="XB Niloofar" panose="02000503080000020003" pitchFamily="2" charset="-78"/>
+              </a:rPr>
+              <a:t>[*]}]</a:t>
+            </a:r>
+            <a:endParaRPr lang="en-DE" sz="2700" dirty="0">
+              <a:latin typeface="XB Niloofar" panose="02000503080000020003" pitchFamily="2" charset="-78"/>
+              <a:cs typeface="XB Niloofar" panose="02000503080000020003" pitchFamily="2" charset="-78"/>
+            </a:endParaRPr>
+          </a:p>
+          <a:p>
+            <a:pPr>
+              <a:buFont typeface="XB Niloofar" panose="02000503080000020003" pitchFamily="2" charset="-78"/>
+              <a:buChar char="&gt;"/>
+            </a:pPr>
+            <a:r>
+              <a:rPr lang="en-IN" sz="2700" dirty="0" err="1">
+                <a:latin typeface="XB Niloofar" panose="02000503080000020003" pitchFamily="2" charset="-78"/>
+                <a:cs typeface="XB Niloofar" panose="02000503080000020003" pitchFamily="2" charset="-78"/>
+              </a:rPr>
+              <a:t>set_input_delay</a:t>
+            </a:r>
+            <a:r>
+              <a:rPr lang="en-IN" sz="2700" dirty="0">
+                <a:latin typeface="XB Niloofar" panose="02000503080000020003" pitchFamily="2" charset="-78"/>
+                <a:cs typeface="XB Niloofar" panose="02000503080000020003" pitchFamily="2" charset="-78"/>
+              </a:rPr>
+              <a:t> -clock </a:t>
+            </a:r>
+            <a:r>
+              <a:rPr lang="en-IN" sz="2700" dirty="0" err="1">
+                <a:latin typeface="XB Niloofar" panose="02000503080000020003" pitchFamily="2" charset="-78"/>
+                <a:cs typeface="XB Niloofar" panose="02000503080000020003" pitchFamily="2" charset="-78"/>
+              </a:rPr>
+              <a:t>Clk_Slow</a:t>
+            </a:r>
+            <a:r>
+              <a:rPr lang="en-IN" sz="2700" dirty="0">
+                <a:latin typeface="XB Niloofar" panose="02000503080000020003" pitchFamily="2" charset="-78"/>
+                <a:cs typeface="XB Niloofar" panose="02000503080000020003" pitchFamily="2" charset="-78"/>
+              </a:rPr>
+              <a:t> -min 1.0 </a:t>
+            </a:r>
+          </a:p>
+          <a:p>
+            <a:pPr marL="0" indent="0">
+              <a:buNone/>
+            </a:pPr>
+            <a:r>
+              <a:rPr lang="en-IN" sz="2700" dirty="0">
+                <a:latin typeface="XB Niloofar" panose="02000503080000020003" pitchFamily="2" charset="-78"/>
+                <a:cs typeface="XB Niloofar" panose="02000503080000020003" pitchFamily="2" charset="-78"/>
+              </a:rPr>
+              <a:t>	\[</a:t>
+            </a:r>
+            <a:r>
+              <a:rPr lang="en-IN" sz="2700" dirty="0" err="1">
+                <a:latin typeface="XB Niloofar" panose="02000503080000020003" pitchFamily="2" charset="-78"/>
+                <a:cs typeface="XB Niloofar" panose="02000503080000020003" pitchFamily="2" charset="-78"/>
+              </a:rPr>
+              <a:t>get_ports</a:t>
+            </a:r>
+            <a:r>
+              <a:rPr lang="en-IN" sz="2700" dirty="0">
+                <a:latin typeface="XB Niloofar" panose="02000503080000020003" pitchFamily="2" charset="-78"/>
+                <a:cs typeface="XB Niloofar" panose="02000503080000020003" pitchFamily="2" charset="-78"/>
+              </a:rPr>
+              <a:t> {</a:t>
+            </a:r>
+            <a:r>
+              <a:rPr lang="en-IN" sz="2700" dirty="0" err="1">
+                <a:latin typeface="XB Niloofar" panose="02000503080000020003" pitchFamily="2" charset="-78"/>
+                <a:cs typeface="XB Niloofar" panose="02000503080000020003" pitchFamily="2" charset="-78"/>
+              </a:rPr>
+              <a:t>Data_Rd_Data</a:t>
+            </a:r>
+            <a:r>
+              <a:rPr lang="en-IN" sz="2700" dirty="0">
+                <a:latin typeface="XB Niloofar" panose="02000503080000020003" pitchFamily="2" charset="-78"/>
+                <a:cs typeface="XB Niloofar" panose="02000503080000020003" pitchFamily="2" charset="-78"/>
+              </a:rPr>
+              <a:t>[*]}]</a:t>
+            </a:r>
+            <a:endParaRPr lang="en-DE" sz="2700" dirty="0">
+              <a:latin typeface="XB Niloofar" panose="02000503080000020003" pitchFamily="2" charset="-78"/>
+              <a:cs typeface="XB Niloofar" panose="02000503080000020003" pitchFamily="2" charset="-78"/>
+            </a:endParaRPr>
+          </a:p>
+          <a:p>
+            <a:pPr>
+              <a:buFont typeface="XB Niloofar" panose="02000503080000020003" pitchFamily="2" charset="-78"/>
+              <a:buChar char="&gt;"/>
+            </a:pPr>
+            <a:r>
+              <a:rPr lang="en-IN" sz="2700" dirty="0" err="1">
+                <a:latin typeface="XB Niloofar" panose="02000503080000020003" pitchFamily="2" charset="-78"/>
+                <a:cs typeface="XB Niloofar" panose="02000503080000020003" pitchFamily="2" charset="-78"/>
+              </a:rPr>
+              <a:t>set_output_delay</a:t>
+            </a:r>
+            <a:r>
+              <a:rPr lang="en-IN" sz="2700" dirty="0">
+                <a:latin typeface="XB Niloofar" panose="02000503080000020003" pitchFamily="2" charset="-78"/>
+                <a:cs typeface="XB Niloofar" panose="02000503080000020003" pitchFamily="2" charset="-78"/>
+              </a:rPr>
+              <a:t> -clock </a:t>
+            </a:r>
+            <a:r>
+              <a:rPr lang="en-IN" sz="2700" dirty="0" err="1">
+                <a:latin typeface="XB Niloofar" panose="02000503080000020003" pitchFamily="2" charset="-78"/>
+                <a:cs typeface="XB Niloofar" panose="02000503080000020003" pitchFamily="2" charset="-78"/>
+              </a:rPr>
+              <a:t>Clk_Fast</a:t>
+            </a:r>
+            <a:r>
+              <a:rPr lang="en-IN" sz="2700" dirty="0">
+                <a:latin typeface="XB Niloofar" panose="02000503080000020003" pitchFamily="2" charset="-78"/>
+                <a:cs typeface="XB Niloofar" panose="02000503080000020003" pitchFamily="2" charset="-78"/>
+              </a:rPr>
+              <a:t> -max 2.0 </a:t>
+            </a:r>
+          </a:p>
+          <a:p>
+            <a:pPr marL="0" indent="0">
+              <a:buNone/>
+            </a:pPr>
+            <a:r>
+              <a:rPr lang="en-IN" sz="2700" dirty="0">
+                <a:latin typeface="XB Niloofar" panose="02000503080000020003" pitchFamily="2" charset="-78"/>
+                <a:cs typeface="XB Niloofar" panose="02000503080000020003" pitchFamily="2" charset="-78"/>
+              </a:rPr>
+              <a:t>	\[</a:t>
+            </a:r>
+            <a:r>
+              <a:rPr lang="en-IN" sz="2700" dirty="0" err="1">
+                <a:latin typeface="XB Niloofar" panose="02000503080000020003" pitchFamily="2" charset="-78"/>
+                <a:cs typeface="XB Niloofar" panose="02000503080000020003" pitchFamily="2" charset="-78"/>
+              </a:rPr>
+              <a:t>get_ports</a:t>
+            </a:r>
+            <a:r>
+              <a:rPr lang="en-IN" sz="2700" dirty="0">
+                <a:latin typeface="XB Niloofar" panose="02000503080000020003" pitchFamily="2" charset="-78"/>
+                <a:cs typeface="XB Niloofar" panose="02000503080000020003" pitchFamily="2" charset="-78"/>
+              </a:rPr>
+              <a:t> {Halted </a:t>
+            </a:r>
+            <a:r>
+              <a:rPr lang="en-IN" sz="2700" dirty="0" err="1">
+                <a:latin typeface="XB Niloofar" panose="02000503080000020003" pitchFamily="2" charset="-78"/>
+                <a:cs typeface="XB Niloofar" panose="02000503080000020003" pitchFamily="2" charset="-78"/>
+              </a:rPr>
+              <a:t>Prog_Addr</a:t>
+            </a:r>
+            <a:r>
+              <a:rPr lang="en-IN" sz="2700" dirty="0">
+                <a:latin typeface="XB Niloofar" panose="02000503080000020003" pitchFamily="2" charset="-78"/>
+                <a:cs typeface="XB Niloofar" panose="02000503080000020003" pitchFamily="2" charset="-78"/>
+              </a:rPr>
+              <a:t>[*]}]</a:t>
+            </a:r>
+            <a:endParaRPr lang="en-DE" sz="2700" dirty="0">
+              <a:latin typeface="XB Niloofar" panose="02000503080000020003" pitchFamily="2" charset="-78"/>
+              <a:cs typeface="XB Niloofar" panose="02000503080000020003" pitchFamily="2" charset="-78"/>
+            </a:endParaRPr>
+          </a:p>
+          <a:p>
+            <a:pPr>
+              <a:buFont typeface="XB Niloofar" panose="02000503080000020003" pitchFamily="2" charset="-78"/>
+              <a:buChar char="&gt;"/>
+            </a:pPr>
+            <a:r>
+              <a:rPr lang="en-IN" sz="2700" dirty="0" err="1">
+                <a:latin typeface="XB Niloofar" panose="02000503080000020003" pitchFamily="2" charset="-78"/>
+                <a:cs typeface="XB Niloofar" panose="02000503080000020003" pitchFamily="2" charset="-78"/>
+              </a:rPr>
+              <a:t>set_output_delay</a:t>
+            </a:r>
+            <a:r>
+              <a:rPr lang="en-IN" sz="2700" dirty="0">
+                <a:latin typeface="XB Niloofar" panose="02000503080000020003" pitchFamily="2" charset="-78"/>
+                <a:cs typeface="XB Niloofar" panose="02000503080000020003" pitchFamily="2" charset="-78"/>
+              </a:rPr>
+              <a:t> -clock </a:t>
+            </a:r>
+            <a:r>
+              <a:rPr lang="en-IN" sz="2700" dirty="0" err="1">
+                <a:latin typeface="XB Niloofar" panose="02000503080000020003" pitchFamily="2" charset="-78"/>
+                <a:cs typeface="XB Niloofar" panose="02000503080000020003" pitchFamily="2" charset="-78"/>
+              </a:rPr>
+              <a:t>Clk_Fast</a:t>
+            </a:r>
+            <a:r>
+              <a:rPr lang="en-IN" sz="2700" dirty="0">
+                <a:latin typeface="XB Niloofar" panose="02000503080000020003" pitchFamily="2" charset="-78"/>
+                <a:cs typeface="XB Niloofar" panose="02000503080000020003" pitchFamily="2" charset="-78"/>
+              </a:rPr>
+              <a:t> -min 0.5 [</a:t>
+            </a:r>
+            <a:r>
+              <a:rPr lang="en-IN" sz="2700" dirty="0" err="1">
+                <a:latin typeface="XB Niloofar" panose="02000503080000020003" pitchFamily="2" charset="-78"/>
+                <a:cs typeface="XB Niloofar" panose="02000503080000020003" pitchFamily="2" charset="-78"/>
+              </a:rPr>
+              <a:t>get_ports</a:t>
+            </a:r>
+            <a:r>
+              <a:rPr lang="en-IN" sz="2700" dirty="0">
+                <a:latin typeface="XB Niloofar" panose="02000503080000020003" pitchFamily="2" charset="-78"/>
+                <a:cs typeface="XB Niloofar" panose="02000503080000020003" pitchFamily="2" charset="-78"/>
+              </a:rPr>
+              <a:t> {Halted </a:t>
+            </a:r>
+            <a:r>
+              <a:rPr lang="en-IN" sz="2700" dirty="0" err="1">
+                <a:latin typeface="XB Niloofar" panose="02000503080000020003" pitchFamily="2" charset="-78"/>
+                <a:cs typeface="XB Niloofar" panose="02000503080000020003" pitchFamily="2" charset="-78"/>
+              </a:rPr>
+              <a:t>Prog_Addr</a:t>
+            </a:r>
+            <a:r>
+              <a:rPr lang="en-IN" sz="2700" dirty="0">
+                <a:latin typeface="XB Niloofar" panose="02000503080000020003" pitchFamily="2" charset="-78"/>
+                <a:cs typeface="XB Niloofar" panose="02000503080000020003" pitchFamily="2" charset="-78"/>
+              </a:rPr>
+              <a:t>[*]}]</a:t>
+            </a:r>
+            <a:endParaRPr lang="en-DE" sz="2700" dirty="0">
+              <a:latin typeface="XB Niloofar" panose="02000503080000020003" pitchFamily="2" charset="-78"/>
+              <a:cs typeface="XB Niloofar" panose="02000503080000020003" pitchFamily="2" charset="-78"/>
+            </a:endParaRPr>
+          </a:p>
+          <a:p>
+            <a:pPr>
+              <a:buFont typeface="XB Niloofar" panose="02000503080000020003" pitchFamily="2" charset="-78"/>
+              <a:buChar char="&gt;"/>
+            </a:pPr>
+            <a:r>
+              <a:rPr lang="en-IN" sz="2700" dirty="0" err="1">
+                <a:latin typeface="XB Niloofar" panose="02000503080000020003" pitchFamily="2" charset="-78"/>
+                <a:cs typeface="XB Niloofar" panose="02000503080000020003" pitchFamily="2" charset="-78"/>
+              </a:rPr>
+              <a:t>set_output_delay</a:t>
+            </a:r>
+            <a:r>
+              <a:rPr lang="en-IN" sz="2700" dirty="0">
+                <a:latin typeface="XB Niloofar" panose="02000503080000020003" pitchFamily="2" charset="-78"/>
+                <a:cs typeface="XB Niloofar" panose="02000503080000020003" pitchFamily="2" charset="-78"/>
+              </a:rPr>
+              <a:t> -clock </a:t>
+            </a:r>
+            <a:r>
+              <a:rPr lang="en-IN" sz="2700" dirty="0" err="1">
+                <a:latin typeface="XB Niloofar" panose="02000503080000020003" pitchFamily="2" charset="-78"/>
+                <a:cs typeface="XB Niloofar" panose="02000503080000020003" pitchFamily="2" charset="-78"/>
+              </a:rPr>
+              <a:t>Clk_Slow</a:t>
+            </a:r>
+            <a:r>
+              <a:rPr lang="en-IN" sz="2700" dirty="0">
+                <a:latin typeface="XB Niloofar" panose="02000503080000020003" pitchFamily="2" charset="-78"/>
+                <a:cs typeface="XB Niloofar" panose="02000503080000020003" pitchFamily="2" charset="-78"/>
+              </a:rPr>
+              <a:t> -max 4.0 \</a:t>
+            </a:r>
+          </a:p>
+          <a:p>
+            <a:pPr marL="0" indent="0">
+              <a:buNone/>
+            </a:pPr>
+            <a:r>
+              <a:rPr lang="en-IN" sz="2700" dirty="0">
+                <a:latin typeface="XB Niloofar" panose="02000503080000020003" pitchFamily="2" charset="-78"/>
+                <a:cs typeface="XB Niloofar" panose="02000503080000020003" pitchFamily="2" charset="-78"/>
+              </a:rPr>
+              <a:t>                [</a:t>
+            </a:r>
+            <a:r>
+              <a:rPr lang="en-IN" sz="2700" dirty="0" err="1">
+                <a:latin typeface="XB Niloofar" panose="02000503080000020003" pitchFamily="2" charset="-78"/>
+                <a:cs typeface="XB Niloofar" panose="02000503080000020003" pitchFamily="2" charset="-78"/>
+              </a:rPr>
+              <a:t>get_ports</a:t>
+            </a:r>
+            <a:r>
+              <a:rPr lang="en-IN" sz="2700" dirty="0">
+                <a:latin typeface="XB Niloofar" panose="02000503080000020003" pitchFamily="2" charset="-78"/>
+                <a:cs typeface="XB Niloofar" panose="02000503080000020003" pitchFamily="2" charset="-78"/>
+              </a:rPr>
+              <a:t> {</a:t>
+            </a:r>
+            <a:r>
+              <a:rPr lang="en-IN" sz="2700" dirty="0" err="1">
+                <a:latin typeface="XB Niloofar" panose="02000503080000020003" pitchFamily="2" charset="-78"/>
+                <a:cs typeface="XB Niloofar" panose="02000503080000020003" pitchFamily="2" charset="-78"/>
+              </a:rPr>
+              <a:t>Data_Wr_En</a:t>
+            </a:r>
+            <a:r>
+              <a:rPr lang="en-IN" sz="2700" dirty="0">
+                <a:latin typeface="XB Niloofar" panose="02000503080000020003" pitchFamily="2" charset="-78"/>
+                <a:cs typeface="XB Niloofar" panose="02000503080000020003" pitchFamily="2" charset="-78"/>
+              </a:rPr>
+              <a:t> </a:t>
+            </a:r>
+            <a:r>
+              <a:rPr lang="en-IN" sz="2700" dirty="0" err="1">
+                <a:latin typeface="XB Niloofar" panose="02000503080000020003" pitchFamily="2" charset="-78"/>
+                <a:cs typeface="XB Niloofar" panose="02000503080000020003" pitchFamily="2" charset="-78"/>
+              </a:rPr>
+              <a:t>Data_Rd_En</a:t>
+            </a:r>
+            <a:r>
+              <a:rPr lang="en-IN" sz="2700" dirty="0">
+                <a:latin typeface="XB Niloofar" panose="02000503080000020003" pitchFamily="2" charset="-78"/>
+                <a:cs typeface="XB Niloofar" panose="02000503080000020003" pitchFamily="2" charset="-78"/>
+              </a:rPr>
+              <a:t> </a:t>
+            </a:r>
+            <a:r>
+              <a:rPr lang="en-IN" sz="2700" dirty="0" err="1">
+                <a:latin typeface="XB Niloofar" panose="02000503080000020003" pitchFamily="2" charset="-78"/>
+                <a:cs typeface="XB Niloofar" panose="02000503080000020003" pitchFamily="2" charset="-78"/>
+              </a:rPr>
+              <a:t>Data_Addr</a:t>
+            </a:r>
+            <a:r>
+              <a:rPr lang="en-IN" sz="2700" dirty="0">
+                <a:latin typeface="XB Niloofar" panose="02000503080000020003" pitchFamily="2" charset="-78"/>
+                <a:cs typeface="XB Niloofar" panose="02000503080000020003" pitchFamily="2" charset="-78"/>
+              </a:rPr>
+              <a:t>[*] </a:t>
+            </a:r>
+            <a:r>
+              <a:rPr lang="en-IN" sz="2700" dirty="0" err="1">
+                <a:latin typeface="XB Niloofar" panose="02000503080000020003" pitchFamily="2" charset="-78"/>
+                <a:cs typeface="XB Niloofar" panose="02000503080000020003" pitchFamily="2" charset="-78"/>
+              </a:rPr>
+              <a:t>Data_Wr_Data</a:t>
+            </a:r>
+            <a:r>
+              <a:rPr lang="en-IN" sz="2700" dirty="0">
+                <a:latin typeface="XB Niloofar" panose="02000503080000020003" pitchFamily="2" charset="-78"/>
+                <a:cs typeface="XB Niloofar" panose="02000503080000020003" pitchFamily="2" charset="-78"/>
+              </a:rPr>
+              <a:t>[*]}]</a:t>
+            </a:r>
+            <a:endParaRPr lang="en-DE" sz="2700" dirty="0">
+              <a:latin typeface="XB Niloofar" panose="02000503080000020003" pitchFamily="2" charset="-78"/>
+              <a:cs typeface="XB Niloofar" panose="02000503080000020003" pitchFamily="2" charset="-78"/>
+            </a:endParaRPr>
+          </a:p>
+          <a:p>
+            <a:pPr>
+              <a:buFont typeface="XB Niloofar" panose="02000503080000020003" pitchFamily="2" charset="-78"/>
+              <a:buChar char="&gt;"/>
+            </a:pPr>
+            <a:r>
+              <a:rPr lang="en-IN" sz="2700" dirty="0" err="1">
+                <a:latin typeface="XB Niloofar" panose="02000503080000020003" pitchFamily="2" charset="-78"/>
+                <a:cs typeface="XB Niloofar" panose="02000503080000020003" pitchFamily="2" charset="-78"/>
+              </a:rPr>
+              <a:t>set_output_delay</a:t>
+            </a:r>
+            <a:r>
+              <a:rPr lang="en-IN" sz="2700" dirty="0">
+                <a:latin typeface="XB Niloofar" panose="02000503080000020003" pitchFamily="2" charset="-78"/>
+                <a:cs typeface="XB Niloofar" panose="02000503080000020003" pitchFamily="2" charset="-78"/>
+              </a:rPr>
+              <a:t> -clock </a:t>
+            </a:r>
+            <a:r>
+              <a:rPr lang="en-IN" sz="2700" dirty="0" err="1">
+                <a:latin typeface="XB Niloofar" panose="02000503080000020003" pitchFamily="2" charset="-78"/>
+                <a:cs typeface="XB Niloofar" panose="02000503080000020003" pitchFamily="2" charset="-78"/>
+              </a:rPr>
+              <a:t>Clk_Slow</a:t>
+            </a:r>
+            <a:r>
+              <a:rPr lang="en-IN" sz="2700" dirty="0">
+                <a:latin typeface="XB Niloofar" panose="02000503080000020003" pitchFamily="2" charset="-78"/>
+                <a:cs typeface="XB Niloofar" panose="02000503080000020003" pitchFamily="2" charset="-78"/>
+              </a:rPr>
+              <a:t> -min 0.5 \</a:t>
+            </a:r>
+            <a:endParaRPr lang="en-DE" sz="2700" dirty="0">
+              <a:latin typeface="XB Niloofar" panose="02000503080000020003" pitchFamily="2" charset="-78"/>
+              <a:cs typeface="XB Niloofar" panose="02000503080000020003" pitchFamily="2" charset="-78"/>
+            </a:endParaRPr>
+          </a:p>
+          <a:p>
+            <a:pPr marL="0" indent="0">
+              <a:buNone/>
+            </a:pPr>
+            <a:r>
+              <a:rPr lang="en-IN" sz="2700" dirty="0">
+                <a:latin typeface="XB Niloofar" panose="02000503080000020003" pitchFamily="2" charset="-78"/>
+                <a:cs typeface="XB Niloofar" panose="02000503080000020003" pitchFamily="2" charset="-78"/>
+              </a:rPr>
+              <a:t>                [</a:t>
+            </a:r>
+            <a:r>
+              <a:rPr lang="en-IN" sz="2700" dirty="0" err="1">
+                <a:latin typeface="XB Niloofar" panose="02000503080000020003" pitchFamily="2" charset="-78"/>
+                <a:cs typeface="XB Niloofar" panose="02000503080000020003" pitchFamily="2" charset="-78"/>
+              </a:rPr>
+              <a:t>get_ports</a:t>
+            </a:r>
+            <a:r>
+              <a:rPr lang="en-IN" sz="2700" dirty="0">
+                <a:latin typeface="XB Niloofar" panose="02000503080000020003" pitchFamily="2" charset="-78"/>
+                <a:cs typeface="XB Niloofar" panose="02000503080000020003" pitchFamily="2" charset="-78"/>
+              </a:rPr>
+              <a:t> {</a:t>
+            </a:r>
+            <a:r>
+              <a:rPr lang="en-IN" sz="2700" dirty="0" err="1">
+                <a:latin typeface="XB Niloofar" panose="02000503080000020003" pitchFamily="2" charset="-78"/>
+                <a:cs typeface="XB Niloofar" panose="02000503080000020003" pitchFamily="2" charset="-78"/>
+              </a:rPr>
+              <a:t>Data_Wr_En</a:t>
+            </a:r>
+            <a:r>
+              <a:rPr lang="en-IN" sz="2700" dirty="0">
+                <a:latin typeface="XB Niloofar" panose="02000503080000020003" pitchFamily="2" charset="-78"/>
+                <a:cs typeface="XB Niloofar" panose="02000503080000020003" pitchFamily="2" charset="-78"/>
+              </a:rPr>
+              <a:t> </a:t>
+            </a:r>
+            <a:r>
+              <a:rPr lang="en-IN" sz="2700" dirty="0" err="1">
+                <a:latin typeface="XB Niloofar" panose="02000503080000020003" pitchFamily="2" charset="-78"/>
+                <a:cs typeface="XB Niloofar" panose="02000503080000020003" pitchFamily="2" charset="-78"/>
+              </a:rPr>
+              <a:t>Data_Rd_En</a:t>
+            </a:r>
+            <a:r>
+              <a:rPr lang="en-IN" sz="2700" dirty="0">
+                <a:latin typeface="XB Niloofar" panose="02000503080000020003" pitchFamily="2" charset="-78"/>
+                <a:cs typeface="XB Niloofar" panose="02000503080000020003" pitchFamily="2" charset="-78"/>
+              </a:rPr>
+              <a:t> </a:t>
+            </a:r>
+            <a:r>
+              <a:rPr lang="en-IN" sz="2700" dirty="0" err="1">
+                <a:latin typeface="XB Niloofar" panose="02000503080000020003" pitchFamily="2" charset="-78"/>
+                <a:cs typeface="XB Niloofar" panose="02000503080000020003" pitchFamily="2" charset="-78"/>
+              </a:rPr>
+              <a:t>Data_Addr</a:t>
+            </a:r>
+            <a:r>
+              <a:rPr lang="en-IN" sz="2700" dirty="0">
+                <a:latin typeface="XB Niloofar" panose="02000503080000020003" pitchFamily="2" charset="-78"/>
+                <a:cs typeface="XB Niloofar" panose="02000503080000020003" pitchFamily="2" charset="-78"/>
+              </a:rPr>
+              <a:t>[*] </a:t>
+            </a:r>
+            <a:r>
+              <a:rPr lang="en-IN" sz="2700" dirty="0" err="1">
+                <a:latin typeface="XB Niloofar" panose="02000503080000020003" pitchFamily="2" charset="-78"/>
+                <a:cs typeface="XB Niloofar" panose="02000503080000020003" pitchFamily="2" charset="-78"/>
+              </a:rPr>
+              <a:t>Data_Wr_Data</a:t>
+            </a:r>
+            <a:r>
+              <a:rPr lang="en-IN" sz="2700" dirty="0">
+                <a:latin typeface="XB Niloofar" panose="02000503080000020003" pitchFamily="2" charset="-78"/>
+                <a:cs typeface="XB Niloofar" panose="02000503080000020003" pitchFamily="2" charset="-78"/>
+              </a:rPr>
+              <a:t>[*]}]</a:t>
+            </a:r>
+            <a:endParaRPr lang="en-DE" sz="2700" dirty="0">
+              <a:latin typeface="XB Niloofar" panose="02000503080000020003" pitchFamily="2" charset="-78"/>
+              <a:cs typeface="XB Niloofar" panose="02000503080000020003" pitchFamily="2" charset="-78"/>
+            </a:endParaRPr>
           </a:p>
         </p:txBody>
       </p:sp>
@@ -4180,7 +5636,7 @@
         <p:cNvPr id="1" name="">
           <a:extLst>
             <a:ext uri="{FF2B5EF4-FFF2-40B4-BE49-F238E27FC236}">
-              <a16:creationId xmlns:a16="http://schemas.microsoft.com/office/drawing/2014/main" id="{8A170F37-85A0-A8E4-183F-C34DE7F1FFC0}"/>
+              <a16:creationId xmlns:a16="http://schemas.microsoft.com/office/drawing/2014/main" id="{126BBC69-BBBA-15D0-6C1F-D7B21FDF5267}"/>
             </a:ext>
           </a:extLst>
         </p:cNvPr>
@@ -4200,7 +5656,7 @@
           <p:cNvPr id="2" name="Title 1">
             <a:extLst>
               <a:ext uri="{FF2B5EF4-FFF2-40B4-BE49-F238E27FC236}">
-                <a16:creationId xmlns:a16="http://schemas.microsoft.com/office/drawing/2014/main" id="{DFD0B336-057B-7514-F422-70F09A3C098A}"/>
+                <a16:creationId xmlns:a16="http://schemas.microsoft.com/office/drawing/2014/main" id="{ADB5968C-8AE8-8084-577F-D5F8B6BBF2ED}"/>
               </a:ext>
             </a:extLst>
           </p:cNvPr>
@@ -4221,7 +5677,7 @@
                 <a:latin typeface="XB Niloofar" panose="02000503080000020003" pitchFamily="2" charset="-78"/>
                 <a:cs typeface="XB Niloofar" panose="02000503080000020003" pitchFamily="2" charset="-78"/>
               </a:rPr>
-              <a:t>STA results</a:t>
+              <a:t>Synthesis results</a:t>
             </a:r>
             <a:endParaRPr lang="en-DE" b="1" dirty="0">
               <a:latin typeface="XB Niloofar" panose="02000503080000020003" pitchFamily="2" charset="-78"/>
@@ -4230,12 +5686,81 @@
           </a:p>
         </p:txBody>
       </p:sp>
-      <p:sp>
-        <p:nvSpPr>
-          <p:cNvPr id="3" name="Content Placeholder 2">
-            <a:extLst>
-              <a:ext uri="{FF2B5EF4-FFF2-40B4-BE49-F238E27FC236}">
-                <a16:creationId xmlns:a16="http://schemas.microsoft.com/office/drawing/2014/main" id="{9C96BC45-A276-90E8-C13A-36F1FB32767D}"/>
+      <p:pic>
+        <p:nvPicPr>
+          <p:cNvPr id="6" name="Content Placeholder 5">
+            <a:extLst>
+              <a:ext uri="{FF2B5EF4-FFF2-40B4-BE49-F238E27FC236}">
+                <a16:creationId xmlns:a16="http://schemas.microsoft.com/office/drawing/2014/main" id="{69939E8C-2B08-97FC-A871-695AD20E4D98}"/>
+              </a:ext>
+            </a:extLst>
+          </p:cNvPr>
+          <p:cNvPicPr>
+            <a:picLocks noGrp="1" noChangeAspect="1"/>
+          </p:cNvPicPr>
+          <p:nvPr>
+            <p:ph idx="1"/>
+          </p:nvPr>
+        </p:nvPicPr>
+        <p:blipFill>
+          <a:blip r:embed="rId2"/>
+          <a:srcRect t="24928"/>
+          <a:stretch>
+            <a:fillRect/>
+          </a:stretch>
+        </p:blipFill>
+        <p:spPr>
+          <a:xfrm>
+            <a:off x="1901582" y="1795692"/>
+            <a:ext cx="8388836" cy="3266615"/>
+          </a:xfrm>
+          <a:prstGeom prst="rect">
+            <a:avLst/>
+          </a:prstGeom>
+        </p:spPr>
+      </p:pic>
+    </p:spTree>
+    <p:extLst>
+      <p:ext uri="{BB962C8B-B14F-4D97-AF65-F5344CB8AC3E}">
+        <p14:creationId xmlns:p14="http://schemas.microsoft.com/office/powerpoint/2010/main" val="325740533"/>
+      </p:ext>
+    </p:extLst>
+  </p:cSld>
+  <p:clrMapOvr>
+    <a:masterClrMapping/>
+  </p:clrMapOvr>
+</p:sld>
+</file>
+
+<file path=ppt/slides/slide15.xml><?xml version="1.0" encoding="utf-8"?>
+<p:sld xmlns:a="http://schemas.openxmlformats.org/drawingml/2006/main" xmlns:r="http://schemas.openxmlformats.org/officeDocument/2006/relationships" xmlns:p="http://schemas.openxmlformats.org/presentationml/2006/main">
+  <p:cSld>
+    <p:spTree>
+      <p:nvGrpSpPr>
+        <p:cNvPr id="1" name="">
+          <a:extLst>
+            <a:ext uri="{FF2B5EF4-FFF2-40B4-BE49-F238E27FC236}">
+              <a16:creationId xmlns:a16="http://schemas.microsoft.com/office/drawing/2014/main" id="{A7C3C849-3DF4-CEAF-959D-4C838C2A39FE}"/>
+            </a:ext>
+          </a:extLst>
+        </p:cNvPr>
+        <p:cNvGrpSpPr/>
+        <p:nvPr/>
+      </p:nvGrpSpPr>
+      <p:grpSpPr>
+        <a:xfrm>
+          <a:off x="0" y="0"/>
+          <a:ext cx="0" cy="0"/>
+          <a:chOff x="0" y="0"/>
+          <a:chExt cx="0" cy="0"/>
+        </a:xfrm>
+      </p:grpSpPr>
+      <p:sp>
+        <p:nvSpPr>
+          <p:cNvPr id="2" name="Title 1">
+            <a:extLst>
+              <a:ext uri="{FF2B5EF4-FFF2-40B4-BE49-F238E27FC236}">
+                <a16:creationId xmlns:a16="http://schemas.microsoft.com/office/drawing/2014/main" id="{DB1CEEDF-751E-725B-0139-FDFE9B229640}"/>
               </a:ext>
             </a:extLst>
           </p:cNvPr>
@@ -4243,7 +5768,7 @@
             <a:spLocks noGrp="1"/>
           </p:cNvSpPr>
           <p:nvPr>
-            <p:ph idx="1"/>
+            <p:ph type="title"/>
           </p:nvPr>
         </p:nvSpPr>
         <p:spPr/>
@@ -4251,14 +5776,165 @@
           <a:bodyPr/>
           <a:lstStyle/>
           <a:p>
-            <a:endParaRPr lang="en-DE"/>
-          </a:p>
-        </p:txBody>
-      </p:sp>
+            <a:r>
+              <a:rPr lang="en-US" b="1" dirty="0">
+                <a:latin typeface="XB Niloofar" panose="02000503080000020003" pitchFamily="2" charset="-78"/>
+                <a:cs typeface="XB Niloofar" panose="02000503080000020003" pitchFamily="2" charset="-78"/>
+              </a:rPr>
+              <a:t>STA results</a:t>
+            </a:r>
+            <a:endParaRPr lang="en-DE" b="1" dirty="0">
+              <a:latin typeface="XB Niloofar" panose="02000503080000020003" pitchFamily="2" charset="-78"/>
+              <a:cs typeface="XB Niloofar" panose="02000503080000020003" pitchFamily="2" charset="-78"/>
+            </a:endParaRPr>
+          </a:p>
+        </p:txBody>
+      </p:sp>
+      <p:pic>
+        <p:nvPicPr>
+          <p:cNvPr id="7" name="Content Placeholder 6">
+            <a:extLst>
+              <a:ext uri="{FF2B5EF4-FFF2-40B4-BE49-F238E27FC236}">
+                <a16:creationId xmlns:a16="http://schemas.microsoft.com/office/drawing/2014/main" id="{B99D67E3-CD7B-C7E5-32FE-AB760C47CA44}"/>
+              </a:ext>
+            </a:extLst>
+          </p:cNvPr>
+          <p:cNvPicPr>
+            <a:picLocks noGrp="1" noChangeAspect="1"/>
+          </p:cNvPicPr>
+          <p:nvPr>
+            <p:ph idx="1"/>
+          </p:nvPr>
+        </p:nvPicPr>
+        <p:blipFill>
+          <a:blip r:embed="rId2">
+            <a:extLst>
+              <a:ext uri="{28A0092B-C50C-407E-A947-70E740481C1C}">
+                <a14:useLocalDpi xmlns:a14="http://schemas.microsoft.com/office/drawing/2010/main" val="0"/>
+              </a:ext>
+            </a:extLst>
+          </a:blip>
+          <a:stretch>
+            <a:fillRect/>
+          </a:stretch>
+        </p:blipFill>
+        <p:spPr>
+          <a:xfrm>
+            <a:off x="1741349" y="1995948"/>
+            <a:ext cx="8297385" cy="3821002"/>
+          </a:xfrm>
+          <a:prstGeom prst="rect">
+            <a:avLst/>
+          </a:prstGeom>
+        </p:spPr>
+      </p:pic>
     </p:spTree>
     <p:extLst>
       <p:ext uri="{BB962C8B-B14F-4D97-AF65-F5344CB8AC3E}">
-        <p14:creationId xmlns:p14="http://schemas.microsoft.com/office/powerpoint/2010/main" val="569207676"/>
+        <p14:creationId xmlns:p14="http://schemas.microsoft.com/office/powerpoint/2010/main" val="1834540024"/>
+      </p:ext>
+    </p:extLst>
+  </p:cSld>
+  <p:clrMapOvr>
+    <a:masterClrMapping/>
+  </p:clrMapOvr>
+</p:sld>
+</file>
+
+<file path=ppt/slides/slide16.xml><?xml version="1.0" encoding="utf-8"?>
+<p:sld xmlns:a="http://schemas.openxmlformats.org/drawingml/2006/main" xmlns:r="http://schemas.openxmlformats.org/officeDocument/2006/relationships" xmlns:p="http://schemas.openxmlformats.org/presentationml/2006/main">
+  <p:cSld>
+    <p:spTree>
+      <p:nvGrpSpPr>
+        <p:cNvPr id="1" name="">
+          <a:extLst>
+            <a:ext uri="{FF2B5EF4-FFF2-40B4-BE49-F238E27FC236}">
+              <a16:creationId xmlns:a16="http://schemas.microsoft.com/office/drawing/2014/main" id="{25491137-5028-8E2F-A9EA-3B0C957199EE}"/>
+            </a:ext>
+          </a:extLst>
+        </p:cNvPr>
+        <p:cNvGrpSpPr/>
+        <p:nvPr/>
+      </p:nvGrpSpPr>
+      <p:grpSpPr>
+        <a:xfrm>
+          <a:off x="0" y="0"/>
+          <a:ext cx="0" cy="0"/>
+          <a:chOff x="0" y="0"/>
+          <a:chExt cx="0" cy="0"/>
+        </a:xfrm>
+      </p:grpSpPr>
+      <p:sp>
+        <p:nvSpPr>
+          <p:cNvPr id="2" name="Title 1">
+            <a:extLst>
+              <a:ext uri="{FF2B5EF4-FFF2-40B4-BE49-F238E27FC236}">
+                <a16:creationId xmlns:a16="http://schemas.microsoft.com/office/drawing/2014/main" id="{BE42CE59-DBA4-2AFD-768C-A37DF096005D}"/>
+              </a:ext>
+            </a:extLst>
+          </p:cNvPr>
+          <p:cNvSpPr>
+            <a:spLocks noGrp="1"/>
+          </p:cNvSpPr>
+          <p:nvPr>
+            <p:ph type="title"/>
+          </p:nvPr>
+        </p:nvSpPr>
+        <p:spPr/>
+        <p:txBody>
+          <a:bodyPr/>
+          <a:lstStyle/>
+          <a:p>
+            <a:r>
+              <a:rPr lang="en-US" b="1" dirty="0">
+                <a:latin typeface="XB Niloofar" panose="02000503080000020003" pitchFamily="2" charset="-78"/>
+                <a:cs typeface="XB Niloofar" panose="02000503080000020003" pitchFamily="2" charset="-78"/>
+              </a:rPr>
+              <a:t>STA results</a:t>
+            </a:r>
+            <a:endParaRPr lang="en-DE" b="1" dirty="0">
+              <a:latin typeface="XB Niloofar" panose="02000503080000020003" pitchFamily="2" charset="-78"/>
+              <a:cs typeface="XB Niloofar" panose="02000503080000020003" pitchFamily="2" charset="-78"/>
+            </a:endParaRPr>
+          </a:p>
+        </p:txBody>
+      </p:sp>
+      <p:pic>
+        <p:nvPicPr>
+          <p:cNvPr id="5" name="Content Placeholder 4">
+            <a:extLst>
+              <a:ext uri="{FF2B5EF4-FFF2-40B4-BE49-F238E27FC236}">
+                <a16:creationId xmlns:a16="http://schemas.microsoft.com/office/drawing/2014/main" id="{3976B2A3-4556-8697-C608-D3BF52192140}"/>
+              </a:ext>
+            </a:extLst>
+          </p:cNvPr>
+          <p:cNvPicPr>
+            <a:picLocks noGrp="1" noChangeAspect="1"/>
+          </p:cNvPicPr>
+          <p:nvPr>
+            <p:ph idx="1"/>
+          </p:nvPr>
+        </p:nvPicPr>
+        <p:blipFill>
+          <a:blip r:embed="rId2"/>
+          <a:stretch>
+            <a:fillRect/>
+          </a:stretch>
+        </p:blipFill>
+        <p:spPr>
+          <a:xfrm>
+            <a:off x="2497394" y="2078751"/>
+            <a:ext cx="6341806" cy="3388088"/>
+          </a:xfrm>
+          <a:prstGeom prst="rect">
+            <a:avLst/>
+          </a:prstGeom>
+        </p:spPr>
+      </p:pic>
+    </p:spTree>
+    <p:extLst>
+      <p:ext uri="{BB962C8B-B14F-4D97-AF65-F5344CB8AC3E}">
+        <p14:creationId xmlns:p14="http://schemas.microsoft.com/office/powerpoint/2010/main" val="2859980823"/>
       </p:ext>
     </p:extLst>
   </p:cSld>

</xml_diff>